<commit_message>
State that the long RL runs are SFT then RL with no CPT (deck slides 4, 16, 28, 29; README)
Co-Authored-By: Claude Sonnet 5.5 <noreply@anthropic.com>
</commit_message>
<xml_diff>
--- a/docs/RL_V2_rl.pptx
+++ b/docs/RL_V2_rl.pptx
@@ -2353,7 +2353,7 @@
           <a:lstStyle/>
           <a:p>
             <a:r>
-              <a:t>Numbers: 16 skills on decision trees and ensembles, 79 chunks, 748 questions that passed a correlation filter (reject any candidate with cosine similarity of 0.80 or more to a kept question; Math 230, Code 179, Instruction 172, STEM 167). CORRECTED 2026-10-02: an earlier version said 240 kept; 240 is the size of each phase set. Partition (src/partition_r3_pools.py): 12 rubric examples, 16 eval, 240 CPT, 240 SFT, 240 RL, with no spare. The 16 eval questions are frozen and never trained on. From 2026-09-27 the RL runs held out a further 40 records (200 train, 40 held out, stratified by category, seed 7). The reward bands are 0 / 0.5 / 1 by judge score, gated by correctness (SETTLED.md). Framing: concepts MDP Formulation Checklist, Dynamic System vs Environment Wrapper, State vs Observation.</a:t>
+              <a:t>Numbers: 16 skills on decision trees and ensembles, 79 chunks, 748 questions that passed a correlation filter (reject any candidate with cosine similarity of 0.80 or more to a kept question; Math 230, Code 179, Instruction 172, STEM 167). CORRECTED 2026-10-02: an earlier version said 240 kept; 240 is the size of each phase set. Partition (src/partition_r3_pools.py): 12 rubric examples, 16 eval, 240 CPT, 240 SFT, 240 RL, with no spare. The 16 eval questions are frozen and never trained on. From 2026-09-27 the RL runs held out a further 40 records (200 train, 40 held out, stratified by category, seed 7). The reward bands are 0 / 0.5 / 1 by judge score, gated by correctness (SETTLED.md). Framing: concepts MDP Formulation Checklist, Dynamic System vs Environment Wrapper, State vs Observation. Pipeline as run: SFT then RL for all long runs (rl_kl03, rl_lr3e6, rl_replay2 start from the SFT checkpoint sft_book1e5/sft_full_epoch1; see docs/run-logs). CPT was tested separately and dropped (slide 24).</a:t>
             </a:r>
           </a:p>
         </p:txBody>
@@ -10307,7 +10307,7 @@
                 </a:solidFill>
                 <a:latin typeface="Calibri"/>
               </a:rPr>
-              <a:t>Same pool and judge. KL beta 0, 0.001, 0.3 and 0.02; learning rate 1e-5 and 3e-6. Watch raw KL, entropy and the answer text each step.</a:t>
+              <a:t>Same pool and judge, SFT checkpoint start (no CPT). KL beta 0, 0.001, 0.3 and 0.02; learning rate 1e-5 and 3e-6. Watch raw KL, entropy and the answer text each step.</a:t>
             </a:r>
           </a:p>
         </p:txBody>
@@ -19349,7 +19349,7 @@
                 </a:solidFill>
                 <a:latin typeface="Calibri"/>
               </a:rPr>
-              <a:t>Left to right: eval of 16 (eval wrapper, not the training prompt), records by outcome out of 240, KL from the SFT reference.</a:t>
+              <a:t>SFT then RL, no CPT. Left to right: eval of 16 (eval wrapper, not the training prompt), records by outcome out of 240, KL from the SFT reference.</a:t>
             </a:r>
           </a:p>
         </p:txBody>
@@ -19710,7 +19710,7 @@
                 </a:solidFill>
                 <a:latin typeface="Calibri"/>
               </a:rPr>
-              <a:t>Eval of 16 (training prompt; not comparable with the previous slide), records by outcome out of 240, KL from the SFT reference.</a:t>
+              <a:t>SFT then RL, no CPT. Eval of 16 (training prompt; not comparable with the previous slide), records by outcome out of 240, KL from the SFT reference.</a:t>
             </a:r>
           </a:p>
         </p:txBody>
@@ -22201,7 +22201,7 @@
                 </a:solidFill>
                 <a:latin typeface="Calibri"/>
               </a:rPr>
-              <a:t>Continued pre-training, then supervised fine-tuning (SFT), then RL: 4 sampled answers per question, compared within the group.</a:t>
+              <a:t>Designed as continued pre-training, then supervised fine-tuning (SFT), then RL. CPT showed no lift, so every long RL run below starts from the SFT checkpoint with no CPT, to remove it as a confounder. RL: 4 sampled answers per question, compared within the group.</a:t>
             </a:r>
           </a:p>
         </p:txBody>

</xml_diff>

<commit_message>
RL deck: drop the pyreft-era SFT lift-chart slide; renumber references (31 slides)
Co-Authored-By: Claude Sonnet 5.5 <noreply@anthropic.com>
</commit_message>
<xml_diff>
--- a/docs/RL_V2_rl.pptx
+++ b/docs/RL_V2_rl.pptx
@@ -15,7 +15,6 @@
     <p:sldId id="263" r:id="rId15"/>
     <p:sldId id="264" r:id="rId16"/>
     <p:sldId id="265" r:id="rId17"/>
-    <p:sldId id="266" r:id="rId18"/>
     <p:sldId id="267" r:id="rId19"/>
     <p:sldId id="268" r:id="rId20"/>
     <p:sldId id="269" r:id="rId21"/>
@@ -628,76 +627,6 @@
 </p:notes>
 </file>
 
-<file path=ppt/notesSlides/notesSlide11.xml><?xml version="1.0" encoding="utf-8"?>
-<p:notes xmlns:a="http://schemas.openxmlformats.org/drawingml/2006/main" xmlns:p="http://schemas.openxmlformats.org/presentationml/2006/main" xmlns:r="http://schemas.openxmlformats.org/officeDocument/2006/relationships">
-  <p:cSld>
-    <p:spTree>
-      <p:nvGrpSpPr>
-        <p:cNvPr id="1" name=""/>
-        <p:cNvGrpSpPr/>
-        <p:nvPr/>
-      </p:nvGrpSpPr>
-      <p:grpSpPr>
-        <a:xfrm>
-          <a:off x="0" y="0"/>
-          <a:ext cx="0" cy="0"/>
-          <a:chOff x="0" y="0"/>
-          <a:chExt cx="0" cy="0"/>
-        </a:xfrm>
-      </p:grpSpPr>
-      <p:sp>
-        <p:nvSpPr>
-          <p:cNvPr id="2" name="Slide Image Placeholder 1"/>
-          <p:cNvSpPr>
-            <a:spLocks noGrp="1"/>
-          </p:cNvSpPr>
-          <p:nvPr>
-            <p:ph type="sldImg" idx="2"/>
-          </p:nvPr>
-        </p:nvSpPr>
-        <p:spPr/>
-      </p:sp>
-      <p:sp>
-        <p:nvSpPr>
-          <p:cNvPr id="3" name="Notes Placeholder 2"/>
-          <p:cNvSpPr>
-            <a:spLocks noGrp="1"/>
-          </p:cNvSpPr>
-          <p:nvPr>
-            <p:ph type="body" idx="3" sz="quarter"/>
-          </p:nvPr>
-        </p:nvSpPr>
-        <p:spPr/>
-        <p:txBody>
-          <a:bodyPr/>
-          <a:lstStyle/>
-          <a:p>
-            <a:r>
-              <a:t>Instrument for this figure: judge qwen3.5-9b, 3-read majority, floor 0.70, eval n=16 (printed at the bottom of docs/lift_chart.png). Other instruments in the campaign read the same checkpoints differently (an earlier talk shows 16/59, 10/58, 21/59, 25/59 sampled-correct counts for base and epochs 1 to 3), which is why every comparison is made within one invocation. The epoch-1 dip is partly an artifact: that checkpoint returned an empty string on 11 of 16 questions, because one epoch of completion-only loss taught it to emit the stop token first. SFT is FFN-only with attention frozen (SETTLED.md). ReFT here is the RL-style fine-tune run from the SFT checkpoint.</a:t>
-            </a:r>
-          </a:p>
-        </p:txBody>
-      </p:sp>
-      <p:sp>
-        <p:nvSpPr>
-          <p:cNvPr id="4" name="Slide Number Placeholder 3"/>
-          <p:cNvSpPr>
-            <a:spLocks noGrp="1"/>
-          </p:cNvSpPr>
-          <p:nvPr>
-            <p:ph type="sldNum" idx="5" sz="quarter"/>
-          </p:nvPr>
-        </p:nvSpPr>
-        <p:spPr/>
-      </p:sp>
-    </p:spTree>
-  </p:cSld>
-  <p:clrMapOvr>
-    <a:masterClrMapping/>
-  </p:clrMapOvr>
-</p:notes>
-</file>
-
 <file path=ppt/notesSlides/notesSlide12.xml><?xml version="1.0" encoding="utf-8"?>
 <p:notes xmlns:a="http://schemas.openxmlformats.org/drawingml/2006/main" xmlns:p="http://schemas.openxmlformats.org/presentationml/2006/main" xmlns:r="http://schemas.openxmlformats.org/officeDocument/2006/relationships">
   <p:cSld>
@@ -2213,7 +2142,7 @@
           <a:lstStyle/>
           <a:p>
             <a:r>
-              <a:t>The fixed-scoring sequence is the same one the short talk opened with. Its numbers are quoted as measured at the time; the long runs used a different eval prompt (see slide 23 and the appendix slides), so the two are not on one instrument.</a:t>
+              <a:t>The fixed-scoring sequence is the same one the short talk opened with. Its numbers are quoted as measured at the time; the long runs used a different eval prompt (see slide 22 and the appendix slides), so the two are not on one instrument.</a:t>
             </a:r>
           </a:p>
         </p:txBody>
@@ -2283,7 +2212,7 @@
           <a:lstStyle/>
           <a:p>
             <a:r>
-              <a:t>Computation: two-proportion test, p = 0.5, alpha 0.05 two-sided (z 1.96), power 80% (z 0.84), detect 0.05: n per arm = (1.96+0.84)^2 * 2 * 0.25 / 0.05^2 = 1568. Standard error of a proportion at n = 16, p = 0.5: sqrt(0.25/16) = 0.125. This supports the eval-size half of the scale reading only; slide 26 lists the tests that would separate the readings.</a:t>
+              <a:t>Computation: two-proportion test, p = 0.5, alpha 0.05 two-sided (z 1.96), power 80% (z 0.84), detect 0.05: n per arm = (1.96+0.84)^2 * 2 * 0.25 / 0.05^2 = 1568. Standard error of a proportion at n = 16, p = 0.5: sqrt(0.25/16) = 0.125. This supports the eval-size half of the scale reading only; slide 25 lists the tests that would separate the readings.</a:t>
             </a:r>
           </a:p>
         </p:txBody>
@@ -2353,7 +2282,7 @@
           <a:lstStyle/>
           <a:p>
             <a:r>
-              <a:t>Numbers: 16 skills on decision trees and ensembles, 79 chunks, 748 questions that passed a correlation filter (reject any candidate with cosine similarity of 0.80 or more to a kept question; Math 230, Code 179, Instruction 172, STEM 167). CORRECTED 2026-10-02: an earlier version said 240 kept; 240 is the size of each phase set. Partition (src/partition_r3_pools.py): 12 rubric examples, 16 eval, 240 CPT, 240 SFT, 240 RL, with no spare. The 16 eval questions are frozen and never trained on. From 2026-09-27 the RL runs held out a further 40 records (200 train, 40 held out, stratified by category, seed 7). The reward bands are 0 / 0.5 / 1 by judge score, gated by correctness (SETTLED.md). Framing: concepts MDP Formulation Checklist, Dynamic System vs Environment Wrapper, State vs Observation. Pipeline as run: SFT then RL for all long runs (rl_kl03, rl_lr3e6, rl_replay2 start from the SFT checkpoint sft_book1e5/sft_full_epoch1; see docs/run-logs). CPT was tested separately and dropped (slide 24).</a:t>
+              <a:t>Numbers: 16 skills on decision trees and ensembles, 79 chunks, 748 questions that passed a correlation filter (reject any candidate with cosine similarity of 0.80 or more to a kept question; Math 230, Code 179, Instruction 172, STEM 167). CORRECTED 2026-10-02: an earlier version said 240 kept; 240 is the size of each phase set. Partition (src/partition_r3_pools.py): 12 rubric examples, 16 eval, 240 CPT, 240 SFT, 240 RL, with no spare. The 16 eval questions are frozen and never trained on. From 2026-09-27 the RL runs held out a further 40 records (200 train, 40 held out, stratified by category, seed 7). The reward bands are 0 / 0.5 / 1 by judge score, gated by correctness (SETTLED.md). Framing: concepts MDP Formulation Checklist, Dynamic System vs Environment Wrapper, State vs Observation. Pipeline as run: SFT then RL for all long runs (rl_kl03, rl_lr3e6, rl_replay2 start from the SFT checkpoint sft_book1e5/sft_full_epoch1; see docs/run-logs). CPT was tested separately and dropped (slide 23).</a:t>
             </a:r>
           </a:p>
         </p:txBody>
@@ -6285,615 +6214,6 @@
 </p:sld>
 </file>
 
-<file path=ppt/slides/slide11.xml><?xml version="1.0" encoding="utf-8"?>
-<p:sld xmlns:a="http://schemas.openxmlformats.org/drawingml/2006/main" xmlns:p="http://schemas.openxmlformats.org/presentationml/2006/main" xmlns:r="http://schemas.openxmlformats.org/officeDocument/2006/relationships">
-  <p:cSld>
-    <p:bg>
-      <p:bgPr>
-        <a:solidFill>
-          <a:srgbClr val="F3F5F6"/>
-        </a:solidFill>
-        <a:effectLst/>
-      </p:bgPr>
-    </p:bg>
-    <p:spTree>
-      <p:nvGrpSpPr>
-        <p:cNvPr id="1" name=""/>
-        <p:cNvGrpSpPr/>
-        <p:nvPr/>
-      </p:nvGrpSpPr>
-      <p:grpSpPr/>
-      <p:sp>
-        <p:nvSpPr>
-          <p:cNvPr id="2" name="TextBox 1"/>
-          <p:cNvSpPr txBox="1"/>
-          <p:nvPr/>
-        </p:nvSpPr>
-        <p:spPr>
-          <a:xfrm>
-            <a:off x="822960" y="658368"/>
-            <a:ext cx="10545775" cy="274320"/>
-          </a:xfrm>
-          <a:prstGeom prst="rect">
-            <a:avLst/>
-          </a:prstGeom>
-          <a:noFill/>
-        </p:spPr>
-        <p:txBody>
-          <a:bodyPr wrap="square" lIns="0" rIns="0" tIns="0" bIns="0" anchor="t">
-            <a:spAutoFit/>
-          </a:bodyPr>
-          <a:lstStyle/>
-          <a:p>
-            <a:r>
-              <a:rPr sz="1200" b="1">
-                <a:solidFill>
-                  <a:srgbClr val="1F5FA8"/>
-                </a:solidFill>
-                <a:latin typeface="Consolas"/>
-              </a:rPr>
-              <a:t>ENTRY 1 · SUPERVISED FINE-TUNING</a:t>
-            </a:r>
-          </a:p>
-        </p:txBody>
-      </p:sp>
-      <p:sp>
-        <p:nvSpPr>
-          <p:cNvPr id="3" name="TextBox 2"/>
-          <p:cNvSpPr txBox="1"/>
-          <p:nvPr/>
-        </p:nvSpPr>
-        <p:spPr>
-          <a:xfrm>
-            <a:off x="822960" y="932688"/>
-            <a:ext cx="10545775" cy="640080"/>
-          </a:xfrm>
-          <a:prstGeom prst="rect">
-            <a:avLst/>
-          </a:prstGeom>
-          <a:noFill/>
-        </p:spPr>
-        <p:txBody>
-          <a:bodyPr wrap="square" lIns="0" rIns="0" tIns="0" bIns="0" anchor="t">
-            <a:spAutoFit/>
-          </a:bodyPr>
-          <a:lstStyle/>
-          <a:p>
-            <a:r>
-              <a:rPr sz="2800" b="1">
-                <a:solidFill>
-                  <a:srgbClr val="16222B"/>
-                </a:solidFill>
-                <a:latin typeface="Georgia"/>
-              </a:rPr>
-              <a:t>SFT: depositing the knowledge</a:t>
-            </a:r>
-          </a:p>
-        </p:txBody>
-      </p:sp>
-      <p:sp>
-        <p:nvSpPr>
-          <p:cNvPr id="4" name="TextBox 3"/>
-          <p:cNvSpPr txBox="1"/>
-          <p:nvPr/>
-        </p:nvSpPr>
-        <p:spPr>
-          <a:xfrm>
-            <a:off x="822960" y="6382512"/>
-            <a:ext cx="10545775" cy="274320"/>
-          </a:xfrm>
-          <a:prstGeom prst="rect">
-            <a:avLst/>
-          </a:prstGeom>
-          <a:noFill/>
-        </p:spPr>
-        <p:txBody>
-          <a:bodyPr wrap="square" lIns="0" rIns="0" tIns="0" bIns="0" anchor="t">
-            <a:spAutoFit/>
-          </a:bodyPr>
-          <a:lstStyle/>
-          <a:p>
-            <a:r>
-              <a:rPr sz="1200" b="0">
-                <a:solidFill>
-                  <a:srgbClr val="5E6B75"/>
-                </a:solidFill>
-                <a:latin typeface="Calibri"/>
-              </a:rPr>
-              <a:t>Source: docs/lift_chart.png · judge qwen3.5-9b, 3-read majority, floor 0.70, n=16</a:t>
-            </a:r>
-          </a:p>
-        </p:txBody>
-      </p:sp>
-      <p:sp>
-        <p:nvSpPr>
-          <p:cNvPr id="5" name="Rounded Rectangle 4"/>
-          <p:cNvSpPr/>
-          <p:nvPr/>
-        </p:nvSpPr>
-        <p:spPr>
-          <a:xfrm>
-            <a:off x="822960" y="1691640"/>
-            <a:ext cx="4023360" cy="1641348"/>
-          </a:xfrm>
-          <a:prstGeom prst="roundRect">
-            <a:avLst>
-              <a:gd name="adj" fmla="val 4000"/>
-            </a:avLst>
-          </a:prstGeom>
-          <a:solidFill>
-            <a:srgbClr val="FBFCFC"/>
-          </a:solidFill>
-          <a:ln w="9525">
-            <a:solidFill>
-              <a:srgbClr val="D2D9DD"/>
-            </a:solidFill>
-          </a:ln>
-          <a:effectLst/>
-        </p:spPr>
-        <p:style>
-          <a:lnRef idx="1">
-            <a:schemeClr val="accent1"/>
-          </a:lnRef>
-          <a:fillRef idx="3">
-            <a:schemeClr val="accent1"/>
-          </a:fillRef>
-          <a:effectRef idx="2">
-            <a:schemeClr val="accent1"/>
-          </a:effectRef>
-          <a:fontRef idx="minor">
-            <a:schemeClr val="lt1"/>
-          </a:fontRef>
-        </p:style>
-        <p:txBody>
-          <a:bodyPr rtlCol="0" anchor="ctr"/>
-          <a:lstStyle/>
-          <a:p>
-            <a:pPr algn="ctr"/>
-          </a:p>
-        </p:txBody>
-      </p:sp>
-      <p:sp>
-        <p:nvSpPr>
-          <p:cNvPr id="6" name="TextBox 5"/>
-          <p:cNvSpPr txBox="1"/>
-          <p:nvPr/>
-        </p:nvSpPr>
-        <p:spPr>
-          <a:xfrm>
-            <a:off x="1005840" y="1837944"/>
-            <a:ext cx="3657600" cy="1367028"/>
-          </a:xfrm>
-          <a:prstGeom prst="rect">
-            <a:avLst/>
-          </a:prstGeom>
-          <a:noFill/>
-        </p:spPr>
-        <p:txBody>
-          <a:bodyPr wrap="square" lIns="0" rIns="0" tIns="0" bIns="0" anchor="t">
-            <a:spAutoFit/>
-          </a:bodyPr>
-          <a:lstStyle/>
-          <a:p>
-            <a:pPr>
-              <a:spcAft>
-                <a:spcPts val="400"/>
-              </a:spcAft>
-            </a:pPr>
-            <a:r>
-              <a:rPr sz="1200" b="1">
-                <a:solidFill>
-                  <a:srgbClr val="5E6B75"/>
-                </a:solidFill>
-                <a:latin typeface="Consolas"/>
-              </a:rPr>
-              <a:t>HYPOTHESIS</a:t>
-            </a:r>
-          </a:p>
-          <a:p>
-            <a:pPr>
-              <a:spcAft>
-                <a:spcPts val="600"/>
-              </a:spcAft>
-            </a:pPr>
-            <a:r>
-              <a:rPr sz="1600" b="0">
-                <a:solidFill>
-                  <a:srgbClr val="16222B"/>
-                </a:solidFill>
-                <a:latin typeface="Calibri"/>
-              </a:rPr>
-              <a:t>Full-parameter SFT on the 240-question pool raises accuracy on questions the model never trained on.</a:t>
-            </a:r>
-          </a:p>
-        </p:txBody>
-      </p:sp>
-      <p:sp>
-        <p:nvSpPr>
-          <p:cNvPr id="7" name="Rounded Rectangle 6"/>
-          <p:cNvSpPr/>
-          <p:nvPr/>
-        </p:nvSpPr>
-        <p:spPr>
-          <a:xfrm>
-            <a:off x="822960" y="3497580"/>
-            <a:ext cx="4023360" cy="1641348"/>
-          </a:xfrm>
-          <a:prstGeom prst="roundRect">
-            <a:avLst>
-              <a:gd name="adj" fmla="val 4000"/>
-            </a:avLst>
-          </a:prstGeom>
-          <a:solidFill>
-            <a:srgbClr val="FBFCFC"/>
-          </a:solidFill>
-          <a:ln w="9525">
-            <a:solidFill>
-              <a:srgbClr val="D2D9DD"/>
-            </a:solidFill>
-          </a:ln>
-          <a:effectLst/>
-        </p:spPr>
-        <p:style>
-          <a:lnRef idx="1">
-            <a:schemeClr val="accent1"/>
-          </a:lnRef>
-          <a:fillRef idx="3">
-            <a:schemeClr val="accent1"/>
-          </a:fillRef>
-          <a:effectRef idx="2">
-            <a:schemeClr val="accent1"/>
-          </a:effectRef>
-          <a:fontRef idx="minor">
-            <a:schemeClr val="lt1"/>
-          </a:fontRef>
-        </p:style>
-        <p:txBody>
-          <a:bodyPr rtlCol="0" anchor="ctr"/>
-          <a:lstStyle/>
-          <a:p>
-            <a:pPr algn="ctr"/>
-          </a:p>
-        </p:txBody>
-      </p:sp>
-      <p:sp>
-        <p:nvSpPr>
-          <p:cNvPr id="8" name="TextBox 7"/>
-          <p:cNvSpPr txBox="1"/>
-          <p:nvPr/>
-        </p:nvSpPr>
-        <p:spPr>
-          <a:xfrm>
-            <a:off x="1005840" y="3643884"/>
-            <a:ext cx="3657600" cy="1367028"/>
-          </a:xfrm>
-          <a:prstGeom prst="rect">
-            <a:avLst/>
-          </a:prstGeom>
-          <a:noFill/>
-        </p:spPr>
-        <p:txBody>
-          <a:bodyPr wrap="square" lIns="0" rIns="0" tIns="0" bIns="0" anchor="t">
-            <a:spAutoFit/>
-          </a:bodyPr>
-          <a:lstStyle/>
-          <a:p>
-            <a:pPr>
-              <a:spcAft>
-                <a:spcPts val="400"/>
-              </a:spcAft>
-            </a:pPr>
-            <a:r>
-              <a:rPr sz="1150" b="1">
-                <a:solidFill>
-                  <a:srgbClr val="5E6B75"/>
-                </a:solidFill>
-                <a:latin typeface="Consolas"/>
-              </a:rPr>
-              <a:t>SETTINGS AND METHOD</a:t>
-            </a:r>
-          </a:p>
-          <a:p>
-            <a:pPr>
-              <a:spcAft>
-                <a:spcPts val="600"/>
-              </a:spcAft>
-            </a:pPr>
-            <a:r>
-              <a:rPr sz="1500" b="0">
-                <a:solidFill>
-                  <a:srgbClr val="16222B"/>
-                </a:solidFill>
-                <a:latin typeface="Calibri"/>
-              </a:rPr>
-              <a:t>Qwen3.5-0.8B, full-parameter SFT with attention frozen, 3 epochs. The same 16 held-out questions after every epoch; 3 judge reads, majority vote.</a:t>
-            </a:r>
-          </a:p>
-        </p:txBody>
-      </p:sp>
-      <p:sp>
-        <p:nvSpPr>
-          <p:cNvPr id="9" name="Rounded Rectangle 8"/>
-          <p:cNvSpPr/>
-          <p:nvPr/>
-        </p:nvSpPr>
-        <p:spPr>
-          <a:xfrm>
-            <a:off x="5102352" y="1691640"/>
-            <a:ext cx="6266383" cy="3447288"/>
-          </a:xfrm>
-          <a:prstGeom prst="roundRect">
-            <a:avLst>
-              <a:gd name="adj" fmla="val 3000"/>
-            </a:avLst>
-          </a:prstGeom>
-          <a:solidFill>
-            <a:srgbClr val="FBFCFC"/>
-          </a:solidFill>
-          <a:ln w="9525">
-            <a:solidFill>
-              <a:srgbClr val="D2D9DD"/>
-            </a:solidFill>
-          </a:ln>
-          <a:effectLst/>
-        </p:spPr>
-        <p:style>
-          <a:lnRef idx="1">
-            <a:schemeClr val="accent1"/>
-          </a:lnRef>
-          <a:fillRef idx="3">
-            <a:schemeClr val="accent1"/>
-          </a:fillRef>
-          <a:effectRef idx="2">
-            <a:schemeClr val="accent1"/>
-          </a:effectRef>
-          <a:fontRef idx="minor">
-            <a:schemeClr val="lt1"/>
-          </a:fontRef>
-        </p:style>
-        <p:txBody>
-          <a:bodyPr rtlCol="0" anchor="ctr"/>
-          <a:lstStyle/>
-          <a:p>
-            <a:pPr algn="ctr"/>
-          </a:p>
-        </p:txBody>
-      </p:sp>
-      <p:sp>
-        <p:nvSpPr>
-          <p:cNvPr id="10" name="TextBox 9"/>
-          <p:cNvSpPr txBox="1"/>
-          <p:nvPr/>
-        </p:nvSpPr>
-        <p:spPr>
-          <a:xfrm>
-            <a:off x="5285232" y="1819656"/>
-            <a:ext cx="5900623" cy="274320"/>
-          </a:xfrm>
-          <a:prstGeom prst="rect">
-            <a:avLst/>
-          </a:prstGeom>
-          <a:noFill/>
-        </p:spPr>
-        <p:txBody>
-          <a:bodyPr wrap="square" lIns="0" rIns="0" tIns="0" bIns="0" anchor="t">
-            <a:spAutoFit/>
-          </a:bodyPr>
-          <a:lstStyle/>
-          <a:p>
-            <a:r>
-              <a:rPr sz="1200" b="1">
-                <a:solidFill>
-                  <a:srgbClr val="5E6B75"/>
-                </a:solidFill>
-                <a:latin typeface="Consolas"/>
-              </a:rPr>
-              <a:t>RESULT</a:t>
-            </a:r>
-          </a:p>
-        </p:txBody>
-      </p:sp>
-      <p:pic>
-        <p:nvPicPr>
-          <p:cNvPr id="11" name="Picture 10" descr="fig_lift.png"/>
-          <p:cNvPicPr>
-            <a:picLocks noChangeAspect="1"/>
-          </p:cNvPicPr>
-          <p:nvPr/>
-        </p:nvPicPr>
-        <p:blipFill>
-          <a:blip r:embed="rId3"/>
-          <a:stretch>
-            <a:fillRect/>
-          </a:stretch>
-        </p:blipFill>
-        <p:spPr>
-          <a:xfrm>
-            <a:off x="5285232" y="2148840"/>
-            <a:ext cx="5900623" cy="1974505"/>
-          </a:xfrm>
-          <a:prstGeom prst="rect">
-            <a:avLst/>
-          </a:prstGeom>
-        </p:spPr>
-      </p:pic>
-      <p:sp>
-        <p:nvSpPr>
-          <p:cNvPr id="12" name="TextBox 11"/>
-          <p:cNvSpPr txBox="1"/>
-          <p:nvPr/>
-        </p:nvSpPr>
-        <p:spPr>
-          <a:xfrm>
-            <a:off x="5285232" y="4553712"/>
-            <a:ext cx="5900623" cy="566928"/>
-          </a:xfrm>
-          <a:prstGeom prst="rect">
-            <a:avLst/>
-          </a:prstGeom>
-          <a:noFill/>
-        </p:spPr>
-        <p:txBody>
-          <a:bodyPr wrap="square" lIns="0" rIns="0" tIns="0" bIns="0" anchor="t">
-            <a:spAutoFit/>
-          </a:bodyPr>
-          <a:lstStyle/>
-          <a:p>
-            <a:r>
-              <a:rPr sz="1300" b="0">
-                <a:solidFill>
-                  <a:srgbClr val="5E6B75"/>
-                </a:solidFill>
-                <a:latin typeface="Calibri"/>
-              </a:rPr>
-              <a:t>Left of the dotted line: base and SFT epochs. Right: ReFT, an RL-style fine-tune run afterwards, never above 6.</a:t>
-            </a:r>
-          </a:p>
-        </p:txBody>
-      </p:sp>
-      <p:sp>
-        <p:nvSpPr>
-          <p:cNvPr id="13" name="Rounded Rectangle 12"/>
-          <p:cNvSpPr/>
-          <p:nvPr/>
-        </p:nvSpPr>
-        <p:spPr>
-          <a:xfrm>
-            <a:off x="822960" y="5321808"/>
-            <a:ext cx="10545775" cy="731520"/>
-          </a:xfrm>
-          <a:prstGeom prst="roundRect">
-            <a:avLst>
-              <a:gd name="adj" fmla="val 12000"/>
-            </a:avLst>
-          </a:prstGeom>
-          <a:solidFill>
-            <a:srgbClr val="E4E9EC"/>
-          </a:solidFill>
-          <a:ln>
-            <a:noFill/>
-          </a:ln>
-          <a:effectLst/>
-        </p:spPr>
-        <p:style>
-          <a:lnRef idx="1">
-            <a:schemeClr val="accent1"/>
-          </a:lnRef>
-          <a:fillRef idx="3">
-            <a:schemeClr val="accent1"/>
-          </a:fillRef>
-          <a:effectRef idx="2">
-            <a:schemeClr val="accent1"/>
-          </a:effectRef>
-          <a:fontRef idx="minor">
-            <a:schemeClr val="lt1"/>
-          </a:fontRef>
-        </p:style>
-        <p:txBody>
-          <a:bodyPr rtlCol="0" anchor="ctr"/>
-          <a:lstStyle/>
-          <a:p>
-            <a:pPr algn="ctr"/>
-          </a:p>
-        </p:txBody>
-      </p:sp>
-      <p:sp>
-        <p:nvSpPr>
-          <p:cNvPr id="14" name="Rounded Rectangle 13"/>
-          <p:cNvSpPr/>
-          <p:nvPr/>
-        </p:nvSpPr>
-        <p:spPr>
-          <a:xfrm>
-            <a:off x="1078992" y="5522976"/>
-            <a:ext cx="1403604" cy="329184"/>
-          </a:xfrm>
-          <a:prstGeom prst="roundRect">
-            <a:avLst>
-              <a:gd name="adj" fmla="val 50000"/>
-            </a:avLst>
-          </a:prstGeom>
-          <a:solidFill>
-            <a:srgbClr val="1F5FA8"/>
-          </a:solidFill>
-          <a:ln>
-            <a:noFill/>
-          </a:ln>
-          <a:effectLst/>
-        </p:spPr>
-        <p:style>
-          <a:lnRef idx="1">
-            <a:schemeClr val="accent1"/>
-          </a:lnRef>
-          <a:fillRef idx="3">
-            <a:schemeClr val="accent1"/>
-          </a:fillRef>
-          <a:effectRef idx="2">
-            <a:schemeClr val="accent1"/>
-          </a:effectRef>
-          <a:fontRef idx="minor">
-            <a:schemeClr val="lt1"/>
-          </a:fontRef>
-        </p:style>
-        <p:txBody>
-          <a:bodyPr rtlCol="0" anchor="ctr" lIns="0" rIns="0" tIns="0" bIns="0"/>
-          <a:lstStyle/>
-          <a:p>
-            <a:pPr algn="ctr"/>
-            <a:r>
-              <a:rPr sz="1100" b="1">
-                <a:solidFill>
-                  <a:srgbClr val="F7FAFB"/>
-                </a:solidFill>
-                <a:latin typeface="Consolas"/>
-              </a:rPr>
-              <a:t>SUPPORTED</a:t>
-            </a:r>
-          </a:p>
-        </p:txBody>
-      </p:sp>
-      <p:sp>
-        <p:nvSpPr>
-          <p:cNvPr id="15" name="TextBox 14"/>
-          <p:cNvSpPr txBox="1"/>
-          <p:nvPr/>
-        </p:nvSpPr>
-        <p:spPr>
-          <a:xfrm>
-            <a:off x="2738628" y="5413248"/>
-            <a:ext cx="8374075" cy="548640"/>
-          </a:xfrm>
-          <a:prstGeom prst="rect">
-            <a:avLst/>
-          </a:prstGeom>
-          <a:noFill/>
-        </p:spPr>
-        <p:txBody>
-          <a:bodyPr wrap="square" lIns="0" rIns="0" tIns="0" bIns="0" anchor="ctr">
-            <a:spAutoFit/>
-          </a:bodyPr>
-          <a:lstStyle/>
-          <a:p>
-            <a:r>
-              <a:rPr sz="1600" b="0">
-                <a:solidFill>
-                  <a:srgbClr val="16222B"/>
-                </a:solidFill>
-                <a:latin typeface="Calibri"/>
-              </a:rPr>
-              <a:t>SFT took the model from 3 to 7 of 16 at epoch 2; epoch 3 fell back to 4. A swing that size is near the noise floor, so read the shape, not the epoch.</a:t>
-            </a:r>
-          </a:p>
-        </p:txBody>
-      </p:sp>
-    </p:spTree>
-  </p:cSld>
-  <p:clrMapOvr>
-    <a:masterClrMapping/>
-  </p:clrMapOvr>
-</p:sld>
-</file>
-
 <file path=ppt/slides/slide12.xml><?xml version="1.0" encoding="utf-8"?>
 <p:sld xmlns:a="http://schemas.openxmlformats.org/drawingml/2006/main" xmlns:p="http://schemas.openxmlformats.org/presentationml/2006/main" xmlns:r="http://schemas.openxmlformats.org/officeDocument/2006/relationships">
   <p:cSld>
@@ -10101,7 +9421,7 @@
                 </a:solidFill>
                 <a:latin typeface="Calibri"/>
               </a:rPr>
-              <a:t>Source: dispositions.md: rl_nowm, rl_k, rl_kl03, rl_lr3e6 (09-23 to 09-25); crossing-run correction 3  ·  figure: slide 28</a:t>
+              <a:t>Source: dispositions.md: rl_nowm, rl_k, rl_kl03, rl_lr3e6 (09-23 to 09-25); crossing-run correction 3  ·  figure: slide 27</a:t>
             </a:r>
           </a:p>
         </p:txBody>
@@ -11757,7 +11077,7 @@
                 </a:solidFill>
                 <a:latin typeface="Calibri"/>
               </a:rPr>
-              <a:t>Source: dispositions.md: "REPLAY SAMPLER" (09-24), "rl_replay2" (09-25 to 09-26)  ·  figure: slide 29</a:t>
+              <a:t>Source: dispositions.md: "REPLAY SAMPLER" (09-24), "rl_replay2" (09-25 to 09-26)  ·  figure: slide 28</a:t>
             </a:r>
           </a:p>
         </p:txBody>
@@ -20832,7 +20152,7 @@
                 </a:solidFill>
                 <a:latin typeface="Calibri"/>
               </a:rPr>
-              <a:t>Later passes degraded, and the long runs on slides 28 and 29 never beat 9 and never held a gain.</a:t>
+              <a:t>Later passes degraded, and the long runs on slides 27 and 28 never beat 9 and never held a gain.</a:t>
             </a:r>
           </a:p>
           <a:p>
@@ -20848,7 +20168,7 @@
                 </a:solidFill>
                 <a:latin typeface="Calibri"/>
               </a:rPr>
-              <a:t>The 9 comes from the early instrument. It was not re-read under the training prompt (slide 23), so it is not comparable with the long-run numbers.</a:t>
+              <a:t>The 9 comes from the early instrument. It was not re-read under the training prompt (slide 22), so it is not comparable with the long-run numbers.</a:t>
             </a:r>
           </a:p>
         </p:txBody>

</xml_diff>

<commit_message>
RL deck: add the LLM-judge-before-Jev slide, plain message on the eval-noise slide; renumber references (32 slides)
Co-Authored-By: Claude Sonnet 5.5 <noreply@anthropic.com>
</commit_message>
<xml_diff>
--- a/docs/RL_V2_rl.pptx
+++ b/docs/RL_V2_rl.pptx
@@ -11,6 +11,7 @@
     <p:sldId id="259" r:id="rId11"/>
     <p:sldId id="260" r:id="rId12"/>
     <p:sldId id="261" r:id="rId13"/>
+    <p:sldId id="292" r:id="rId38"/>
     <p:sldId id="262" r:id="rId14"/>
     <p:sldId id="263" r:id="rId15"/>
     <p:sldId id="264" r:id="rId16"/>
@@ -1887,6 +1888,76 @@
 </p:notes>
 </file>
 
+<file path=ppt/notesSlides/notesSlide31.xml><?xml version="1.0" encoding="utf-8"?>
+<p:notes xmlns:a="http://schemas.openxmlformats.org/drawingml/2006/main" xmlns:p="http://schemas.openxmlformats.org/presentationml/2006/main" xmlns:r="http://schemas.openxmlformats.org/officeDocument/2006/relationships">
+  <p:cSld>
+    <p:spTree>
+      <p:nvGrpSpPr>
+        <p:cNvPr id="1" name=""/>
+        <p:cNvGrpSpPr/>
+        <p:nvPr/>
+      </p:nvGrpSpPr>
+      <p:grpSpPr>
+        <a:xfrm>
+          <a:off x="0" y="0"/>
+          <a:ext cx="0" cy="0"/>
+          <a:chOff x="0" y="0"/>
+          <a:chExt cx="0" cy="0"/>
+        </a:xfrm>
+      </p:grpSpPr>
+      <p:sp>
+        <p:nvSpPr>
+          <p:cNvPr id="2" name="Slide Image Placeholder 1"/>
+          <p:cNvSpPr>
+            <a:spLocks noGrp="1"/>
+          </p:cNvSpPr>
+          <p:nvPr>
+            <p:ph type="sldImg" idx="2"/>
+          </p:nvPr>
+        </p:nvSpPr>
+        <p:spPr/>
+      </p:sp>
+      <p:sp>
+        <p:nvSpPr>
+          <p:cNvPr id="3" name="Notes Placeholder 2"/>
+          <p:cNvSpPr>
+            <a:spLocks noGrp="1"/>
+          </p:cNvSpPr>
+          <p:nvPr>
+            <p:ph type="body" idx="3" sz="quarter"/>
+          </p:nvPr>
+        </p:nvSpPr>
+        <p:spPr/>
+        <p:txBody>
+          <a:bodyPr/>
+          <a:lstStyle/>
+          <a:p>
+            <a:r>
+              <a:t>Judge details from judge.py's docstring and dispositions.md. Reasoning-first schema: constrained decoding emits fields in order, so the judge writes the claims before it may emit a score; on item r3-0057 that turned 'correct 0.700' into 'incorrect 0.450'. The earlier two-call design returned verdict correct with quality 0.0 on the same item. Judges are compressed and lenient, so the rubric demonstrates the range with worked examples (data/synthetic_domain_rubric.md). Which judge: eval cells used the 4B judge with a 3-read majority; the RL runs up to 2026-09-26 used the 9B (qwen3.5-9b). Replacement: Open-Jev-2B yes/no, measured on 150 stored answers against the 9B labels (slide 8).</a:t>
+            </a:r>
+          </a:p>
+        </p:txBody>
+      </p:sp>
+      <p:sp>
+        <p:nvSpPr>
+          <p:cNvPr id="4" name="Slide Number Placeholder 3"/>
+          <p:cNvSpPr>
+            <a:spLocks noGrp="1"/>
+          </p:cNvSpPr>
+          <p:nvPr>
+            <p:ph type="sldNum" idx="5" sz="quarter"/>
+          </p:nvPr>
+        </p:nvSpPr>
+        <p:spPr/>
+      </p:sp>
+    </p:spTree>
+  </p:cSld>
+  <p:clrMapOvr>
+    <a:masterClrMapping/>
+  </p:clrMapOvr>
+</p:notes>
+</file>
+
 <file path=ppt/notesSlides/notesSlide32.xml><?xml version="1.0" encoding="utf-8"?>
 <p:notes xmlns:a="http://schemas.openxmlformats.org/drawingml/2006/main" xmlns:p="http://schemas.openxmlformats.org/presentationml/2006/main" xmlns:r="http://schemas.openxmlformats.org/officeDocument/2006/relationships">
   <p:cSld>
@@ -2142,7 +2213,7 @@
           <a:lstStyle/>
           <a:p>
             <a:r>
-              <a:t>The fixed-scoring sequence is the same one the short talk opened with. Its numbers are quoted as measured at the time; the long runs used a different eval prompt (see slide 22 and the appendix slides), so the two are not on one instrument.</a:t>
+              <a:t>The fixed-scoring sequence is the same one the short talk opened with. Its numbers are quoted as measured at the time; the long runs used a different eval prompt (see slide 23 and the appendix slides), so the two are not on one instrument.</a:t>
             </a:r>
           </a:p>
         </p:txBody>
@@ -2212,7 +2283,7 @@
           <a:lstStyle/>
           <a:p>
             <a:r>
-              <a:t>Computation: two-proportion test, p = 0.5, alpha 0.05 two-sided (z 1.96), power 80% (z 0.84), detect 0.05: n per arm = (1.96+0.84)^2 * 2 * 0.25 / 0.05^2 = 1568. Standard error of a proportion at n = 16, p = 0.5: sqrt(0.25/16) = 0.125. This supports the eval-size half of the scale reading only; slide 25 lists the tests that would separate the readings.</a:t>
+              <a:t>Computation: two-proportion test, p = 0.5, alpha 0.05 two-sided (z 1.96), power 80% (z 0.84), detect 0.05: n per arm = (1.96+0.84)^2 * 2 * 0.25 / 0.05^2 = 1568. Standard error of a proportion at n = 16, p = 0.5: sqrt(0.25/16) = 0.125. This supports the eval-size half of the scale reading only; slide 26 lists the tests that would separate the readings.</a:t>
             </a:r>
           </a:p>
         </p:txBody>
@@ -2282,7 +2353,7 @@
           <a:lstStyle/>
           <a:p>
             <a:r>
-              <a:t>Numbers: 16 skills on decision trees and ensembles, 79 chunks, 748 questions that passed a correlation filter (reject any candidate with cosine similarity of 0.80 or more to a kept question; Math 230, Code 179, Instruction 172, STEM 167). CORRECTED 2026-10-02: an earlier version said 240 kept; 240 is the size of each phase set. Partition (src/partition_r3_pools.py): 12 rubric examples, 16 eval, 240 CPT, 240 SFT, 240 RL, with no spare. The 16 eval questions are frozen and never trained on. From 2026-09-27 the RL runs held out a further 40 records (200 train, 40 held out, stratified by category, seed 7). The reward bands are 0 / 0.5 / 1 by judge score, gated by correctness (SETTLED.md). Framing: concepts MDP Formulation Checklist, Dynamic System vs Environment Wrapper, State vs Observation. Pipeline as run: SFT then RL for all long runs (rl_kl03, rl_lr3e6, rl_replay2 start from the SFT checkpoint sft_book1e5/sft_full_epoch1; see docs/run-logs). CPT was tested separately and dropped (slide 23).</a:t>
+              <a:t>Numbers: 16 skills on decision trees and ensembles, 79 chunks, 748 questions that passed a correlation filter (reject any candidate with cosine similarity of 0.80 or more to a kept question; Math 230, Code 179, Instruction 172, STEM 167). CORRECTED 2026-10-02: an earlier version said 240 kept; 240 is the size of each phase set. Partition (src/partition_r3_pools.py): 12 rubric examples, 16 eval, 240 CPT, 240 SFT, 240 RL, with no spare. The 16 eval questions are frozen and never trained on. From 2026-09-27 the RL runs held out a further 40 records (200 train, 40 held out, stratified by category, seed 7). The reward bands are 0 / 0.5 / 1 by judge score, gated by correctness (SETTLED.md). Framing: concepts MDP Formulation Checklist, Dynamic System vs Environment Wrapper, State vs Observation. Pipeline as run: SFT then RL for all long runs (rl_kl03, rl_lr3e6, rl_replay2 start from the SFT checkpoint sft_book1e5/sft_full_epoch1; see docs/run-logs). CPT was tested separately and dropped (slide 24).</a:t>
             </a:r>
           </a:p>
         </p:txBody>
@@ -5837,7 +5908,7 @@
                 </a:solidFill>
                 <a:latin typeface="Consolas"/>
               </a:rPr>
-              <a:t>INSTRUMENT</a:t>
+              <a:t>GROUNDING</a:t>
             </a:r>
           </a:p>
         </p:txBody>
@@ -5871,7 +5942,774 @@
                 </a:solidFill>
                 <a:latin typeface="Georgia"/>
               </a:rPr>
-              <a:t>What a 16-question eval can resolve</a:t>
+              <a:t>RL-theory concepts and where each landed</a:t>
+            </a:r>
+          </a:p>
+        </p:txBody>
+      </p:sp>
+      <p:sp>
+        <p:nvSpPr>
+          <p:cNvPr id="4" name="TextBox 3"/>
+          <p:cNvSpPr txBox="1"/>
+          <p:nvPr/>
+        </p:nvSpPr>
+        <p:spPr>
+          <a:xfrm>
+            <a:off x="822960" y="6382512"/>
+            <a:ext cx="10545775" cy="274320"/>
+          </a:xfrm>
+          <a:prstGeom prst="rect">
+            <a:avLst/>
+          </a:prstGeom>
+          <a:noFill/>
+        </p:spPr>
+        <p:txBody>
+          <a:bodyPr wrap="square" lIns="0" rIns="0" tIns="0" bIns="0" anchor="t">
+            <a:spAutoFit/>
+          </a:bodyPr>
+          <a:lstStyle/>
+          <a:p>
+            <a:r>
+              <a:rPr sz="1200" b="0">
+                <a:solidFill>
+                  <a:srgbClr val="5E6B75"/>
+                </a:solidFill>
+                <a:latin typeface="Calibri"/>
+              </a:rPr>
+              <a:t>Source: docs/INSPIRATIONS.md · dispositions.md · each mapping is an analogy until its entry tests it</a:t>
+            </a:r>
+          </a:p>
+        </p:txBody>
+      </p:sp>
+      <p:graphicFrame>
+        <p:nvGraphicFramePr>
+          <p:cNvPr id="5" name="Table 4"/>
+          <p:cNvGraphicFramePr>
+            <a:graphicFrameLocks noGrp="1"/>
+          </p:cNvGraphicFramePr>
+          <p:nvPr/>
+        </p:nvGraphicFramePr>
+        <p:xfrm>
+          <a:off x="822960" y="1691640"/>
+          <a:ext cx="10545774" cy="3236976"/>
+        </p:xfrm>
+        <a:graphic>
+          <a:graphicData uri="http://schemas.openxmlformats.org/drawingml/2006/table">
+            <a:tbl>
+              <a:tblPr firstRow="1" bandRow="1">
+                <a:tableStyleId>{5C22544A-7EE6-4342-B048-85BDC9FD1C3A}</a:tableStyleId>
+              </a:tblPr>
+              <a:tblGrid>
+                <a:gridCol w="4007394"/>
+                <a:gridCol w="3796479"/>
+                <a:gridCol w="2741901"/>
+              </a:tblGrid>
+              <a:tr h="359664">
+                <a:tc>
+                  <a:txBody>
+                    <a:bodyPr wrap="square"/>
+                    <a:lstStyle/>
+                    <a:p>
+                      <a:r>
+                        <a:rPr sz="1400" b="1">
+                          <a:solidFill>
+                            <a:srgbClr val="16222B"/>
+                          </a:solidFill>
+                          <a:latin typeface="Calibri"/>
+                        </a:rPr>
+                        <a:t>RL-theory concept</a:t>
+                      </a:r>
+                    </a:p>
+                  </a:txBody>
+                  <a:tcPr marL="91440" marR="91440" marT="45720" marB="45720" anchor="ctr">
+                    <a:solidFill>
+                      <a:srgbClr val="D2D9DD"/>
+                    </a:solidFill>
+                  </a:tcPr>
+                </a:tc>
+                <a:tc>
+                  <a:txBody>
+                    <a:bodyPr wrap="square"/>
+                    <a:lstStyle/>
+                    <a:p>
+                      <a:r>
+                        <a:rPr sz="1400" b="1">
+                          <a:solidFill>
+                            <a:srgbClr val="16222B"/>
+                          </a:solidFill>
+                          <a:latin typeface="Calibri"/>
+                        </a:rPr>
+                        <a:t>What I built</a:t>
+                      </a:r>
+                    </a:p>
+                  </a:txBody>
+                  <a:tcPr marL="91440" marR="91440" marT="45720" marB="45720" anchor="ctr">
+                    <a:solidFill>
+                      <a:srgbClr val="D2D9DD"/>
+                    </a:solidFill>
+                  </a:tcPr>
+                </a:tc>
+                <a:tc>
+                  <a:txBody>
+                    <a:bodyPr wrap="square"/>
+                    <a:lstStyle/>
+                    <a:p>
+                      <a:r>
+                        <a:rPr sz="1400" b="1">
+                          <a:solidFill>
+                            <a:srgbClr val="16222B"/>
+                          </a:solidFill>
+                          <a:latin typeface="Calibri"/>
+                        </a:rPr>
+                        <a:t>Where it landed</a:t>
+                      </a:r>
+                    </a:p>
+                  </a:txBody>
+                  <a:tcPr marL="91440" marR="91440" marT="45720" marB="45720" anchor="ctr">
+                    <a:solidFill>
+                      <a:srgbClr val="D2D9DD"/>
+                    </a:solidFill>
+                  </a:tcPr>
+                </a:tc>
+              </a:tr>
+              <a:tr h="359664">
+                <a:tc>
+                  <a:txBody>
+                    <a:bodyPr wrap="square"/>
+                    <a:lstStyle/>
+                    <a:p>
+                      <a:r>
+                        <a:rPr sz="1400" b="0">
+                          <a:solidFill>
+                            <a:srgbClr val="16222B"/>
+                          </a:solidFill>
+                          <a:latin typeface="Calibri"/>
+                        </a:rPr>
+                        <a:t>Policy gradient without a critic</a:t>
+                      </a:r>
+                    </a:p>
+                  </a:txBody>
+                  <a:tcPr marL="91440" marR="91440" marT="45720" marB="45720" anchor="ctr">
+                    <a:solidFill>
+                      <a:srgbClr val="FBFCFC"/>
+                    </a:solidFill>
+                  </a:tcPr>
+                </a:tc>
+                <a:tc>
+                  <a:txBody>
+                    <a:bodyPr wrap="square"/>
+                    <a:lstStyle/>
+                    <a:p>
+                      <a:r>
+                        <a:rPr sz="1400" b="0">
+                          <a:solidFill>
+                            <a:srgbClr val="16222B"/>
+                          </a:solidFill>
+                          <a:latin typeface="Calibri"/>
+                        </a:rPr>
+                        <a:t>GRPO: group of 4, minus the mean</a:t>
+                      </a:r>
+                    </a:p>
+                  </a:txBody>
+                  <a:tcPr marL="91440" marR="91440" marT="45720" marB="45720" anchor="ctr">
+                    <a:solidFill>
+                      <a:srgbClr val="FBFCFC"/>
+                    </a:solidFill>
+                  </a:tcPr>
+                </a:tc>
+                <a:tc>
+                  <a:txBody>
+                    <a:bodyPr wrap="square"/>
+                    <a:lstStyle/>
+                    <a:p>
+                      <a:r>
+                        <a:rPr sz="1400" b="0">
+                          <a:solidFill>
+                            <a:srgbClr val="1F5FA8"/>
+                          </a:solidFill>
+                          <a:latin typeface="Calibri"/>
+                        </a:rPr>
+                        <a:t>core of every run</a:t>
+                      </a:r>
+                    </a:p>
+                  </a:txBody>
+                  <a:tcPr marL="91440" marR="91440" marT="45720" marB="45720" anchor="ctr">
+                    <a:solidFill>
+                      <a:srgbClr val="FBFCFC"/>
+                    </a:solidFill>
+                  </a:tcPr>
+                </a:tc>
+              </a:tr>
+              <a:tr h="359664">
+                <a:tc>
+                  <a:txBody>
+                    <a:bodyPr wrap="square"/>
+                    <a:lstStyle/>
+                    <a:p>
+                      <a:r>
+                        <a:rPr sz="1400" b="0">
+                          <a:solidFill>
+                            <a:srgbClr val="16222B"/>
+                          </a:solidFill>
+                          <a:latin typeface="Calibri"/>
+                        </a:rPr>
+                        <a:t>Boltzmann exploration, optimistic start</a:t>
+                      </a:r>
+                    </a:p>
+                  </a:txBody>
+                  <a:tcPr marL="91440" marR="91440" marT="45720" marB="45720" anchor="ctr">
+                    <a:solidFill>
+                      <a:srgbClr val="FBFCFC"/>
+                    </a:solidFill>
+                  </a:tcPr>
+                </a:tc>
+                <a:tc>
+                  <a:txBody>
+                    <a:bodyPr wrap="square"/>
+                    <a:lstStyle/>
+                    <a:p>
+                      <a:r>
+                        <a:rPr sz="1400" b="0">
+                          <a:solidFill>
+                            <a:srgbClr val="16222B"/>
+                          </a:solidFill>
+                          <a:latin typeface="Calibri"/>
+                        </a:rPr>
+                        <a:t>Draw by uncertainty; unseen first</a:t>
+                      </a:r>
+                    </a:p>
+                  </a:txBody>
+                  <a:tcPr marL="91440" marR="91440" marT="45720" marB="45720" anchor="ctr">
+                    <a:solidFill>
+                      <a:srgbClr val="FBFCFC"/>
+                    </a:solidFill>
+                  </a:tcPr>
+                </a:tc>
+                <a:tc>
+                  <a:txBody>
+                    <a:bodyPr wrap="square"/>
+                    <a:lstStyle/>
+                    <a:p>
+                      <a:r>
+                        <a:rPr sz="1400" b="0">
+                          <a:solidFill>
+                            <a:srgbClr val="1F5FA8"/>
+                          </a:solidFill>
+                          <a:latin typeface="Calibri"/>
+                        </a:rPr>
+                        <a:t>kept (entry 8)</a:t>
+                      </a:r>
+                    </a:p>
+                  </a:txBody>
+                  <a:tcPr marL="91440" marR="91440" marT="45720" marB="45720" anchor="ctr">
+                    <a:solidFill>
+                      <a:srgbClr val="FBFCFC"/>
+                    </a:solidFill>
+                  </a:tcPr>
+                </a:tc>
+              </a:tr>
+              <a:tr h="359664">
+                <a:tc>
+                  <a:txBody>
+                    <a:bodyPr wrap="square"/>
+                    <a:lstStyle/>
+                    <a:p>
+                      <a:r>
+                        <a:rPr sz="1400" b="0">
+                          <a:solidFill>
+                            <a:srgbClr val="16222B"/>
+                          </a:solidFill>
+                          <a:latin typeface="Calibri"/>
+                        </a:rPr>
+                        <a:t>Replay buffer: decorrelate and reuse</a:t>
+                      </a:r>
+                    </a:p>
+                  </a:txBody>
+                  <a:tcPr marL="91440" marR="91440" marT="45720" marB="45720" anchor="ctr">
+                    <a:solidFill>
+                      <a:srgbClr val="FBFCFC"/>
+                    </a:solidFill>
+                  </a:tcPr>
+                </a:tc>
+                <a:tc>
+                  <a:txBody>
+                    <a:bodyPr wrap="square"/>
+                    <a:lstStyle/>
+                    <a:p>
+                      <a:r>
+                        <a:rPr sz="1400" b="0">
+                          <a:solidFill>
+                            <a:srgbClr val="16222B"/>
+                          </a:solidFill>
+                          <a:latin typeface="Calibri"/>
+                        </a:rPr>
+                        <a:t>Flashcard priority; reuse of answers</a:t>
+                      </a:r>
+                    </a:p>
+                  </a:txBody>
+                  <a:tcPr marL="91440" marR="91440" marT="45720" marB="45720" anchor="ctr">
+                    <a:solidFill>
+                      <a:srgbClr val="FBFCFC"/>
+                    </a:solidFill>
+                  </a:tcPr>
+                </a:tc>
+                <a:tc>
+                  <a:txBody>
+                    <a:bodyPr wrap="square"/>
+                    <a:lstStyle/>
+                    <a:p>
+                      <a:r>
+                        <a:rPr sz="1400" b="0">
+                          <a:solidFill>
+                            <a:srgbClr val="B94E08"/>
+                          </a:solidFill>
+                          <a:latin typeface="Calibri"/>
+                        </a:rPr>
+                        <a:t>lost (entry 9)</a:t>
+                      </a:r>
+                    </a:p>
+                  </a:txBody>
+                  <a:tcPr marL="91440" marR="91440" marT="45720" marB="45720" anchor="ctr">
+                    <a:solidFill>
+                      <a:srgbClr val="FBFCFC"/>
+                    </a:solidFill>
+                  </a:tcPr>
+                </a:tc>
+              </a:tr>
+              <a:tr h="359664">
+                <a:tc>
+                  <a:txBody>
+                    <a:bodyPr wrap="square"/>
+                    <a:lstStyle/>
+                    <a:p>
+                      <a:r>
+                        <a:rPr sz="1400" b="0">
+                          <a:solidFill>
+                            <a:srgbClr val="16222B"/>
+                          </a:solidFill>
+                          <a:latin typeface="Calibri"/>
+                        </a:rPr>
+                        <a:t>Target network: a slow, stable target</a:t>
+                      </a:r>
+                    </a:p>
+                  </a:txBody>
+                  <a:tcPr marL="91440" marR="91440" marT="45720" marB="45720" anchor="ctr">
+                    <a:solidFill>
+                      <a:srgbClr val="FBFCFC"/>
+                    </a:solidFill>
+                  </a:tcPr>
+                </a:tc>
+                <a:tc>
+                  <a:txBody>
+                    <a:bodyPr wrap="square"/>
+                    <a:lstStyle/>
+                    <a:p>
+                      <a:r>
+                        <a:rPr sz="1400" b="0">
+                          <a:solidFill>
+                            <a:srgbClr val="16222B"/>
+                          </a:solidFill>
+                          <a:latin typeface="Calibri"/>
+                        </a:rPr>
+                        <a:t>KL anchor to the SFT checkpoint</a:t>
+                      </a:r>
+                    </a:p>
+                  </a:txBody>
+                  <a:tcPr marL="91440" marR="91440" marT="45720" marB="45720" anchor="ctr">
+                    <a:solidFill>
+                      <a:srgbClr val="FBFCFC"/>
+                    </a:solidFill>
+                  </a:tcPr>
+                </a:tc>
+                <a:tc>
+                  <a:txBody>
+                    <a:bodyPr wrap="square"/>
+                    <a:lstStyle/>
+                    <a:p>
+                      <a:r>
+                        <a:rPr sz="1400" b="0">
+                          <a:solidFill>
+                            <a:srgbClr val="1F5FA8"/>
+                          </a:solidFill>
+                          <a:latin typeface="Calibri"/>
+                        </a:rPr>
+                        <a:t>a leash (entry 6)</a:t>
+                      </a:r>
+                    </a:p>
+                  </a:txBody>
+                  <a:tcPr marL="91440" marR="91440" marT="45720" marB="45720" anchor="ctr">
+                    <a:solidFill>
+                      <a:srgbClr val="FBFCFC"/>
+                    </a:solidFill>
+                  </a:tcPr>
+                </a:tc>
+              </a:tr>
+              <a:tr h="359664">
+                <a:tc>
+                  <a:txBody>
+                    <a:bodyPr wrap="square"/>
+                    <a:lstStyle/>
+                    <a:p>
+                      <a:r>
+                        <a:rPr sz="1400" b="0">
+                          <a:solidFill>
+                            <a:srgbClr val="16222B"/>
+                          </a:solidFill>
+                          <a:latin typeface="Calibri"/>
+                        </a:rPr>
+                        <a:t>Deadly triad: off-policy + approximation</a:t>
+                      </a:r>
+                    </a:p>
+                  </a:txBody>
+                  <a:tcPr marL="91440" marR="91440" marT="45720" marB="45720" anchor="ctr">
+                    <a:solidFill>
+                      <a:srgbClr val="FBFCFC"/>
+                    </a:solidFill>
+                  </a:tcPr>
+                </a:tc>
+                <a:tc>
+                  <a:txBody>
+                    <a:bodyPr wrap="square"/>
+                    <a:lstStyle/>
+                    <a:p>
+                      <a:r>
+                        <a:rPr sz="1400" b="0">
+                          <a:solidFill>
+                            <a:srgbClr val="16222B"/>
+                          </a:solidFill>
+                          <a:latin typeface="Calibri"/>
+                        </a:rPr>
+                        <a:t>Stale replayed answers, 0.8B network</a:t>
+                      </a:r>
+                    </a:p>
+                  </a:txBody>
+                  <a:tcPr marL="91440" marR="91440" marT="45720" marB="45720" anchor="ctr">
+                    <a:solidFill>
+                      <a:srgbClr val="FBFCFC"/>
+                    </a:solidFill>
+                  </a:tcPr>
+                </a:tc>
+                <a:tc>
+                  <a:txBody>
+                    <a:bodyPr wrap="square"/>
+                    <a:lstStyle/>
+                    <a:p>
+                      <a:r>
+                        <a:rPr sz="1400" b="0">
+                          <a:solidFill>
+                            <a:srgbClr val="B94E08"/>
+                          </a:solidFill>
+                          <a:latin typeface="Calibri"/>
+                        </a:rPr>
+                        <a:t>KL runaway (entry 9)</a:t>
+                      </a:r>
+                    </a:p>
+                  </a:txBody>
+                  <a:tcPr marL="91440" marR="91440" marT="45720" marB="45720" anchor="ctr">
+                    <a:solidFill>
+                      <a:srgbClr val="FBFCFC"/>
+                    </a:solidFill>
+                  </a:tcPr>
+                </a:tc>
+              </a:tr>
+              <a:tr h="359664">
+                <a:tc>
+                  <a:txBody>
+                    <a:bodyPr wrap="square"/>
+                    <a:lstStyle/>
+                    <a:p>
+                      <a:r>
+                        <a:rPr sz="1400" b="0">
+                          <a:solidFill>
+                            <a:srgbClr val="16222B"/>
+                          </a:solidFill>
+                          <a:latin typeface="Calibri"/>
+                        </a:rPr>
+                        <a:t>Learned model of the world (Dyna)</a:t>
+                      </a:r>
+                    </a:p>
+                  </a:txBody>
+                  <a:tcPr marL="91440" marR="91440" marT="45720" marB="45720" anchor="ctr">
+                    <a:solidFill>
+                      <a:srgbClr val="FBFCFC"/>
+                    </a:solidFill>
+                  </a:tcPr>
+                </a:tc>
+                <a:tc>
+                  <a:txBody>
+                    <a:bodyPr wrap="square"/>
+                    <a:lstStyle/>
+                    <a:p>
+                      <a:r>
+                        <a:rPr sz="1400" b="0">
+                          <a:solidFill>
+                            <a:srgbClr val="16222B"/>
+                          </a:solidFill>
+                          <a:latin typeface="Calibri"/>
+                        </a:rPr>
+                        <a:t>Ensemble predicting the judge</a:t>
+                      </a:r>
+                    </a:p>
+                  </a:txBody>
+                  <a:tcPr marL="91440" marR="91440" marT="45720" marB="45720" anchor="ctr">
+                    <a:solidFill>
+                      <a:srgbClr val="FBFCFC"/>
+                    </a:solidFill>
+                  </a:tcPr>
+                </a:tc>
+                <a:tc>
+                  <a:txBody>
+                    <a:bodyPr wrap="square"/>
+                    <a:lstStyle/>
+                    <a:p>
+                      <a:r>
+                        <a:rPr sz="1400" b="0">
+                          <a:solidFill>
+                            <a:srgbClr val="B94E08"/>
+                          </a:solidFill>
+                          <a:latin typeface="Calibri"/>
+                        </a:rPr>
+                        <a:t>falsified (entry 10)</a:t>
+                      </a:r>
+                    </a:p>
+                  </a:txBody>
+                  <a:tcPr marL="91440" marR="91440" marT="45720" marB="45720" anchor="ctr">
+                    <a:solidFill>
+                      <a:srgbClr val="FBFCFC"/>
+                    </a:solidFill>
+                  </a:tcPr>
+                </a:tc>
+              </a:tr>
+              <a:tr h="359664">
+                <a:tc>
+                  <a:txBody>
+                    <a:bodyPr wrap="square"/>
+                    <a:lstStyle/>
+                    <a:p>
+                      <a:r>
+                        <a:rPr sz="1400" b="0">
+                          <a:solidFill>
+                            <a:srgbClr val="16222B"/>
+                          </a:solidFill>
+                          <a:latin typeface="Calibri"/>
+                        </a:rPr>
+                        <a:t>Reward modeling</a:t>
+                      </a:r>
+                    </a:p>
+                  </a:txBody>
+                  <a:tcPr marL="91440" marR="91440" marT="45720" marB="45720" anchor="ctr">
+                    <a:solidFill>
+                      <a:srgbClr val="FBFCFC"/>
+                    </a:solidFill>
+                  </a:tcPr>
+                </a:tc>
+                <a:tc>
+                  <a:txBody>
+                    <a:bodyPr wrap="square"/>
+                    <a:lstStyle/>
+                    <a:p>
+                      <a:r>
+                        <a:rPr sz="1400" b="0">
+                          <a:solidFill>
+                            <a:srgbClr val="16222B"/>
+                          </a:solidFill>
+                          <a:latin typeface="Calibri"/>
+                        </a:rPr>
+                        <a:t>Jev, a small yes/no judge</a:t>
+                      </a:r>
+                    </a:p>
+                  </a:txBody>
+                  <a:tcPr marL="91440" marR="91440" marT="45720" marB="45720" anchor="ctr">
+                    <a:solidFill>
+                      <a:srgbClr val="FBFCFC"/>
+                    </a:solidFill>
+                  </a:tcPr>
+                </a:tc>
+                <a:tc>
+                  <a:txBody>
+                    <a:bodyPr wrap="square"/>
+                    <a:lstStyle/>
+                    <a:p>
+                      <a:r>
+                        <a:rPr sz="1400" b="0">
+                          <a:solidFill>
+                            <a:srgbClr val="B94E08"/>
+                          </a:solidFill>
+                          <a:latin typeface="Calibri"/>
+                        </a:rPr>
+                        <a:t>needs a guard (entry 11)</a:t>
+                      </a:r>
+                    </a:p>
+                  </a:txBody>
+                  <a:tcPr marL="91440" marR="91440" marT="45720" marB="45720" anchor="ctr">
+                    <a:solidFill>
+                      <a:srgbClr val="FBFCFC"/>
+                    </a:solidFill>
+                  </a:tcPr>
+                </a:tc>
+              </a:tr>
+              <a:tr h="359664">
+                <a:tc>
+                  <a:txBody>
+                    <a:bodyPr wrap="square"/>
+                    <a:lstStyle/>
+                    <a:p>
+                      <a:r>
+                        <a:rPr sz="1400" b="0">
+                          <a:solidFill>
+                            <a:srgbClr val="16222B"/>
+                          </a:solidFill>
+                          <a:latin typeface="Calibri"/>
+                        </a:rPr>
+                        <a:t>Reward shaping</a:t>
+                      </a:r>
+                    </a:p>
+                  </a:txBody>
+                  <a:tcPr marL="91440" marR="91440" marT="45720" marB="45720" anchor="ctr">
+                    <a:solidFill>
+                      <a:srgbClr val="FBFCFC"/>
+                    </a:solidFill>
+                  </a:tcPr>
+                </a:tc>
+                <a:tc>
+                  <a:txBody>
+                    <a:bodyPr wrap="square"/>
+                    <a:lstStyle/>
+                    <a:p>
+                      <a:r>
+                        <a:rPr sz="1400" b="0">
+                          <a:solidFill>
+                            <a:srgbClr val="16222B"/>
+                          </a:solidFill>
+                          <a:latin typeface="Calibri"/>
+                        </a:rPr>
+                        <a:t>Bands gated by correctness</a:t>
+                      </a:r>
+                    </a:p>
+                  </a:txBody>
+                  <a:tcPr marL="91440" marR="91440" marT="45720" marB="45720" anchor="ctr">
+                    <a:solidFill>
+                      <a:srgbClr val="FBFCFC"/>
+                    </a:solidFill>
+                  </a:tcPr>
+                </a:tc>
+                <a:tc>
+                  <a:txBody>
+                    <a:bodyPr wrap="square"/>
+                    <a:lstStyle/>
+                    <a:p>
+                      <a:r>
+                        <a:rPr sz="1400" b="0">
+                          <a:solidFill>
+                            <a:srgbClr val="B94E08"/>
+                          </a:solidFill>
+                          <a:latin typeface="Calibri"/>
+                        </a:rPr>
+                        <a:t>87% paid zero (entry 5)</a:t>
+                      </a:r>
+                    </a:p>
+                  </a:txBody>
+                  <a:tcPr marL="91440" marR="91440" marT="45720" marB="45720" anchor="ctr">
+                    <a:solidFill>
+                      <a:srgbClr val="FBFCFC"/>
+                    </a:solidFill>
+                  </a:tcPr>
+                </a:tc>
+              </a:tr>
+            </a:tbl>
+          </a:graphicData>
+        </a:graphic>
+      </p:graphicFrame>
+    </p:spTree>
+  </p:cSld>
+  <p:clrMapOvr>
+    <a:masterClrMapping/>
+  </p:clrMapOvr>
+</p:sld>
+</file>
+
+<file path=ppt/slides/slide11.xml><?xml version="1.0" encoding="utf-8"?>
+<p:sld xmlns:a="http://schemas.openxmlformats.org/drawingml/2006/main" xmlns:p="http://schemas.openxmlformats.org/presentationml/2006/main" xmlns:r="http://schemas.openxmlformats.org/officeDocument/2006/relationships">
+  <p:cSld>
+    <p:bg>
+      <p:bgPr>
+        <a:solidFill>
+          <a:srgbClr val="F3F5F6"/>
+        </a:solidFill>
+        <a:effectLst/>
+      </p:bgPr>
+    </p:bg>
+    <p:spTree>
+      <p:nvGrpSpPr>
+        <p:cNvPr id="1" name=""/>
+        <p:cNvGrpSpPr/>
+        <p:nvPr/>
+      </p:nvGrpSpPr>
+      <p:grpSpPr/>
+      <p:sp>
+        <p:nvSpPr>
+          <p:cNvPr id="2" name="TextBox 1"/>
+          <p:cNvSpPr txBox="1"/>
+          <p:nvPr/>
+        </p:nvSpPr>
+        <p:spPr>
+          <a:xfrm>
+            <a:off x="822960" y="658368"/>
+            <a:ext cx="10545775" cy="274320"/>
+          </a:xfrm>
+          <a:prstGeom prst="rect">
+            <a:avLst/>
+          </a:prstGeom>
+          <a:noFill/>
+        </p:spPr>
+        <p:txBody>
+          <a:bodyPr wrap="square" lIns="0" rIns="0" tIns="0" bIns="0" anchor="t">
+            <a:spAutoFit/>
+          </a:bodyPr>
+          <a:lstStyle/>
+          <a:p>
+            <a:r>
+              <a:rPr sz="1200" b="1">
+                <a:solidFill>
+                  <a:srgbClr val="1F5FA8"/>
+                </a:solidFill>
+                <a:latin typeface="Consolas"/>
+              </a:rPr>
+              <a:t>INSTRUMENT</a:t>
+            </a:r>
+          </a:p>
+        </p:txBody>
+      </p:sp>
+      <p:sp>
+        <p:nvSpPr>
+          <p:cNvPr id="3" name="TextBox 2"/>
+          <p:cNvSpPr txBox="1"/>
+          <p:nvPr/>
+        </p:nvSpPr>
+        <p:spPr>
+          <a:xfrm>
+            <a:off x="822960" y="932688"/>
+            <a:ext cx="10545775" cy="640080"/>
+          </a:xfrm>
+          <a:prstGeom prst="rect">
+            <a:avLst/>
+          </a:prstGeom>
+          <a:noFill/>
+        </p:spPr>
+        <p:txBody>
+          <a:bodyPr wrap="square" lIns="0" rIns="0" tIns="0" bIns="0" anchor="t">
+            <a:spAutoFit/>
+          </a:bodyPr>
+          <a:lstStyle/>
+          <a:p>
+            <a:r>
+              <a:rPr sz="2800" b="1">
+                <a:solidFill>
+                  <a:srgbClr val="16222B"/>
+                </a:solidFill>
+                <a:latin typeface="Georgia"/>
+              </a:rPr>
+              <a:t>A 16-question eval is noisy</a:t>
             </a:r>
           </a:p>
         </p:txBody>
@@ -5963,7 +6801,7 @@
                 </a:solidFill>
                 <a:latin typeface="Calibri"/>
               </a:rPr>
-              <a:t>Earlier recipe. Sampled gaps overlap (left); one greedy answer per question clears the instrument floor of 0.0526 (right).</a:t>
+              <a:t>Earlier lane. Left: sampled scores overlap, so no gap can be called. Right: one greedy answer per question separates each step by more than the 0.0526 floor.</a:t>
             </a:r>
           </a:p>
         </p:txBody>
@@ -6201,7 +7039,7 @@
                 </a:solidFill>
                 <a:latin typeface="Calibri"/>
               </a:rPr>
-              <a:t>So: read shapes across steps, and trust a comparison only when both sides were scored in one invocation.</a:t>
+              <a:t>Compare two models only when one scoring run measured both.</a:t>
             </a:r>
           </a:p>
         </p:txBody>
@@ -9421,7 +10259,7 @@
                 </a:solidFill>
                 <a:latin typeface="Calibri"/>
               </a:rPr>
-              <a:t>Source: dispositions.md: rl_nowm, rl_k, rl_kl03, rl_lr3e6 (09-23 to 09-25); crossing-run correction 3  ·  figure: slide 27</a:t>
+              <a:t>Source: dispositions.md: rl_nowm, rl_k, rl_kl03, rl_lr3e6 (09-23 to 09-25); crossing-run correction 3  ·  figure: slide 28</a:t>
             </a:r>
           </a:p>
         </p:txBody>
@@ -11077,7 +11915,7 @@
                 </a:solidFill>
                 <a:latin typeface="Calibri"/>
               </a:rPr>
-              <a:t>Source: dispositions.md: "REPLAY SAMPLER" (09-24), "rl_replay2" (09-25 to 09-26)  ·  figure: slide 28</a:t>
+              <a:t>Source: dispositions.md: "REPLAY SAMPLER" (09-24), "rl_replay2" (09-25 to 09-26)  ·  figure: slide 29</a:t>
             </a:r>
           </a:p>
         </p:txBody>
@@ -20152,7 +20990,7 @@
                 </a:solidFill>
                 <a:latin typeface="Calibri"/>
               </a:rPr>
-              <a:t>Later passes degraded, and the long runs on slides 27 and 28 never beat 9 and never held a gain.</a:t>
+              <a:t>Later passes degraded, and the long runs on slides 28 and 29 never beat 9 and never held a gain.</a:t>
             </a:r>
           </a:p>
           <a:p>
@@ -20168,7 +21006,7 @@
                 </a:solidFill>
                 <a:latin typeface="Calibri"/>
               </a:rPr>
-              <a:t>The 9 comes from the early instrument. It was not re-read under the training prompt (slide 22), so it is not comparable with the long-run numbers.</a:t>
+              <a:t>The 9 comes from the early instrument. It was not re-read under the training prompt (slide 23), so it is not comparable with the long-run numbers.</a:t>
             </a:r>
           </a:p>
         </p:txBody>
@@ -23157,6 +23995,428 @@
 <file path=ppt/slides/slide7.xml><?xml version="1.0" encoding="utf-8"?>
 <p:sld xmlns:a="http://schemas.openxmlformats.org/drawingml/2006/main" xmlns:p="http://schemas.openxmlformats.org/presentationml/2006/main" xmlns:r="http://schemas.openxmlformats.org/officeDocument/2006/relationships">
   <p:cSld>
+    <p:spTree>
+      <p:nvGrpSpPr>
+        <p:cNvPr id="1" name=""/>
+        <p:cNvGrpSpPr/>
+        <p:nvPr/>
+      </p:nvGrpSpPr>
+      <p:grpSpPr/>
+      <p:sp>
+        <p:nvSpPr>
+          <p:cNvPr id="2" name="TextBox 1"/>
+          <p:cNvSpPr txBox="1"/>
+          <p:nvPr/>
+        </p:nvSpPr>
+        <p:spPr>
+          <a:xfrm>
+            <a:off x="822960" y="658368"/>
+            <a:ext cx="10545775" cy="274320"/>
+          </a:xfrm>
+          <a:prstGeom prst="rect">
+            <a:avLst/>
+          </a:prstGeom>
+          <a:noFill/>
+        </p:spPr>
+        <p:txBody>
+          <a:bodyPr wrap="square" lIns="0" rIns="0" tIns="0" bIns="0" anchor="t">
+            <a:spAutoFit/>
+          </a:bodyPr>
+          <a:lstStyle/>
+          <a:p>
+            <a:r>
+              <a:rPr sz="1200" b="1">
+                <a:solidFill>
+                  <a:srgbClr val="1F5FA8"/>
+                </a:solidFill>
+                <a:latin typeface="Consolas"/>
+              </a:rPr>
+              <a:t>METHOD · THE JUDGE BEFORE JEV</a:t>
+            </a:r>
+          </a:p>
+        </p:txBody>
+      </p:sp>
+      <p:sp>
+        <p:nvSpPr>
+          <p:cNvPr id="3" name="TextBox 2"/>
+          <p:cNvSpPr txBox="1"/>
+          <p:nvPr/>
+        </p:nvSpPr>
+        <p:spPr>
+          <a:xfrm>
+            <a:off x="822960" y="932688"/>
+            <a:ext cx="10545775" cy="640080"/>
+          </a:xfrm>
+          <a:prstGeom prst="rect">
+            <a:avLst/>
+          </a:prstGeom>
+          <a:noFill/>
+        </p:spPr>
+        <p:txBody>
+          <a:bodyPr wrap="square" lIns="0" rIns="0" tIns="0" bIns="0" anchor="t">
+            <a:spAutoFit/>
+          </a:bodyPr>
+          <a:lstStyle/>
+          <a:p>
+            <a:r>
+              <a:rPr sz="2800" b="1">
+                <a:solidFill>
+                  <a:srgbClr val="16222B"/>
+                </a:solidFill>
+                <a:latin typeface="Georgia"/>
+              </a:rPr>
+              <a:t>An LLM judge scored every answer against the gold</a:t>
+            </a:r>
+          </a:p>
+        </p:txBody>
+      </p:sp>
+      <p:sp>
+        <p:nvSpPr>
+          <p:cNvPr id="4" name="TextBox 3"/>
+          <p:cNvSpPr txBox="1"/>
+          <p:nvPr/>
+        </p:nvSpPr>
+        <p:spPr>
+          <a:xfrm>
+            <a:off x="822960" y="6382512"/>
+            <a:ext cx="10545775" cy="274320"/>
+          </a:xfrm>
+          <a:prstGeom prst="rect">
+            <a:avLst/>
+          </a:prstGeom>
+          <a:noFill/>
+        </p:spPr>
+        <p:txBody>
+          <a:bodyPr wrap="square" lIns="0" rIns="0" tIns="0" bIns="0" anchor="t">
+            <a:spAutoFit/>
+          </a:bodyPr>
+          <a:lstStyle/>
+          <a:p>
+            <a:r>
+              <a:rPr sz="1200" b="0">
+                <a:solidFill>
+                  <a:srgbClr val="5E6B75"/>
+                </a:solidFill>
+                <a:latin typeface="Calibri"/>
+              </a:rPr>
+              <a:t>Source: src/rlv2/judge/judge.py (docstring) · docs/dispositions.md: JUDGE CHANGE (09-26), the reward was a constant for 87% of rollouts (09-22) · docs/SETTLED.md</a:t>
+            </a:r>
+          </a:p>
+        </p:txBody>
+      </p:sp>
+      <p:sp>
+        <p:nvSpPr>
+          <p:cNvPr id="5" name="Rounded Rectangle 4"/>
+          <p:cNvSpPr/>
+          <p:nvPr/>
+        </p:nvSpPr>
+        <p:spPr>
+          <a:xfrm>
+            <a:off x="822960" y="1691640"/>
+            <a:ext cx="10545775" cy="3447288"/>
+          </a:xfrm>
+          <a:prstGeom prst="roundRect">
+            <a:avLst>
+              <a:gd name="adj" fmla="val 3000"/>
+            </a:avLst>
+          </a:prstGeom>
+          <a:solidFill>
+            <a:srgbClr val="FBFCFC"/>
+          </a:solidFill>
+          <a:ln w="9525">
+            <a:solidFill>
+              <a:srgbClr val="D2D9DD"/>
+            </a:solidFill>
+          </a:ln>
+          <a:effectLst/>
+        </p:spPr>
+        <p:style>
+          <a:lnRef idx="1">
+            <a:schemeClr val="accent1"/>
+          </a:lnRef>
+          <a:fillRef idx="3">
+            <a:schemeClr val="accent1"/>
+          </a:fillRef>
+          <a:effectRef idx="2">
+            <a:schemeClr val="accent1"/>
+          </a:effectRef>
+          <a:fontRef idx="minor">
+            <a:schemeClr val="lt1"/>
+          </a:fontRef>
+        </p:style>
+        <p:txBody>
+          <a:bodyPr rtlCol="0" anchor="ctr"/>
+          <a:lstStyle/>
+          <a:p>
+            <a:pPr algn="ctr"/>
+          </a:p>
+        </p:txBody>
+      </p:sp>
+      <p:sp>
+        <p:nvSpPr>
+          <p:cNvPr id="7" name="TextBox 6"/>
+          <p:cNvSpPr txBox="1"/>
+          <p:nvPr/>
+        </p:nvSpPr>
+        <p:spPr>
+          <a:xfrm>
+            <a:off x="1051560" y="1800000"/>
+            <a:ext cx="10088575" cy="3200000"/>
+          </a:xfrm>
+          <a:prstGeom prst="rect">
+            <a:avLst/>
+          </a:prstGeom>
+          <a:noFill/>
+        </p:spPr>
+        <p:txBody>
+          <a:bodyPr wrap="square" lIns="0" rIns="0" tIns="0" bIns="0" anchor="t">
+            <a:spAutoFit/>
+          </a:bodyPr>
+          <a:lstStyle/>
+          <a:p>
+            <a:pPr>
+              <a:spcAft>
+                <a:spcPts val="500"/>
+              </a:spcAft>
+            </a:pPr>
+            <a:r>
+              <a:rPr sz="1500" b="1">
+                <a:solidFill>
+                  <a:srgbClr val="1A2332"/>
+                </a:solidFill>
+                <a:latin typeface="Calibri"/>
+              </a:rPr>
+              <a:t>How it worked</a:t>
+            </a:r>
+          </a:p>
+          <a:p>
+            <a:pPr>
+              <a:spcAft>
+                <a:spcPts val="500"/>
+              </a:spcAft>
+            </a:pPr>
+            <a:r>
+              <a:rPr sz="1500" b="0">
+                <a:solidFill>
+                  <a:srgbClr val="1A2332"/>
+                </a:solidFill>
+                <a:latin typeface="Calibri"/>
+              </a:rPr>
+              <a:t>A 9B model wrote the questions, gold answers and rubric examples. A separate judge (4B for eval scoring, 9B for the RL runs) read the question, the gold and one answer, and applied the written rubric. The policy never saw the rubric.</a:t>
+            </a:r>
+          </a:p>
+          <a:p>
+            <a:pPr>
+              <a:spcAft>
+                <a:spcPts val="500"/>
+              </a:spcAft>
+            </a:pPr>
+            <a:r>
+              <a:rPr sz="1500" b="0">
+                <a:solidFill>
+                  <a:srgbClr val="1A2332"/>
+                </a:solidFill>
+                <a:latin typeface="Calibri"/>
+              </a:rPr>
+              <a:t>One call returns the reasoning first (the gold's claim, the answer's claim, whether they match, what holds it back), then one score from 0 to 1. Correct means 0.70 or more. A malformed reply scores 0, never correct.</a:t>
+            </a:r>
+          </a:p>
+          <a:p>
+            <a:pPr>
+              <a:spcAft>
+                <a:spcPts val="500"/>
+              </a:spcAft>
+            </a:pPr>
+            <a:r>
+              <a:rPr sz="1500" b="0">
+                <a:solidFill>
+                  <a:srgbClr val="1A2332"/>
+                </a:solidFill>
+                <a:latin typeface="Calibri"/>
+              </a:rPr>
+              <a:t>Reward: 0, 0.5 or 1 by score, gated by correctness. Eval counts used three reads and a majority.</a:t>
+            </a:r>
+          </a:p>
+          <a:p>
+            <a:pPr>
+              <a:spcAft>
+                <a:spcPts val="500"/>
+              </a:spcAft>
+            </a:pPr>
+            <a:r>
+              <a:rPr sz="1500" b="1">
+                <a:solidFill>
+                  <a:srgbClr val="1A2332"/>
+                </a:solidFill>
+                <a:latin typeface="Calibri"/>
+              </a:rPr>
+              <a:t>What went wrong</a:t>
+            </a:r>
+          </a:p>
+          <a:p>
+            <a:pPr>
+              <a:spcAft>
+                <a:spcPts val="500"/>
+              </a:spcAft>
+            </a:pPr>
+            <a:r>
+              <a:rPr sz="1500" b="0">
+                <a:solidFill>
+                  <a:srgbClr val="1A2332"/>
+                </a:solidFill>
+                <a:latin typeface="Calibri"/>
+              </a:rPr>
+              <a:t>It paid for empty answers (now scored 0 mechanically). 87% of 1,752 judged answers paid exactly 0.0, so seven rollouts in eight carried no signal. Two-call verdict and score disagreed on one item; the one-number form fixed that.</a:t>
+            </a:r>
+          </a:p>
+        </p:txBody>
+      </p:sp>
+      <p:sp>
+        <p:nvSpPr>
+          <p:cNvPr id="8" name="Rounded Rectangle 7"/>
+          <p:cNvSpPr/>
+          <p:nvPr/>
+        </p:nvSpPr>
+        <p:spPr>
+          <a:xfrm>
+            <a:off x="822960" y="5321808"/>
+            <a:ext cx="10545775" cy="731520"/>
+          </a:xfrm>
+          <a:prstGeom prst="roundRect">
+            <a:avLst>
+              <a:gd name="adj" fmla="val 12000"/>
+            </a:avLst>
+          </a:prstGeom>
+          <a:solidFill>
+            <a:srgbClr val="E4E9EC"/>
+          </a:solidFill>
+          <a:ln>
+            <a:noFill/>
+          </a:ln>
+          <a:effectLst/>
+        </p:spPr>
+        <p:style>
+          <a:lnRef idx="1">
+            <a:schemeClr val="accent1"/>
+          </a:lnRef>
+          <a:fillRef idx="3">
+            <a:schemeClr val="accent1"/>
+          </a:fillRef>
+          <a:effectRef idx="2">
+            <a:schemeClr val="accent1"/>
+          </a:effectRef>
+          <a:fontRef idx="minor">
+            <a:schemeClr val="lt1"/>
+          </a:fontRef>
+        </p:style>
+        <p:txBody>
+          <a:bodyPr rtlCol="0" anchor="ctr"/>
+          <a:lstStyle/>
+          <a:p>
+            <a:pPr algn="ctr"/>
+          </a:p>
+        </p:txBody>
+      </p:sp>
+      <p:sp>
+        <p:nvSpPr>
+          <p:cNvPr id="9" name="Rounded Rectangle 8"/>
+          <p:cNvSpPr/>
+          <p:nvPr/>
+        </p:nvSpPr>
+        <p:spPr>
+          <a:xfrm>
+            <a:off x="1078992" y="5522976"/>
+            <a:ext cx="1508760" cy="329184"/>
+          </a:xfrm>
+          <a:prstGeom prst="roundRect">
+            <a:avLst>
+              <a:gd name="adj" fmla="val 50000"/>
+            </a:avLst>
+          </a:prstGeom>
+          <a:solidFill>
+            <a:srgbClr val="5E6B75"/>
+          </a:solidFill>
+          <a:ln>
+            <a:noFill/>
+          </a:ln>
+          <a:effectLst/>
+        </p:spPr>
+        <p:style>
+          <a:lnRef idx="1">
+            <a:schemeClr val="accent1"/>
+          </a:lnRef>
+          <a:fillRef idx="3">
+            <a:schemeClr val="accent1"/>
+          </a:fillRef>
+          <a:effectRef idx="2">
+            <a:schemeClr val="accent1"/>
+          </a:effectRef>
+          <a:fontRef idx="minor">
+            <a:schemeClr val="lt1"/>
+          </a:fontRef>
+        </p:style>
+        <p:txBody>
+          <a:bodyPr rtlCol="0" anchor="ctr" lIns="0" rIns="0" tIns="0" bIns="0"/>
+          <a:lstStyle/>
+          <a:p>
+            <a:pPr algn="ctr"/>
+            <a:r>
+              <a:rPr sz="1100" b="1">
+                <a:solidFill>
+                  <a:srgbClr val="F7FAFB"/>
+                </a:solidFill>
+                <a:latin typeface="Consolas"/>
+              </a:rPr>
+              <a:t>REPLACED</a:t>
+            </a:r>
+          </a:p>
+        </p:txBody>
+      </p:sp>
+      <p:sp>
+        <p:nvSpPr>
+          <p:cNvPr id="10" name="TextBox 9"/>
+          <p:cNvSpPr txBox="1"/>
+          <p:nvPr/>
+        </p:nvSpPr>
+        <p:spPr>
+          <a:xfrm>
+            <a:off x="2843784" y="5413248"/>
+            <a:ext cx="8268919" cy="548640"/>
+          </a:xfrm>
+          <a:prstGeom prst="rect">
+            <a:avLst/>
+          </a:prstGeom>
+          <a:noFill/>
+        </p:spPr>
+        <p:txBody>
+          <a:bodyPr wrap="square" lIns="0" rIns="0" tIns="0" bIns="0" anchor="ctr">
+            <a:spAutoFit/>
+          </a:bodyPr>
+          <a:lstStyle/>
+          <a:p>
+            <a:r>
+              <a:rPr sz="1600" b="0">
+                <a:solidFill>
+                  <a:srgbClr val="16222B"/>
+                </a:solidFill>
+                <a:latin typeface="Calibri"/>
+              </a:rPr>
+              <a:t>Replaced by Jev on 2026-09-26: the 9B judge's 3-level score paid 28 of 50 wrong answers as fully correct when Jev's yes/no form paid 6.</a:t>
+            </a:r>
+          </a:p>
+        </p:txBody>
+      </p:sp>
+    </p:spTree>
+  </p:cSld>
+  <p:clrMapOvr>
+    <a:masterClrMapping/>
+  </p:clrMapOvr>
+</p:sld>
+</file>
+
+<file path=ppt/slides/slide8.xml><?xml version="1.0" encoding="utf-8"?>
+<p:sld xmlns:a="http://schemas.openxmlformats.org/drawingml/2006/main" xmlns:p="http://schemas.openxmlformats.org/presentationml/2006/main" xmlns:r="http://schemas.openxmlformats.org/officeDocument/2006/relationships">
+  <p:cSld>
     <p:bg>
       <p:bgPr>
         <a:solidFill>
@@ -23852,635 +25112,6 @@
 </p:sld>
 </file>
 
-<file path=ppt/slides/slide8.xml><?xml version="1.0" encoding="utf-8"?>
-<p:sld xmlns:a="http://schemas.openxmlformats.org/drawingml/2006/main" xmlns:p="http://schemas.openxmlformats.org/presentationml/2006/main" xmlns:r="http://schemas.openxmlformats.org/officeDocument/2006/relationships">
-  <p:cSld>
-    <p:bg>
-      <p:bgPr>
-        <a:solidFill>
-          <a:srgbClr val="F3F5F6"/>
-        </a:solidFill>
-        <a:effectLst/>
-      </p:bgPr>
-    </p:bg>
-    <p:spTree>
-      <p:nvGrpSpPr>
-        <p:cNvPr id="1" name=""/>
-        <p:cNvGrpSpPr/>
-        <p:nvPr/>
-      </p:nvGrpSpPr>
-      <p:grpSpPr/>
-      <p:sp>
-        <p:nvSpPr>
-          <p:cNvPr id="2" name="TextBox 1"/>
-          <p:cNvSpPr txBox="1"/>
-          <p:nvPr/>
-        </p:nvSpPr>
-        <p:spPr>
-          <a:xfrm>
-            <a:off x="822960" y="658368"/>
-            <a:ext cx="10545775" cy="274320"/>
-          </a:xfrm>
-          <a:prstGeom prst="rect">
-            <a:avLst/>
-          </a:prstGeom>
-          <a:noFill/>
-        </p:spPr>
-        <p:txBody>
-          <a:bodyPr wrap="square" lIns="0" rIns="0" tIns="0" bIns="0" anchor="t">
-            <a:spAutoFit/>
-          </a:bodyPr>
-          <a:lstStyle/>
-          <a:p>
-            <a:r>
-              <a:rPr sz="1200" b="1">
-                <a:solidFill>
-                  <a:srgbClr val="1F5FA8"/>
-                </a:solidFill>
-                <a:latin typeface="Consolas"/>
-              </a:rPr>
-              <a:t>METHOD · SETTINGS</a:t>
-            </a:r>
-          </a:p>
-        </p:txBody>
-      </p:sp>
-      <p:sp>
-        <p:nvSpPr>
-          <p:cNvPr id="3" name="TextBox 2"/>
-          <p:cNvSpPr txBox="1"/>
-          <p:nvPr/>
-        </p:nvSpPr>
-        <p:spPr>
-          <a:xfrm>
-            <a:off x="822960" y="932688"/>
-            <a:ext cx="10545775" cy="640080"/>
-          </a:xfrm>
-          <a:prstGeom prst="rect">
-            <a:avLst/>
-          </a:prstGeom>
-          <a:noFill/>
-        </p:spPr>
-        <p:txBody>
-          <a:bodyPr wrap="square" lIns="0" rIns="0" tIns="0" bIns="0" anchor="t">
-            <a:spAutoFit/>
-          </a:bodyPr>
-          <a:lstStyle/>
-          <a:p>
-            <a:r>
-              <a:rPr sz="2800" b="1">
-                <a:solidFill>
-                  <a:srgbClr val="16222B"/>
-                </a:solidFill>
-                <a:latin typeface="Georgia"/>
-              </a:rPr>
-              <a:t>The RL trainer's default settings</a:t>
-            </a:r>
-          </a:p>
-        </p:txBody>
-      </p:sp>
-      <p:sp>
-        <p:nvSpPr>
-          <p:cNvPr id="4" name="TextBox 3"/>
-          <p:cNvSpPr txBox="1"/>
-          <p:nvPr/>
-        </p:nvSpPr>
-        <p:spPr>
-          <a:xfrm>
-            <a:off x="822960" y="6382512"/>
-            <a:ext cx="10545775" cy="274320"/>
-          </a:xfrm>
-          <a:prstGeom prst="rect">
-            <a:avLst/>
-          </a:prstGeom>
-          <a:noFill/>
-        </p:spPr>
-        <p:txBody>
-          <a:bodyPr wrap="square" lIns="0" rIns="0" tIns="0" bIns="0" anchor="t">
-            <a:spAutoFit/>
-          </a:bodyPr>
-          <a:lstStyle/>
-          <a:p>
-            <a:r>
-              <a:rPr sz="1200" b="0">
-                <a:solidFill>
-                  <a:srgbClr val="5E6B75"/>
-                </a:solidFill>
-                <a:latin typeface="Calibri"/>
-              </a:rPr>
-              <a:t>Source: docs/grpo_one_file.py DEFAULTS and argument list · dispositions.md · each run's launcher holds its own overrides</a:t>
-            </a:r>
-          </a:p>
-        </p:txBody>
-      </p:sp>
-      <p:sp>
-        <p:nvSpPr>
-          <p:cNvPr id="5" name="Rounded Rectangle 4"/>
-          <p:cNvSpPr/>
-          <p:nvPr/>
-        </p:nvSpPr>
-        <p:spPr>
-          <a:xfrm>
-            <a:off x="822960" y="1691640"/>
-            <a:ext cx="3362858" cy="4343400"/>
-          </a:xfrm>
-          <a:prstGeom prst="roundRect">
-            <a:avLst>
-              <a:gd name="adj" fmla="val 4000"/>
-            </a:avLst>
-          </a:prstGeom>
-          <a:solidFill>
-            <a:srgbClr val="FBFCFC"/>
-          </a:solidFill>
-          <a:ln w="9525">
-            <a:solidFill>
-              <a:srgbClr val="D2D9DD"/>
-            </a:solidFill>
-          </a:ln>
-          <a:effectLst/>
-        </p:spPr>
-        <p:style>
-          <a:lnRef idx="1">
-            <a:schemeClr val="accent1"/>
-          </a:lnRef>
-          <a:fillRef idx="3">
-            <a:schemeClr val="accent1"/>
-          </a:fillRef>
-          <a:effectRef idx="2">
-            <a:schemeClr val="accent1"/>
-          </a:effectRef>
-          <a:fontRef idx="minor">
-            <a:schemeClr val="lt1"/>
-          </a:fontRef>
-        </p:style>
-        <p:txBody>
-          <a:bodyPr rtlCol="0" anchor="ctr"/>
-          <a:lstStyle/>
-          <a:p>
-            <a:pPr algn="ctr"/>
-          </a:p>
-        </p:txBody>
-      </p:sp>
-      <p:sp>
-        <p:nvSpPr>
-          <p:cNvPr id="6" name="TextBox 5"/>
-          <p:cNvSpPr txBox="1"/>
-          <p:nvPr/>
-        </p:nvSpPr>
-        <p:spPr>
-          <a:xfrm>
-            <a:off x="1005840" y="1837944"/>
-            <a:ext cx="2997098" cy="4069080"/>
-          </a:xfrm>
-          <a:prstGeom prst="rect">
-            <a:avLst/>
-          </a:prstGeom>
-          <a:noFill/>
-        </p:spPr>
-        <p:txBody>
-          <a:bodyPr wrap="square" lIns="0" rIns="0" tIns="0" bIns="0" anchor="t">
-            <a:spAutoFit/>
-          </a:bodyPr>
-          <a:lstStyle/>
-          <a:p>
-            <a:pPr>
-              <a:spcAft>
-                <a:spcPts val="400"/>
-              </a:spcAft>
-            </a:pPr>
-            <a:r>
-              <a:rPr sz="1200" b="1">
-                <a:solidFill>
-                  <a:srgbClr val="5E6B75"/>
-                </a:solidFill>
-                <a:latin typeface="Consolas"/>
-              </a:rPr>
-              <a:t>LEARNING</a:t>
-            </a:r>
-          </a:p>
-          <a:p>
-            <a:pPr>
-              <a:spcAft>
-                <a:spcPts val="400"/>
-              </a:spcAft>
-            </a:pPr>
-            <a:r>
-              <a:rPr sz="1600" b="0">
-                <a:solidFill>
-                  <a:srgbClr val="16222B"/>
-                </a:solidFill>
-                <a:latin typeface="Calibri"/>
-              </a:rPr>
-              <a:t>•  Learning rate 1e-5, constant</a:t>
-            </a:r>
-          </a:p>
-          <a:p>
-            <a:pPr>
-              <a:spcAft>
-                <a:spcPts val="400"/>
-              </a:spcAft>
-            </a:pPr>
-            <a:r>
-              <a:rPr sz="1600" b="0">
-                <a:solidFill>
-                  <a:srgbClr val="16222B"/>
-                </a:solidFill>
-                <a:latin typeface="Calibri"/>
-              </a:rPr>
-              <a:t>•  KL penalty beta 0.3, per-token estimator</a:t>
-            </a:r>
-          </a:p>
-          <a:p>
-            <a:pPr>
-              <a:spcAft>
-                <a:spcPts val="400"/>
-              </a:spcAft>
-            </a:pPr>
-            <a:r>
-              <a:rPr sz="1600" b="0">
-                <a:solidFill>
-                  <a:srgbClr val="16222B"/>
-                </a:solidFill>
-                <a:latin typeface="Calibri"/>
-              </a:rPr>
-              <a:t>•  Clip range 0.2; gradient clip 1.0</a:t>
-            </a:r>
-          </a:p>
-          <a:p>
-            <a:pPr>
-              <a:spcAft>
-                <a:spcPts val="400"/>
-              </a:spcAft>
-            </a:pPr>
-            <a:r>
-              <a:rPr sz="1600" b="0">
-                <a:solidFill>
-                  <a:srgbClr val="16222B"/>
-                </a:solidFill>
-                <a:latin typeface="Calibri"/>
-              </a:rPr>
-              <a:t>•  Log-probability summed over the answer</a:t>
-            </a:r>
-          </a:p>
-          <a:p>
-            <a:pPr>
-              <a:spcAft>
-                <a:spcPts val="400"/>
-              </a:spcAft>
-            </a:pPr>
-            <a:r>
-              <a:rPr sz="1600" b="0">
-                <a:solidFill>
-                  <a:srgbClr val="16222B"/>
-                </a:solidFill>
-                <a:latin typeface="Calibri"/>
-              </a:rPr>
-              <a:t>•  Full parameters, not an adapter</a:t>
-            </a:r>
-          </a:p>
-        </p:txBody>
-      </p:sp>
-      <p:sp>
-        <p:nvSpPr>
-          <p:cNvPr id="7" name="Rounded Rectangle 6"/>
-          <p:cNvSpPr/>
-          <p:nvPr/>
-        </p:nvSpPr>
-        <p:spPr>
-          <a:xfrm>
-            <a:off x="4414418" y="1691640"/>
-            <a:ext cx="3362858" cy="4343400"/>
-          </a:xfrm>
-          <a:prstGeom prst="roundRect">
-            <a:avLst>
-              <a:gd name="adj" fmla="val 4000"/>
-            </a:avLst>
-          </a:prstGeom>
-          <a:solidFill>
-            <a:srgbClr val="FBFCFC"/>
-          </a:solidFill>
-          <a:ln w="9525">
-            <a:solidFill>
-              <a:srgbClr val="D2D9DD"/>
-            </a:solidFill>
-          </a:ln>
-          <a:effectLst/>
-        </p:spPr>
-        <p:style>
-          <a:lnRef idx="1">
-            <a:schemeClr val="accent1"/>
-          </a:lnRef>
-          <a:fillRef idx="3">
-            <a:schemeClr val="accent1"/>
-          </a:fillRef>
-          <a:effectRef idx="2">
-            <a:schemeClr val="accent1"/>
-          </a:effectRef>
-          <a:fontRef idx="minor">
-            <a:schemeClr val="lt1"/>
-          </a:fontRef>
-        </p:style>
-        <p:txBody>
-          <a:bodyPr rtlCol="0" anchor="ctr"/>
-          <a:lstStyle/>
-          <a:p>
-            <a:pPr algn="ctr"/>
-          </a:p>
-        </p:txBody>
-      </p:sp>
-      <p:sp>
-        <p:nvSpPr>
-          <p:cNvPr id="8" name="TextBox 7"/>
-          <p:cNvSpPr txBox="1"/>
-          <p:nvPr/>
-        </p:nvSpPr>
-        <p:spPr>
-          <a:xfrm>
-            <a:off x="4597298" y="1837944"/>
-            <a:ext cx="2997098" cy="4069080"/>
-          </a:xfrm>
-          <a:prstGeom prst="rect">
-            <a:avLst/>
-          </a:prstGeom>
-          <a:noFill/>
-        </p:spPr>
-        <p:txBody>
-          <a:bodyPr wrap="square" lIns="0" rIns="0" tIns="0" bIns="0" anchor="t">
-            <a:spAutoFit/>
-          </a:bodyPr>
-          <a:lstStyle/>
-          <a:p>
-            <a:pPr>
-              <a:spcAft>
-                <a:spcPts val="400"/>
-              </a:spcAft>
-            </a:pPr>
-            <a:r>
-              <a:rPr sz="1200" b="1">
-                <a:solidFill>
-                  <a:srgbClr val="5E6B75"/>
-                </a:solidFill>
-                <a:latin typeface="Consolas"/>
-              </a:rPr>
-              <a:t>GENERATION</a:t>
-            </a:r>
-          </a:p>
-          <a:p>
-            <a:pPr>
-              <a:spcAft>
-                <a:spcPts val="400"/>
-              </a:spcAft>
-            </a:pPr>
-            <a:r>
-              <a:rPr sz="1600" b="0">
-                <a:solidFill>
-                  <a:srgbClr val="16222B"/>
-                </a:solidFill>
-                <a:latin typeface="Calibri"/>
-              </a:rPr>
-              <a:t>•  4 answers per record</a:t>
-            </a:r>
-          </a:p>
-          <a:p>
-            <a:pPr>
-              <a:spcAft>
-                <a:spcPts val="400"/>
-              </a:spcAft>
-            </a:pPr>
-            <a:r>
-              <a:rPr sz="1600" b="0">
-                <a:solidFill>
-                  <a:srgbClr val="16222B"/>
-                </a:solidFill>
-                <a:latin typeface="Calibri"/>
-              </a:rPr>
-              <a:t>•  Temperature 0.9, top-p 0.9 for rollouts</a:t>
-            </a:r>
-          </a:p>
-          <a:p>
-            <a:pPr>
-              <a:spcAft>
-                <a:spcPts val="400"/>
-              </a:spcAft>
-            </a:pPr>
-            <a:r>
-              <a:rPr sz="1600" b="0">
-                <a:solidFill>
-                  <a:srgbClr val="16222B"/>
-                </a:solidFill>
-                <a:latin typeface="Calibri"/>
-              </a:rPr>
-              <a:t>•  Eval is greedy; thinking switched off</a:t>
-            </a:r>
-          </a:p>
-          <a:p>
-            <a:pPr>
-              <a:spcAft>
-                <a:spcPts val="400"/>
-              </a:spcAft>
-            </a:pPr>
-            <a:r>
-              <a:rPr sz="1600" b="0">
-                <a:solidFill>
-                  <a:srgbClr val="16222B"/>
-                </a:solidFill>
-                <a:latin typeface="Calibri"/>
-              </a:rPr>
-              <a:t>•  Prompt up to 288 tokens, answer up to 160</a:t>
-            </a:r>
-          </a:p>
-          <a:p>
-            <a:pPr>
-              <a:spcAft>
-                <a:spcPts val="400"/>
-              </a:spcAft>
-            </a:pPr>
-            <a:r>
-              <a:rPr sz="1600" b="0">
-                <a:solidFill>
-                  <a:srgbClr val="16222B"/>
-                </a:solidFill>
-                <a:latin typeface="Calibri"/>
-              </a:rPr>
-              <a:t>•  Seed 7</a:t>
-            </a:r>
-          </a:p>
-        </p:txBody>
-      </p:sp>
-      <p:sp>
-        <p:nvSpPr>
-          <p:cNvPr id="9" name="Rounded Rectangle 8"/>
-          <p:cNvSpPr/>
-          <p:nvPr/>
-        </p:nvSpPr>
-        <p:spPr>
-          <a:xfrm>
-            <a:off x="8005876" y="1691640"/>
-            <a:ext cx="3362858" cy="4343400"/>
-          </a:xfrm>
-          <a:prstGeom prst="roundRect">
-            <a:avLst>
-              <a:gd name="adj" fmla="val 4000"/>
-            </a:avLst>
-          </a:prstGeom>
-          <a:solidFill>
-            <a:srgbClr val="FBFCFC"/>
-          </a:solidFill>
-          <a:ln w="9525">
-            <a:solidFill>
-              <a:srgbClr val="D2D9DD"/>
-            </a:solidFill>
-          </a:ln>
-          <a:effectLst/>
-        </p:spPr>
-        <p:style>
-          <a:lnRef idx="1">
-            <a:schemeClr val="accent1"/>
-          </a:lnRef>
-          <a:fillRef idx="3">
-            <a:schemeClr val="accent1"/>
-          </a:fillRef>
-          <a:effectRef idx="2">
-            <a:schemeClr val="accent1"/>
-          </a:effectRef>
-          <a:fontRef idx="minor">
-            <a:schemeClr val="lt1"/>
-          </a:fontRef>
-        </p:style>
-        <p:txBody>
-          <a:bodyPr rtlCol="0" anchor="ctr"/>
-          <a:lstStyle/>
-          <a:p>
-            <a:pPr algn="ctr"/>
-          </a:p>
-        </p:txBody>
-      </p:sp>
-      <p:sp>
-        <p:nvSpPr>
-          <p:cNvPr id="10" name="TextBox 9"/>
-          <p:cNvSpPr txBox="1"/>
-          <p:nvPr/>
-        </p:nvSpPr>
-        <p:spPr>
-          <a:xfrm>
-            <a:off x="8188756" y="1837944"/>
-            <a:ext cx="2997098" cy="4069080"/>
-          </a:xfrm>
-          <a:prstGeom prst="rect">
-            <a:avLst/>
-          </a:prstGeom>
-          <a:noFill/>
-        </p:spPr>
-        <p:txBody>
-          <a:bodyPr wrap="square" lIns="0" rIns="0" tIns="0" bIns="0" anchor="t">
-            <a:spAutoFit/>
-          </a:bodyPr>
-          <a:lstStyle/>
-          <a:p>
-            <a:pPr>
-              <a:spcAft>
-                <a:spcPts val="400"/>
-              </a:spcAft>
-            </a:pPr>
-            <a:r>
-              <a:rPr sz="1200" b="1">
-                <a:solidFill>
-                  <a:srgbClr val="5E6B75"/>
-                </a:solidFill>
-                <a:latin typeface="Consolas"/>
-              </a:rPr>
-              <a:t>MEMORY AND EVAL</a:t>
-            </a:r>
-          </a:p>
-          <a:p>
-            <a:pPr>
-              <a:spcAft>
-                <a:spcPts val="400"/>
-              </a:spcAft>
-            </a:pPr>
-            <a:r>
-              <a:rPr sz="1600" b="0">
-                <a:solidFill>
-                  <a:srgbClr val="16222B"/>
-                </a:solidFill>
-                <a:latin typeface="Calibri"/>
-              </a:rPr>
-              <a:t>•  Optimizer state can live on the CPU</a:t>
-            </a:r>
-          </a:p>
-          <a:p>
-            <a:pPr>
-              <a:spcAft>
-                <a:spcPts val="400"/>
-              </a:spcAft>
-            </a:pPr>
-            <a:r>
-              <a:rPr sz="1600" b="0">
-                <a:solidFill>
-                  <a:srgbClr val="16222B"/>
-                </a:solidFill>
-                <a:latin typeface="Calibri"/>
-              </a:rPr>
-              <a:t>•  Reference model can be offloaded</a:t>
-            </a:r>
-          </a:p>
-          <a:p>
-            <a:pPr>
-              <a:spcAft>
-                <a:spcPts val="400"/>
-              </a:spcAft>
-            </a:pPr>
-            <a:r>
-              <a:rPr sz="1600" b="0">
-                <a:solidFill>
-                  <a:srgbClr val="16222B"/>
-                </a:solidFill>
-                <a:latin typeface="Calibri"/>
-              </a:rPr>
-              <a:t>•  Judge on a remote small GPU</a:t>
-            </a:r>
-          </a:p>
-          <a:p>
-            <a:pPr>
-              <a:spcAft>
-                <a:spcPts val="400"/>
-              </a:spcAft>
-            </a:pPr>
-            <a:r>
-              <a:rPr sz="1600" b="0">
-                <a:solidFill>
-                  <a:srgbClr val="16222B"/>
-                </a:solidFill>
-                <a:latin typeface="Calibri"/>
-              </a:rPr>
-              <a:t>•  Eval: 16 questions, 8 answers each</a:t>
-            </a:r>
-          </a:p>
-          <a:p>
-            <a:pPr>
-              <a:spcAft>
-                <a:spcPts val="400"/>
-              </a:spcAft>
-            </a:pPr>
-            <a:r>
-              <a:rPr sz="1600" b="0">
-                <a:solidFill>
-                  <a:srgbClr val="16222B"/>
-                </a:solidFill>
-                <a:latin typeface="Calibri"/>
-              </a:rPr>
-              <a:t>•  Same-seed wobble: about one question</a:t>
-            </a:r>
-          </a:p>
-        </p:txBody>
-      </p:sp>
-    </p:spTree>
-  </p:cSld>
-  <p:clrMapOvr>
-    <a:masterClrMapping/>
-  </p:clrMapOvr>
-</p:sld>
-</file>
-
 <file path=ppt/slides/slide9.xml><?xml version="1.0" encoding="utf-8"?>
 <p:sld xmlns:a="http://schemas.openxmlformats.org/drawingml/2006/main" xmlns:p="http://schemas.openxmlformats.org/presentationml/2006/main" xmlns:r="http://schemas.openxmlformats.org/officeDocument/2006/relationships">
   <p:cSld>
@@ -24528,7 +25159,7 @@
                 </a:solidFill>
                 <a:latin typeface="Consolas"/>
               </a:rPr>
-              <a:t>GROUNDING</a:t>
+              <a:t>METHOD · SETTINGS</a:t>
             </a:r>
           </a:p>
         </p:txBody>
@@ -24562,7 +25193,7 @@
                 </a:solidFill>
                 <a:latin typeface="Georgia"/>
               </a:rPr>
-              <a:t>RL-theory concepts and where each landed</a:t>
+              <a:t>The RL trainer's default settings</a:t>
             </a:r>
           </a:p>
         </p:txBody>
@@ -24596,650 +25227,512 @@
                 </a:solidFill>
                 <a:latin typeface="Calibri"/>
               </a:rPr>
-              <a:t>Source: docs/INSPIRATIONS.md · dispositions.md · each mapping is an analogy until its entry tests it</a:t>
-            </a:r>
-          </a:p>
-        </p:txBody>
-      </p:sp>
-      <p:graphicFrame>
-        <p:nvGraphicFramePr>
-          <p:cNvPr id="5" name="Table 4"/>
-          <p:cNvGraphicFramePr>
-            <a:graphicFrameLocks noGrp="1"/>
-          </p:cNvGraphicFramePr>
-          <p:nvPr/>
-        </p:nvGraphicFramePr>
-        <p:xfrm>
-          <a:off x="822960" y="1691640"/>
-          <a:ext cx="10545774" cy="3236976"/>
-        </p:xfrm>
-        <a:graphic>
-          <a:graphicData uri="http://schemas.openxmlformats.org/drawingml/2006/table">
-            <a:tbl>
-              <a:tblPr firstRow="1" bandRow="1">
-                <a:tableStyleId>{5C22544A-7EE6-4342-B048-85BDC9FD1C3A}</a:tableStyleId>
-              </a:tblPr>
-              <a:tblGrid>
-                <a:gridCol w="4007394"/>
-                <a:gridCol w="3796479"/>
-                <a:gridCol w="2741901"/>
-              </a:tblGrid>
-              <a:tr h="359664">
-                <a:tc>
-                  <a:txBody>
-                    <a:bodyPr wrap="square"/>
-                    <a:lstStyle/>
-                    <a:p>
-                      <a:r>
-                        <a:rPr sz="1400" b="1">
-                          <a:solidFill>
-                            <a:srgbClr val="16222B"/>
-                          </a:solidFill>
-                          <a:latin typeface="Calibri"/>
-                        </a:rPr>
-                        <a:t>RL-theory concept</a:t>
-                      </a:r>
-                    </a:p>
-                  </a:txBody>
-                  <a:tcPr marL="91440" marR="91440" marT="45720" marB="45720" anchor="ctr">
-                    <a:solidFill>
-                      <a:srgbClr val="D2D9DD"/>
-                    </a:solidFill>
-                  </a:tcPr>
-                </a:tc>
-                <a:tc>
-                  <a:txBody>
-                    <a:bodyPr wrap="square"/>
-                    <a:lstStyle/>
-                    <a:p>
-                      <a:r>
-                        <a:rPr sz="1400" b="1">
-                          <a:solidFill>
-                            <a:srgbClr val="16222B"/>
-                          </a:solidFill>
-                          <a:latin typeface="Calibri"/>
-                        </a:rPr>
-                        <a:t>What I built</a:t>
-                      </a:r>
-                    </a:p>
-                  </a:txBody>
-                  <a:tcPr marL="91440" marR="91440" marT="45720" marB="45720" anchor="ctr">
-                    <a:solidFill>
-                      <a:srgbClr val="D2D9DD"/>
-                    </a:solidFill>
-                  </a:tcPr>
-                </a:tc>
-                <a:tc>
-                  <a:txBody>
-                    <a:bodyPr wrap="square"/>
-                    <a:lstStyle/>
-                    <a:p>
-                      <a:r>
-                        <a:rPr sz="1400" b="1">
-                          <a:solidFill>
-                            <a:srgbClr val="16222B"/>
-                          </a:solidFill>
-                          <a:latin typeface="Calibri"/>
-                        </a:rPr>
-                        <a:t>Where it landed</a:t>
-                      </a:r>
-                    </a:p>
-                  </a:txBody>
-                  <a:tcPr marL="91440" marR="91440" marT="45720" marB="45720" anchor="ctr">
-                    <a:solidFill>
-                      <a:srgbClr val="D2D9DD"/>
-                    </a:solidFill>
-                  </a:tcPr>
-                </a:tc>
-              </a:tr>
-              <a:tr h="359664">
-                <a:tc>
-                  <a:txBody>
-                    <a:bodyPr wrap="square"/>
-                    <a:lstStyle/>
-                    <a:p>
-                      <a:r>
-                        <a:rPr sz="1400" b="0">
-                          <a:solidFill>
-                            <a:srgbClr val="16222B"/>
-                          </a:solidFill>
-                          <a:latin typeface="Calibri"/>
-                        </a:rPr>
-                        <a:t>Policy gradient without a critic</a:t>
-                      </a:r>
-                    </a:p>
-                  </a:txBody>
-                  <a:tcPr marL="91440" marR="91440" marT="45720" marB="45720" anchor="ctr">
-                    <a:solidFill>
-                      <a:srgbClr val="FBFCFC"/>
-                    </a:solidFill>
-                  </a:tcPr>
-                </a:tc>
-                <a:tc>
-                  <a:txBody>
-                    <a:bodyPr wrap="square"/>
-                    <a:lstStyle/>
-                    <a:p>
-                      <a:r>
-                        <a:rPr sz="1400" b="0">
-                          <a:solidFill>
-                            <a:srgbClr val="16222B"/>
-                          </a:solidFill>
-                          <a:latin typeface="Calibri"/>
-                        </a:rPr>
-                        <a:t>GRPO: group of 4, minus the mean</a:t>
-                      </a:r>
-                    </a:p>
-                  </a:txBody>
-                  <a:tcPr marL="91440" marR="91440" marT="45720" marB="45720" anchor="ctr">
-                    <a:solidFill>
-                      <a:srgbClr val="FBFCFC"/>
-                    </a:solidFill>
-                  </a:tcPr>
-                </a:tc>
-                <a:tc>
-                  <a:txBody>
-                    <a:bodyPr wrap="square"/>
-                    <a:lstStyle/>
-                    <a:p>
-                      <a:r>
-                        <a:rPr sz="1400" b="0">
-                          <a:solidFill>
-                            <a:srgbClr val="1F5FA8"/>
-                          </a:solidFill>
-                          <a:latin typeface="Calibri"/>
-                        </a:rPr>
-                        <a:t>core of every run</a:t>
-                      </a:r>
-                    </a:p>
-                  </a:txBody>
-                  <a:tcPr marL="91440" marR="91440" marT="45720" marB="45720" anchor="ctr">
-                    <a:solidFill>
-                      <a:srgbClr val="FBFCFC"/>
-                    </a:solidFill>
-                  </a:tcPr>
-                </a:tc>
-              </a:tr>
-              <a:tr h="359664">
-                <a:tc>
-                  <a:txBody>
-                    <a:bodyPr wrap="square"/>
-                    <a:lstStyle/>
-                    <a:p>
-                      <a:r>
-                        <a:rPr sz="1400" b="0">
-                          <a:solidFill>
-                            <a:srgbClr val="16222B"/>
-                          </a:solidFill>
-                          <a:latin typeface="Calibri"/>
-                        </a:rPr>
-                        <a:t>Boltzmann exploration, optimistic start</a:t>
-                      </a:r>
-                    </a:p>
-                  </a:txBody>
-                  <a:tcPr marL="91440" marR="91440" marT="45720" marB="45720" anchor="ctr">
-                    <a:solidFill>
-                      <a:srgbClr val="FBFCFC"/>
-                    </a:solidFill>
-                  </a:tcPr>
-                </a:tc>
-                <a:tc>
-                  <a:txBody>
-                    <a:bodyPr wrap="square"/>
-                    <a:lstStyle/>
-                    <a:p>
-                      <a:r>
-                        <a:rPr sz="1400" b="0">
-                          <a:solidFill>
-                            <a:srgbClr val="16222B"/>
-                          </a:solidFill>
-                          <a:latin typeface="Calibri"/>
-                        </a:rPr>
-                        <a:t>Draw by uncertainty; unseen first</a:t>
-                      </a:r>
-                    </a:p>
-                  </a:txBody>
-                  <a:tcPr marL="91440" marR="91440" marT="45720" marB="45720" anchor="ctr">
-                    <a:solidFill>
-                      <a:srgbClr val="FBFCFC"/>
-                    </a:solidFill>
-                  </a:tcPr>
-                </a:tc>
-                <a:tc>
-                  <a:txBody>
-                    <a:bodyPr wrap="square"/>
-                    <a:lstStyle/>
-                    <a:p>
-                      <a:r>
-                        <a:rPr sz="1400" b="0">
-                          <a:solidFill>
-                            <a:srgbClr val="1F5FA8"/>
-                          </a:solidFill>
-                          <a:latin typeface="Calibri"/>
-                        </a:rPr>
-                        <a:t>kept (entry 8)</a:t>
-                      </a:r>
-                    </a:p>
-                  </a:txBody>
-                  <a:tcPr marL="91440" marR="91440" marT="45720" marB="45720" anchor="ctr">
-                    <a:solidFill>
-                      <a:srgbClr val="FBFCFC"/>
-                    </a:solidFill>
-                  </a:tcPr>
-                </a:tc>
-              </a:tr>
-              <a:tr h="359664">
-                <a:tc>
-                  <a:txBody>
-                    <a:bodyPr wrap="square"/>
-                    <a:lstStyle/>
-                    <a:p>
-                      <a:r>
-                        <a:rPr sz="1400" b="0">
-                          <a:solidFill>
-                            <a:srgbClr val="16222B"/>
-                          </a:solidFill>
-                          <a:latin typeface="Calibri"/>
-                        </a:rPr>
-                        <a:t>Replay buffer: decorrelate and reuse</a:t>
-                      </a:r>
-                    </a:p>
-                  </a:txBody>
-                  <a:tcPr marL="91440" marR="91440" marT="45720" marB="45720" anchor="ctr">
-                    <a:solidFill>
-                      <a:srgbClr val="FBFCFC"/>
-                    </a:solidFill>
-                  </a:tcPr>
-                </a:tc>
-                <a:tc>
-                  <a:txBody>
-                    <a:bodyPr wrap="square"/>
-                    <a:lstStyle/>
-                    <a:p>
-                      <a:r>
-                        <a:rPr sz="1400" b="0">
-                          <a:solidFill>
-                            <a:srgbClr val="16222B"/>
-                          </a:solidFill>
-                          <a:latin typeface="Calibri"/>
-                        </a:rPr>
-                        <a:t>Flashcard priority; reuse of answers</a:t>
-                      </a:r>
-                    </a:p>
-                  </a:txBody>
-                  <a:tcPr marL="91440" marR="91440" marT="45720" marB="45720" anchor="ctr">
-                    <a:solidFill>
-                      <a:srgbClr val="FBFCFC"/>
-                    </a:solidFill>
-                  </a:tcPr>
-                </a:tc>
-                <a:tc>
-                  <a:txBody>
-                    <a:bodyPr wrap="square"/>
-                    <a:lstStyle/>
-                    <a:p>
-                      <a:r>
-                        <a:rPr sz="1400" b="0">
-                          <a:solidFill>
-                            <a:srgbClr val="B94E08"/>
-                          </a:solidFill>
-                          <a:latin typeface="Calibri"/>
-                        </a:rPr>
-                        <a:t>lost (entry 9)</a:t>
-                      </a:r>
-                    </a:p>
-                  </a:txBody>
-                  <a:tcPr marL="91440" marR="91440" marT="45720" marB="45720" anchor="ctr">
-                    <a:solidFill>
-                      <a:srgbClr val="FBFCFC"/>
-                    </a:solidFill>
-                  </a:tcPr>
-                </a:tc>
-              </a:tr>
-              <a:tr h="359664">
-                <a:tc>
-                  <a:txBody>
-                    <a:bodyPr wrap="square"/>
-                    <a:lstStyle/>
-                    <a:p>
-                      <a:r>
-                        <a:rPr sz="1400" b="0">
-                          <a:solidFill>
-                            <a:srgbClr val="16222B"/>
-                          </a:solidFill>
-                          <a:latin typeface="Calibri"/>
-                        </a:rPr>
-                        <a:t>Target network: a slow, stable target</a:t>
-                      </a:r>
-                    </a:p>
-                  </a:txBody>
-                  <a:tcPr marL="91440" marR="91440" marT="45720" marB="45720" anchor="ctr">
-                    <a:solidFill>
-                      <a:srgbClr val="FBFCFC"/>
-                    </a:solidFill>
-                  </a:tcPr>
-                </a:tc>
-                <a:tc>
-                  <a:txBody>
-                    <a:bodyPr wrap="square"/>
-                    <a:lstStyle/>
-                    <a:p>
-                      <a:r>
-                        <a:rPr sz="1400" b="0">
-                          <a:solidFill>
-                            <a:srgbClr val="16222B"/>
-                          </a:solidFill>
-                          <a:latin typeface="Calibri"/>
-                        </a:rPr>
-                        <a:t>KL anchor to the SFT checkpoint</a:t>
-                      </a:r>
-                    </a:p>
-                  </a:txBody>
-                  <a:tcPr marL="91440" marR="91440" marT="45720" marB="45720" anchor="ctr">
-                    <a:solidFill>
-                      <a:srgbClr val="FBFCFC"/>
-                    </a:solidFill>
-                  </a:tcPr>
-                </a:tc>
-                <a:tc>
-                  <a:txBody>
-                    <a:bodyPr wrap="square"/>
-                    <a:lstStyle/>
-                    <a:p>
-                      <a:r>
-                        <a:rPr sz="1400" b="0">
-                          <a:solidFill>
-                            <a:srgbClr val="1F5FA8"/>
-                          </a:solidFill>
-                          <a:latin typeface="Calibri"/>
-                        </a:rPr>
-                        <a:t>a leash (entry 6)</a:t>
-                      </a:r>
-                    </a:p>
-                  </a:txBody>
-                  <a:tcPr marL="91440" marR="91440" marT="45720" marB="45720" anchor="ctr">
-                    <a:solidFill>
-                      <a:srgbClr val="FBFCFC"/>
-                    </a:solidFill>
-                  </a:tcPr>
-                </a:tc>
-              </a:tr>
-              <a:tr h="359664">
-                <a:tc>
-                  <a:txBody>
-                    <a:bodyPr wrap="square"/>
-                    <a:lstStyle/>
-                    <a:p>
-                      <a:r>
-                        <a:rPr sz="1400" b="0">
-                          <a:solidFill>
-                            <a:srgbClr val="16222B"/>
-                          </a:solidFill>
-                          <a:latin typeface="Calibri"/>
-                        </a:rPr>
-                        <a:t>Deadly triad: off-policy + approximation</a:t>
-                      </a:r>
-                    </a:p>
-                  </a:txBody>
-                  <a:tcPr marL="91440" marR="91440" marT="45720" marB="45720" anchor="ctr">
-                    <a:solidFill>
-                      <a:srgbClr val="FBFCFC"/>
-                    </a:solidFill>
-                  </a:tcPr>
-                </a:tc>
-                <a:tc>
-                  <a:txBody>
-                    <a:bodyPr wrap="square"/>
-                    <a:lstStyle/>
-                    <a:p>
-                      <a:r>
-                        <a:rPr sz="1400" b="0">
-                          <a:solidFill>
-                            <a:srgbClr val="16222B"/>
-                          </a:solidFill>
-                          <a:latin typeface="Calibri"/>
-                        </a:rPr>
-                        <a:t>Stale replayed answers, 0.8B network</a:t>
-                      </a:r>
-                    </a:p>
-                  </a:txBody>
-                  <a:tcPr marL="91440" marR="91440" marT="45720" marB="45720" anchor="ctr">
-                    <a:solidFill>
-                      <a:srgbClr val="FBFCFC"/>
-                    </a:solidFill>
-                  </a:tcPr>
-                </a:tc>
-                <a:tc>
-                  <a:txBody>
-                    <a:bodyPr wrap="square"/>
-                    <a:lstStyle/>
-                    <a:p>
-                      <a:r>
-                        <a:rPr sz="1400" b="0">
-                          <a:solidFill>
-                            <a:srgbClr val="B94E08"/>
-                          </a:solidFill>
-                          <a:latin typeface="Calibri"/>
-                        </a:rPr>
-                        <a:t>KL runaway (entry 9)</a:t>
-                      </a:r>
-                    </a:p>
-                  </a:txBody>
-                  <a:tcPr marL="91440" marR="91440" marT="45720" marB="45720" anchor="ctr">
-                    <a:solidFill>
-                      <a:srgbClr val="FBFCFC"/>
-                    </a:solidFill>
-                  </a:tcPr>
-                </a:tc>
-              </a:tr>
-              <a:tr h="359664">
-                <a:tc>
-                  <a:txBody>
-                    <a:bodyPr wrap="square"/>
-                    <a:lstStyle/>
-                    <a:p>
-                      <a:r>
-                        <a:rPr sz="1400" b="0">
-                          <a:solidFill>
-                            <a:srgbClr val="16222B"/>
-                          </a:solidFill>
-                          <a:latin typeface="Calibri"/>
-                        </a:rPr>
-                        <a:t>Learned model of the world (Dyna)</a:t>
-                      </a:r>
-                    </a:p>
-                  </a:txBody>
-                  <a:tcPr marL="91440" marR="91440" marT="45720" marB="45720" anchor="ctr">
-                    <a:solidFill>
-                      <a:srgbClr val="FBFCFC"/>
-                    </a:solidFill>
-                  </a:tcPr>
-                </a:tc>
-                <a:tc>
-                  <a:txBody>
-                    <a:bodyPr wrap="square"/>
-                    <a:lstStyle/>
-                    <a:p>
-                      <a:r>
-                        <a:rPr sz="1400" b="0">
-                          <a:solidFill>
-                            <a:srgbClr val="16222B"/>
-                          </a:solidFill>
-                          <a:latin typeface="Calibri"/>
-                        </a:rPr>
-                        <a:t>Ensemble predicting the judge</a:t>
-                      </a:r>
-                    </a:p>
-                  </a:txBody>
-                  <a:tcPr marL="91440" marR="91440" marT="45720" marB="45720" anchor="ctr">
-                    <a:solidFill>
-                      <a:srgbClr val="FBFCFC"/>
-                    </a:solidFill>
-                  </a:tcPr>
-                </a:tc>
-                <a:tc>
-                  <a:txBody>
-                    <a:bodyPr wrap="square"/>
-                    <a:lstStyle/>
-                    <a:p>
-                      <a:r>
-                        <a:rPr sz="1400" b="0">
-                          <a:solidFill>
-                            <a:srgbClr val="B94E08"/>
-                          </a:solidFill>
-                          <a:latin typeface="Calibri"/>
-                        </a:rPr>
-                        <a:t>falsified (entry 10)</a:t>
-                      </a:r>
-                    </a:p>
-                  </a:txBody>
-                  <a:tcPr marL="91440" marR="91440" marT="45720" marB="45720" anchor="ctr">
-                    <a:solidFill>
-                      <a:srgbClr val="FBFCFC"/>
-                    </a:solidFill>
-                  </a:tcPr>
-                </a:tc>
-              </a:tr>
-              <a:tr h="359664">
-                <a:tc>
-                  <a:txBody>
-                    <a:bodyPr wrap="square"/>
-                    <a:lstStyle/>
-                    <a:p>
-                      <a:r>
-                        <a:rPr sz="1400" b="0">
-                          <a:solidFill>
-                            <a:srgbClr val="16222B"/>
-                          </a:solidFill>
-                          <a:latin typeface="Calibri"/>
-                        </a:rPr>
-                        <a:t>Reward modeling</a:t>
-                      </a:r>
-                    </a:p>
-                  </a:txBody>
-                  <a:tcPr marL="91440" marR="91440" marT="45720" marB="45720" anchor="ctr">
-                    <a:solidFill>
-                      <a:srgbClr val="FBFCFC"/>
-                    </a:solidFill>
-                  </a:tcPr>
-                </a:tc>
-                <a:tc>
-                  <a:txBody>
-                    <a:bodyPr wrap="square"/>
-                    <a:lstStyle/>
-                    <a:p>
-                      <a:r>
-                        <a:rPr sz="1400" b="0">
-                          <a:solidFill>
-                            <a:srgbClr val="16222B"/>
-                          </a:solidFill>
-                          <a:latin typeface="Calibri"/>
-                        </a:rPr>
-                        <a:t>Jev, a small yes/no judge</a:t>
-                      </a:r>
-                    </a:p>
-                  </a:txBody>
-                  <a:tcPr marL="91440" marR="91440" marT="45720" marB="45720" anchor="ctr">
-                    <a:solidFill>
-                      <a:srgbClr val="FBFCFC"/>
-                    </a:solidFill>
-                  </a:tcPr>
-                </a:tc>
-                <a:tc>
-                  <a:txBody>
-                    <a:bodyPr wrap="square"/>
-                    <a:lstStyle/>
-                    <a:p>
-                      <a:r>
-                        <a:rPr sz="1400" b="0">
-                          <a:solidFill>
-                            <a:srgbClr val="B94E08"/>
-                          </a:solidFill>
-                          <a:latin typeface="Calibri"/>
-                        </a:rPr>
-                        <a:t>needs a guard (entry 11)</a:t>
-                      </a:r>
-                    </a:p>
-                  </a:txBody>
-                  <a:tcPr marL="91440" marR="91440" marT="45720" marB="45720" anchor="ctr">
-                    <a:solidFill>
-                      <a:srgbClr val="FBFCFC"/>
-                    </a:solidFill>
-                  </a:tcPr>
-                </a:tc>
-              </a:tr>
-              <a:tr h="359664">
-                <a:tc>
-                  <a:txBody>
-                    <a:bodyPr wrap="square"/>
-                    <a:lstStyle/>
-                    <a:p>
-                      <a:r>
-                        <a:rPr sz="1400" b="0">
-                          <a:solidFill>
-                            <a:srgbClr val="16222B"/>
-                          </a:solidFill>
-                          <a:latin typeface="Calibri"/>
-                        </a:rPr>
-                        <a:t>Reward shaping</a:t>
-                      </a:r>
-                    </a:p>
-                  </a:txBody>
-                  <a:tcPr marL="91440" marR="91440" marT="45720" marB="45720" anchor="ctr">
-                    <a:solidFill>
-                      <a:srgbClr val="FBFCFC"/>
-                    </a:solidFill>
-                  </a:tcPr>
-                </a:tc>
-                <a:tc>
-                  <a:txBody>
-                    <a:bodyPr wrap="square"/>
-                    <a:lstStyle/>
-                    <a:p>
-                      <a:r>
-                        <a:rPr sz="1400" b="0">
-                          <a:solidFill>
-                            <a:srgbClr val="16222B"/>
-                          </a:solidFill>
-                          <a:latin typeface="Calibri"/>
-                        </a:rPr>
-                        <a:t>Bands gated by correctness</a:t>
-                      </a:r>
-                    </a:p>
-                  </a:txBody>
-                  <a:tcPr marL="91440" marR="91440" marT="45720" marB="45720" anchor="ctr">
-                    <a:solidFill>
-                      <a:srgbClr val="FBFCFC"/>
-                    </a:solidFill>
-                  </a:tcPr>
-                </a:tc>
-                <a:tc>
-                  <a:txBody>
-                    <a:bodyPr wrap="square"/>
-                    <a:lstStyle/>
-                    <a:p>
-                      <a:r>
-                        <a:rPr sz="1400" b="0">
-                          <a:solidFill>
-                            <a:srgbClr val="B94E08"/>
-                          </a:solidFill>
-                          <a:latin typeface="Calibri"/>
-                        </a:rPr>
-                        <a:t>87% paid zero (entry 5)</a:t>
-                      </a:r>
-                    </a:p>
-                  </a:txBody>
-                  <a:tcPr marL="91440" marR="91440" marT="45720" marB="45720" anchor="ctr">
-                    <a:solidFill>
-                      <a:srgbClr val="FBFCFC"/>
-                    </a:solidFill>
-                  </a:tcPr>
-                </a:tc>
-              </a:tr>
-            </a:tbl>
-          </a:graphicData>
-        </a:graphic>
-      </p:graphicFrame>
+              <a:t>Source: docs/grpo_one_file.py DEFAULTS and argument list · dispositions.md · each run's launcher holds its own overrides</a:t>
+            </a:r>
+          </a:p>
+        </p:txBody>
+      </p:sp>
+      <p:sp>
+        <p:nvSpPr>
+          <p:cNvPr id="5" name="Rounded Rectangle 4"/>
+          <p:cNvSpPr/>
+          <p:nvPr/>
+        </p:nvSpPr>
+        <p:spPr>
+          <a:xfrm>
+            <a:off x="822960" y="1691640"/>
+            <a:ext cx="3362858" cy="4343400"/>
+          </a:xfrm>
+          <a:prstGeom prst="roundRect">
+            <a:avLst>
+              <a:gd name="adj" fmla="val 4000"/>
+            </a:avLst>
+          </a:prstGeom>
+          <a:solidFill>
+            <a:srgbClr val="FBFCFC"/>
+          </a:solidFill>
+          <a:ln w="9525">
+            <a:solidFill>
+              <a:srgbClr val="D2D9DD"/>
+            </a:solidFill>
+          </a:ln>
+          <a:effectLst/>
+        </p:spPr>
+        <p:style>
+          <a:lnRef idx="1">
+            <a:schemeClr val="accent1"/>
+          </a:lnRef>
+          <a:fillRef idx="3">
+            <a:schemeClr val="accent1"/>
+          </a:fillRef>
+          <a:effectRef idx="2">
+            <a:schemeClr val="accent1"/>
+          </a:effectRef>
+          <a:fontRef idx="minor">
+            <a:schemeClr val="lt1"/>
+          </a:fontRef>
+        </p:style>
+        <p:txBody>
+          <a:bodyPr rtlCol="0" anchor="ctr"/>
+          <a:lstStyle/>
+          <a:p>
+            <a:pPr algn="ctr"/>
+          </a:p>
+        </p:txBody>
+      </p:sp>
+      <p:sp>
+        <p:nvSpPr>
+          <p:cNvPr id="6" name="TextBox 5"/>
+          <p:cNvSpPr txBox="1"/>
+          <p:nvPr/>
+        </p:nvSpPr>
+        <p:spPr>
+          <a:xfrm>
+            <a:off x="1005840" y="1837944"/>
+            <a:ext cx="2997098" cy="4069080"/>
+          </a:xfrm>
+          <a:prstGeom prst="rect">
+            <a:avLst/>
+          </a:prstGeom>
+          <a:noFill/>
+        </p:spPr>
+        <p:txBody>
+          <a:bodyPr wrap="square" lIns="0" rIns="0" tIns="0" bIns="0" anchor="t">
+            <a:spAutoFit/>
+          </a:bodyPr>
+          <a:lstStyle/>
+          <a:p>
+            <a:pPr>
+              <a:spcAft>
+                <a:spcPts val="400"/>
+              </a:spcAft>
+            </a:pPr>
+            <a:r>
+              <a:rPr sz="1200" b="1">
+                <a:solidFill>
+                  <a:srgbClr val="5E6B75"/>
+                </a:solidFill>
+                <a:latin typeface="Consolas"/>
+              </a:rPr>
+              <a:t>LEARNING</a:t>
+            </a:r>
+          </a:p>
+          <a:p>
+            <a:pPr>
+              <a:spcAft>
+                <a:spcPts val="400"/>
+              </a:spcAft>
+            </a:pPr>
+            <a:r>
+              <a:rPr sz="1600" b="0">
+                <a:solidFill>
+                  <a:srgbClr val="16222B"/>
+                </a:solidFill>
+                <a:latin typeface="Calibri"/>
+              </a:rPr>
+              <a:t>•  Learning rate 1e-5, constant</a:t>
+            </a:r>
+          </a:p>
+          <a:p>
+            <a:pPr>
+              <a:spcAft>
+                <a:spcPts val="400"/>
+              </a:spcAft>
+            </a:pPr>
+            <a:r>
+              <a:rPr sz="1600" b="0">
+                <a:solidFill>
+                  <a:srgbClr val="16222B"/>
+                </a:solidFill>
+                <a:latin typeface="Calibri"/>
+              </a:rPr>
+              <a:t>•  KL penalty beta 0.3, per-token estimator</a:t>
+            </a:r>
+          </a:p>
+          <a:p>
+            <a:pPr>
+              <a:spcAft>
+                <a:spcPts val="400"/>
+              </a:spcAft>
+            </a:pPr>
+            <a:r>
+              <a:rPr sz="1600" b="0">
+                <a:solidFill>
+                  <a:srgbClr val="16222B"/>
+                </a:solidFill>
+                <a:latin typeface="Calibri"/>
+              </a:rPr>
+              <a:t>•  Clip range 0.2; gradient clip 1.0</a:t>
+            </a:r>
+          </a:p>
+          <a:p>
+            <a:pPr>
+              <a:spcAft>
+                <a:spcPts val="400"/>
+              </a:spcAft>
+            </a:pPr>
+            <a:r>
+              <a:rPr sz="1600" b="0">
+                <a:solidFill>
+                  <a:srgbClr val="16222B"/>
+                </a:solidFill>
+                <a:latin typeface="Calibri"/>
+              </a:rPr>
+              <a:t>•  Log-probability summed over the answer</a:t>
+            </a:r>
+          </a:p>
+          <a:p>
+            <a:pPr>
+              <a:spcAft>
+                <a:spcPts val="400"/>
+              </a:spcAft>
+            </a:pPr>
+            <a:r>
+              <a:rPr sz="1600" b="0">
+                <a:solidFill>
+                  <a:srgbClr val="16222B"/>
+                </a:solidFill>
+                <a:latin typeface="Calibri"/>
+              </a:rPr>
+              <a:t>•  Full parameters, not an adapter</a:t>
+            </a:r>
+          </a:p>
+        </p:txBody>
+      </p:sp>
+      <p:sp>
+        <p:nvSpPr>
+          <p:cNvPr id="7" name="Rounded Rectangle 6"/>
+          <p:cNvSpPr/>
+          <p:nvPr/>
+        </p:nvSpPr>
+        <p:spPr>
+          <a:xfrm>
+            <a:off x="4414418" y="1691640"/>
+            <a:ext cx="3362858" cy="4343400"/>
+          </a:xfrm>
+          <a:prstGeom prst="roundRect">
+            <a:avLst>
+              <a:gd name="adj" fmla="val 4000"/>
+            </a:avLst>
+          </a:prstGeom>
+          <a:solidFill>
+            <a:srgbClr val="FBFCFC"/>
+          </a:solidFill>
+          <a:ln w="9525">
+            <a:solidFill>
+              <a:srgbClr val="D2D9DD"/>
+            </a:solidFill>
+          </a:ln>
+          <a:effectLst/>
+        </p:spPr>
+        <p:style>
+          <a:lnRef idx="1">
+            <a:schemeClr val="accent1"/>
+          </a:lnRef>
+          <a:fillRef idx="3">
+            <a:schemeClr val="accent1"/>
+          </a:fillRef>
+          <a:effectRef idx="2">
+            <a:schemeClr val="accent1"/>
+          </a:effectRef>
+          <a:fontRef idx="minor">
+            <a:schemeClr val="lt1"/>
+          </a:fontRef>
+        </p:style>
+        <p:txBody>
+          <a:bodyPr rtlCol="0" anchor="ctr"/>
+          <a:lstStyle/>
+          <a:p>
+            <a:pPr algn="ctr"/>
+          </a:p>
+        </p:txBody>
+      </p:sp>
+      <p:sp>
+        <p:nvSpPr>
+          <p:cNvPr id="8" name="TextBox 7"/>
+          <p:cNvSpPr txBox="1"/>
+          <p:nvPr/>
+        </p:nvSpPr>
+        <p:spPr>
+          <a:xfrm>
+            <a:off x="4597298" y="1837944"/>
+            <a:ext cx="2997098" cy="4069080"/>
+          </a:xfrm>
+          <a:prstGeom prst="rect">
+            <a:avLst/>
+          </a:prstGeom>
+          <a:noFill/>
+        </p:spPr>
+        <p:txBody>
+          <a:bodyPr wrap="square" lIns="0" rIns="0" tIns="0" bIns="0" anchor="t">
+            <a:spAutoFit/>
+          </a:bodyPr>
+          <a:lstStyle/>
+          <a:p>
+            <a:pPr>
+              <a:spcAft>
+                <a:spcPts val="400"/>
+              </a:spcAft>
+            </a:pPr>
+            <a:r>
+              <a:rPr sz="1200" b="1">
+                <a:solidFill>
+                  <a:srgbClr val="5E6B75"/>
+                </a:solidFill>
+                <a:latin typeface="Consolas"/>
+              </a:rPr>
+              <a:t>GENERATION</a:t>
+            </a:r>
+          </a:p>
+          <a:p>
+            <a:pPr>
+              <a:spcAft>
+                <a:spcPts val="400"/>
+              </a:spcAft>
+            </a:pPr>
+            <a:r>
+              <a:rPr sz="1600" b="0">
+                <a:solidFill>
+                  <a:srgbClr val="16222B"/>
+                </a:solidFill>
+                <a:latin typeface="Calibri"/>
+              </a:rPr>
+              <a:t>•  4 answers per record</a:t>
+            </a:r>
+          </a:p>
+          <a:p>
+            <a:pPr>
+              <a:spcAft>
+                <a:spcPts val="400"/>
+              </a:spcAft>
+            </a:pPr>
+            <a:r>
+              <a:rPr sz="1600" b="0">
+                <a:solidFill>
+                  <a:srgbClr val="16222B"/>
+                </a:solidFill>
+                <a:latin typeface="Calibri"/>
+              </a:rPr>
+              <a:t>•  Temperature 0.9, top-p 0.9 for rollouts</a:t>
+            </a:r>
+          </a:p>
+          <a:p>
+            <a:pPr>
+              <a:spcAft>
+                <a:spcPts val="400"/>
+              </a:spcAft>
+            </a:pPr>
+            <a:r>
+              <a:rPr sz="1600" b="0">
+                <a:solidFill>
+                  <a:srgbClr val="16222B"/>
+                </a:solidFill>
+                <a:latin typeface="Calibri"/>
+              </a:rPr>
+              <a:t>•  Eval is greedy; thinking switched off</a:t>
+            </a:r>
+          </a:p>
+          <a:p>
+            <a:pPr>
+              <a:spcAft>
+                <a:spcPts val="400"/>
+              </a:spcAft>
+            </a:pPr>
+            <a:r>
+              <a:rPr sz="1600" b="0">
+                <a:solidFill>
+                  <a:srgbClr val="16222B"/>
+                </a:solidFill>
+                <a:latin typeface="Calibri"/>
+              </a:rPr>
+              <a:t>•  Prompt up to 288 tokens, answer up to 160</a:t>
+            </a:r>
+          </a:p>
+          <a:p>
+            <a:pPr>
+              <a:spcAft>
+                <a:spcPts val="400"/>
+              </a:spcAft>
+            </a:pPr>
+            <a:r>
+              <a:rPr sz="1600" b="0">
+                <a:solidFill>
+                  <a:srgbClr val="16222B"/>
+                </a:solidFill>
+                <a:latin typeface="Calibri"/>
+              </a:rPr>
+              <a:t>•  Seed 7</a:t>
+            </a:r>
+          </a:p>
+        </p:txBody>
+      </p:sp>
+      <p:sp>
+        <p:nvSpPr>
+          <p:cNvPr id="9" name="Rounded Rectangle 8"/>
+          <p:cNvSpPr/>
+          <p:nvPr/>
+        </p:nvSpPr>
+        <p:spPr>
+          <a:xfrm>
+            <a:off x="8005876" y="1691640"/>
+            <a:ext cx="3362858" cy="4343400"/>
+          </a:xfrm>
+          <a:prstGeom prst="roundRect">
+            <a:avLst>
+              <a:gd name="adj" fmla="val 4000"/>
+            </a:avLst>
+          </a:prstGeom>
+          <a:solidFill>
+            <a:srgbClr val="FBFCFC"/>
+          </a:solidFill>
+          <a:ln w="9525">
+            <a:solidFill>
+              <a:srgbClr val="D2D9DD"/>
+            </a:solidFill>
+          </a:ln>
+          <a:effectLst/>
+        </p:spPr>
+        <p:style>
+          <a:lnRef idx="1">
+            <a:schemeClr val="accent1"/>
+          </a:lnRef>
+          <a:fillRef idx="3">
+            <a:schemeClr val="accent1"/>
+          </a:fillRef>
+          <a:effectRef idx="2">
+            <a:schemeClr val="accent1"/>
+          </a:effectRef>
+          <a:fontRef idx="minor">
+            <a:schemeClr val="lt1"/>
+          </a:fontRef>
+        </p:style>
+        <p:txBody>
+          <a:bodyPr rtlCol="0" anchor="ctr"/>
+          <a:lstStyle/>
+          <a:p>
+            <a:pPr algn="ctr"/>
+          </a:p>
+        </p:txBody>
+      </p:sp>
+      <p:sp>
+        <p:nvSpPr>
+          <p:cNvPr id="10" name="TextBox 9"/>
+          <p:cNvSpPr txBox="1"/>
+          <p:nvPr/>
+        </p:nvSpPr>
+        <p:spPr>
+          <a:xfrm>
+            <a:off x="8188756" y="1837944"/>
+            <a:ext cx="2997098" cy="4069080"/>
+          </a:xfrm>
+          <a:prstGeom prst="rect">
+            <a:avLst/>
+          </a:prstGeom>
+          <a:noFill/>
+        </p:spPr>
+        <p:txBody>
+          <a:bodyPr wrap="square" lIns="0" rIns="0" tIns="0" bIns="0" anchor="t">
+            <a:spAutoFit/>
+          </a:bodyPr>
+          <a:lstStyle/>
+          <a:p>
+            <a:pPr>
+              <a:spcAft>
+                <a:spcPts val="400"/>
+              </a:spcAft>
+            </a:pPr>
+            <a:r>
+              <a:rPr sz="1200" b="1">
+                <a:solidFill>
+                  <a:srgbClr val="5E6B75"/>
+                </a:solidFill>
+                <a:latin typeface="Consolas"/>
+              </a:rPr>
+              <a:t>MEMORY AND EVAL</a:t>
+            </a:r>
+          </a:p>
+          <a:p>
+            <a:pPr>
+              <a:spcAft>
+                <a:spcPts val="400"/>
+              </a:spcAft>
+            </a:pPr>
+            <a:r>
+              <a:rPr sz="1600" b="0">
+                <a:solidFill>
+                  <a:srgbClr val="16222B"/>
+                </a:solidFill>
+                <a:latin typeface="Calibri"/>
+              </a:rPr>
+              <a:t>•  Optimizer state can live on the CPU</a:t>
+            </a:r>
+          </a:p>
+          <a:p>
+            <a:pPr>
+              <a:spcAft>
+                <a:spcPts val="400"/>
+              </a:spcAft>
+            </a:pPr>
+            <a:r>
+              <a:rPr sz="1600" b="0">
+                <a:solidFill>
+                  <a:srgbClr val="16222B"/>
+                </a:solidFill>
+                <a:latin typeface="Calibri"/>
+              </a:rPr>
+              <a:t>•  Reference model can be offloaded</a:t>
+            </a:r>
+          </a:p>
+          <a:p>
+            <a:pPr>
+              <a:spcAft>
+                <a:spcPts val="400"/>
+              </a:spcAft>
+            </a:pPr>
+            <a:r>
+              <a:rPr sz="1600" b="0">
+                <a:solidFill>
+                  <a:srgbClr val="16222B"/>
+                </a:solidFill>
+                <a:latin typeface="Calibri"/>
+              </a:rPr>
+              <a:t>•  Judge on a remote small GPU</a:t>
+            </a:r>
+          </a:p>
+          <a:p>
+            <a:pPr>
+              <a:spcAft>
+                <a:spcPts val="400"/>
+              </a:spcAft>
+            </a:pPr>
+            <a:r>
+              <a:rPr sz="1600" b="0">
+                <a:solidFill>
+                  <a:srgbClr val="16222B"/>
+                </a:solidFill>
+                <a:latin typeface="Calibri"/>
+              </a:rPr>
+              <a:t>•  Eval: 16 questions, 8 answers each</a:t>
+            </a:r>
+          </a:p>
+          <a:p>
+            <a:pPr>
+              <a:spcAft>
+                <a:spcPts val="400"/>
+              </a:spcAft>
+            </a:pPr>
+            <a:r>
+              <a:rPr sz="1600" b="0">
+                <a:solidFill>
+                  <a:srgbClr val="16222B"/>
+                </a:solidFill>
+                <a:latin typeface="Calibri"/>
+              </a:rPr>
+              <a:t>•  Same-seed wobble: about one question</a:t>
+            </a:r>
+          </a:p>
+        </p:txBody>
+      </p:sp>
     </p:spTree>
   </p:cSld>
   <p:clrMapOvr>

</xml_diff>

<commit_message>
RL deck slide 4: reward bands under the LLM judge vs Jev; pipeline box fits
Co-Authored-By: Claude Sonnet 5.5 <noreply@anthropic.com>
</commit_message>
<xml_diff>
--- a/docs/RL_V2_rl.pptx
+++ b/docs/RL_V2_rl.pptx
@@ -2353,7 +2353,7 @@
           <a:lstStyle/>
           <a:p>
             <a:r>
-              <a:t>Numbers: 16 skills on decision trees and ensembles, 79 chunks, 748 questions that passed a correlation filter (reject any candidate with cosine similarity of 0.80 or more to a kept question; Math 230, Code 179, Instruction 172, STEM 167). CORRECTED 2026-10-02: an earlier version said 240 kept; 240 is the size of each phase set. Partition (src/partition_r3_pools.py): 12 rubric examples, 16 eval, 240 CPT, 240 SFT, 240 RL, with no spare. The 16 eval questions are frozen and never trained on. From 2026-09-27 the RL runs held out a further 40 records (200 train, 40 held out, stratified by category, seed 7). The reward bands are 0 / 0.5 / 1 by judge score, gated by correctness (SETTLED.md). Framing: concepts MDP Formulation Checklist, Dynamic System vs Environment Wrapper, State vs Observation. Pipeline as run: SFT then RL for all long runs (rl_kl03, rl_lr3e6, rl_replay2 start from the SFT checkpoint sft_book1e5/sft_full_epoch1; see docs/run-logs). CPT was tested separately and dropped (slide 24).</a:t>
+              <a:t>Numbers: 16 skills on decision trees and ensembles, 79 chunks, 748 questions that passed a correlation filter (reject any candidate with cosine similarity of 0.80 or more to a kept question; Math 230, Code 179, Instruction 172, STEM 167). CORRECTED 2026-10-02: an earlier version said 240 kept; 240 is the size of each phase set. Partition (src/partition_r3_pools.py): 12 rubric examples, 16 eval, 240 CPT, 240 SFT, 240 RL, with no spare. The 16 eval questions are frozen and never trained on. From 2026-09-27 the RL runs held out a further 40 records (200 train, 40 held out, stratified by category, seed 7). Reward under the LLM judge: 0 / 0.5 / 1 by judge score (0.70 passing, 0.90 high quality), gated by correctness (SETTLED.md). Under Jev (from 2026-09-26) it is 0 or 1, since Jev answers yes/no. Framing: concepts MDP Formulation Checklist, Dynamic System vs Environment Wrapper, State vs Observation. Pipeline as run: SFT then RL for all long runs (rl_kl03, rl_lr3e6, rl_replay2 start from the SFT checkpoint sft_book1e5/sft_full_epoch1; see docs/run-logs). CPT was tested separately and dropped (slide 24).</a:t>
             </a:r>
           </a:p>
         </p:txBody>
@@ -22359,7 +22359,7 @@
                 </a:solidFill>
                 <a:latin typeface="Calibri"/>
               </a:rPr>
-              <a:t>Designed as continued pre-training, then supervised fine-tuning (SFT), then RL. CPT showed no lift, so every long RL run below starts from the SFT checkpoint with no CPT, to remove it as a confounder. RL: 4 sampled answers per question, compared within the group.</a:t>
+              <a:t>Designed as CPT, then supervised fine-tuning (SFT), then RL. CPT showed no lift, so every long RL run starts from the SFT checkpoint. RL: 4 sampled answers per question, compared within the group.</a:t>
             </a:r>
           </a:p>
         </p:txBody>
@@ -22565,7 +22565,7 @@
                 </a:solidFill>
                 <a:latin typeface="Calibri"/>
               </a:rPr>
-              <a:t>Pays only when correct. Quality is a multiplier gated by correctness, so a wrong answer earns nothing at any quality.</a:t>
+              <a:t>Pays only when correct. With the LLM judge: 0 wrong, 0.5 passing (score 0.70+), 1 high quality (0.90+). With Jev: 0 or 1.</a:t>
             </a:r>
           </a:p>
         </p:txBody>

</xml_diff>

<commit_message>
RL deck slide 6: dynamic batching on total tokens
Co-Authored-By: Claude Sonnet 5.5 <noreply@anthropic.com>
</commit_message>
<xml_diff>
--- a/docs/RL_V2_rl.pptx
+++ b/docs/RL_V2_rl.pptx
@@ -2493,7 +2493,7 @@
           <a:lstStyle/>
           <a:p>
             <a:r>
-              <a:t>All values are the trainer's defaults in docs/grpo_one_file.py: grad_accum 1 record per optimizer step, num_rollouts 4, max_draw_attempts 40, retire_after 3, boltzmann True (spread-weighted draw), stratify_domains True, gen_batch 32, gen_tokens 16 x (288 + 160) = 7,168, length_slack 42 with min_completion 24, gen_timeout_s 90. The gen_batch default of 8 mentioned in a nearby comment is stale; the value is 32. The operator asked for batched generation on 2026-09-19 after seeing one-at-a-time rollouts. The visit cap counts gradient exposures, not judged draws: commit 64c53d9 and dispositions.md. The 112 of 197 figure is from the capfix probe in dispositions.md. A given run's flags can override these defaults; the launcher files in .tmp/ hold the exact values per run and are not reproduced here.</a:t>
+              <a:t>All values are the trainer's defaults in docs/grpo_one_file.py: grad_accum 1 record per optimizer step, num_rollouts 4, max_draw_attempts 40, retire_after 3, boltzmann True (spread-weighted draw), stratify_domains True, gen_batch 32 (hard sequence cap, halved on out-of-memory), gen_tokens 16 x (288 + 160) = 7,168 (total tokens per generate call: sequences x the batch's widest prompt+budget; questions are sorted longest first by prompt+budget before packing, which cut padded tokens 67% on the RL pool), length_slack 42 with min_completion 24, gen_timeout_s 90. The gen_batch default of 8 mentioned in a nearby comment is stale; the value is 32. The operator asked for batched generation on 2026-09-19 after seeing one-at-a-time rollouts. The visit cap counts gradient exposures, not judged draws: commit 64c53d9 and dispositions.md. The 112 of 197 figure is from the capfix probe in dispositions.md. A given run's flags can override these defaults; the launcher files in .tmp/ hold the exact values per run and are not reproduced here.</a:t>
             </a:r>
           </a:p>
         </p:txBody>
@@ -23780,7 +23780,7 @@
                 </a:solidFill>
                 <a:latin typeface="Calibri"/>
               </a:rPr>
-              <a:t>•  Many answers share one generate call, capped at 32 sequences</a:t>
+              <a:t>•  Questions are sorted longest first, then packed (dynamic batching)</a:t>
             </a:r>
           </a:p>
           <a:p>
@@ -23796,7 +23796,7 @@
                 </a:solidFill>
                 <a:latin typeface="Calibri"/>
               </a:rPr>
-              <a:t>•  Also capped at 7,168 tokens, so short records batch wider</a:t>
+              <a:t>•  Each batch stays under 7,168 tokens in total: sequences x longest prompt+answer</a:t>
             </a:r>
           </a:p>
           <a:p>
@@ -23812,7 +23812,7 @@
                 </a:solidFill>
                 <a:latin typeface="Calibri"/>
               </a:rPr>
-              <a:t>•  Halved automatically if the GPU runs out of memory</a:t>
+              <a:t>•  Short records batch wider, up to 32 sequences</a:t>
             </a:r>
           </a:p>
           <a:p>
@@ -23828,7 +23828,23 @@
                 </a:solidFill>
                 <a:latin typeface="Calibri"/>
               </a:rPr>
-              <a:t>•  Each answer's length budget is its gold's length plus 42 tokens</a:t>
+              <a:t>•  Halved automatically if the GPU runs out of memory</a:t>
+            </a:r>
+          </a:p>
+          <a:p>
+            <a:pPr>
+              <a:spcAft>
+                <a:spcPts val="400"/>
+              </a:spcAft>
+            </a:pPr>
+            <a:r>
+              <a:rPr sz="1600" b="0">
+                <a:solidFill>
+                  <a:srgbClr val="16222B"/>
+                </a:solidFill>
+                <a:latin typeface="Calibri"/>
+              </a:rPr>
+              <a:t>•  Answer length budget: gold's length plus 42 tokens</a:t>
             </a:r>
           </a:p>
           <a:p>

</xml_diff>

<commit_message>
RL deck slide 5: chunking is median/MAD-based, not a target length
Co-Authored-By: Claude Sonnet 5.5 <noreply@anthropic.com>
</commit_message>
<xml_diff>
--- a/docs/RL_V2_rl.pptx
+++ b/docs/RL_V2_rl.pptx
@@ -2423,7 +2423,7 @@
           <a:lstStyle/>
           <a:p>
             <a:r>
-              <a:t>CORRECTED 2026-10-02: an earlier version of this slide and the design slide said 748 candidates and 240 kept. That was wrong. The pool is 748 questions that passed the gate, and 240 is the size of each of three phase sets (src/partition_r3_pools.py docstring: 748 - 12 rubric - 16 eval = 720 = 240 x 3, zero spare; data/rl/pools_r3.jsonl has 748 rows, r3_rubric.jsonl 12, r3_eval.jsonl 16, r3_cpt/r3_sft/r3_rl.jsonl 240 each). The count of candidates rejected by the gate is not recorded here. HPO screens: data/rl/r3_screen_*.jsonl, 60 rows each. No separate replay-buffer holdout partition was found; the 40 held-out records are carved from the RL set, and the replay text in CPT is the RedPajama 10% mix (instructions.md 6.4). Numbers: 79 chunks and 16 skills come from instructions.md 1.6 and SETTLED.md. Chunk target 458 tokens: TARGET_TOKENS in src/chunk_more_trees.py, set to match the median packed chunk in the base file. The 0.80 gate: COSINE_MAX in src/build_pools_r3.py. Saturation figures (147 items, 36% at 0.78 or above, the last twelve at 0.798 to 0.800, 24 to 42 chunks did not help, 3 to 17 skills widened on 2026-08-26) are comments in the TARGET_SKILLS block of build_pools_r3.py and the docstring of split_chunks_finer.py. Four categories multiply usable items per chunk: R3_CATEGORIES in build_pools_r3.py. 197 train and 40 held out: commit 5264d4c ("197-record RL split without gold==question records") and the transfer run entries in dispositions.md; the design slide's notes say 200 and 40, the file counts are 197 and 40. Not recorded here: the exact per-skill quotas of the final 240; the count of records per category differs between the 237 rows in the RL files (math 71, code 58, instruction 55, STEM 53) and the candidate counts above, because filtering was not uniform.</a:t>
+              <a:t>CORRECTED 2026-10-02: an earlier version of this slide and the design slide said 748 candidates and 240 kept. That was wrong. The pool is 748 questions that passed the gate, and 240 is the size of each of three phase sets (src/partition_r3_pools.py docstring: 748 - 12 rubric - 16 eval = 720 = 240 x 3, zero spare; data/rl/pools_r3.jsonl has 748 rows, r3_rubric.jsonl 12, r3_eval.jsonl 16, r3_cpt/r3_sft/r3_rl.jsonl 240 each). The count of candidates rejected by the gate is not recorded here. HPO screens: data/rl/r3_screen_*.jsonl, 60 rows each. No separate replay-buffer holdout partition was found; the 40 held-out records are carved from the RL set, and the replay text in CPT is the RedPajama 10% mix (instructions.md 6.4). Numbers: 79 chunks and 16 skills come from instructions.md 1.6 and SETTLED.md. Chunking is median-based, not a fixed target: src/rlv2/data/chunking.py (atoms_for) takes each note's own paragraphs-per-section median m and MAD d, merges sections below m paragraphs and splits those above m + 2d with stride m; the 458-token size in src/chunk_more_trees.py (TARGET_TOKENS) was set to the median packed chunk of the base file. The 0.80 gate: COSINE_MAX in src/build_pools_r3.py. Saturation figures (147 items, 36% at 0.78 or above, the last twelve at 0.798 to 0.800, 24 to 42 chunks did not help, 3 to 17 skills widened on 2026-08-26) are comments in the TARGET_SKILLS block of build_pools_r3.py and the docstring of split_chunks_finer.py. Four categories multiply usable items per chunk: R3_CATEGORIES in build_pools_r3.py. 197 train and 40 held out: commit 5264d4c ("197-record RL split without gold==question records") and the transfer run entries in dispositions.md; the design slide's notes say 200 and 40, the file counts are 197 and 40. Not recorded here: the exact per-skill quotas of the final 240; the count of records per category differs between the 237 rows in the RL files (math 71, code 58, instruction 55, STEM 53) and the candidate counts above, because filtering was not uniform.</a:t>
             </a:r>
           </a:p>
         </p:txBody>
@@ -22796,7 +22796,7 @@
                 </a:solidFill>
                 <a:latin typeface="Calibri"/>
               </a:rPr>
-              <a:t>Source: src/build_pools_r3.py (COSINE_MAX), src/chunk_more_trees.py, src/split_chunks_finer.py · instructions.md 1.6</a:t>
+              <a:t>Source: src/rlv2/data/chunking.py (atoms_for), src/build_pools_r3.py (COSINE_MAX), src/chunk_more_trees.py, src/split_chunks_finer.py · instructions.md 1.6</a:t>
             </a:r>
           </a:p>
         </p:txBody>
@@ -22927,7 +22927,7 @@
                           </a:solidFill>
                           <a:latin typeface="Calibri"/>
                         </a:rPr>
-                        <a:t>Source skill notes packed on paragraph boundaries toward a target length</a:t>
+                        <a:t>Skill notes cut on paragraph boundaries. Size comes from each note's own median and MAD, not a fixed length: merge below the median, split above median + 2 MAD</a:t>
                       </a:r>
                     </a:p>
                   </a:txBody>
@@ -22949,7 +22949,7 @@
                           </a:solidFill>
                           <a:latin typeface="Calibri"/>
                         </a:rPr>
-                        <a:t>target 458 tokens; 79 chunks, 16 skills</a:t>
+                        <a:t>458 tokens = median packed chunk; 79 chunks, 16 skills</a:t>
                       </a:r>
                     </a:p>
                   </a:txBody>

</xml_diff>

<commit_message>
RL deck slide 5: chunk split mechanism, overlap, de-overlap
Co-Authored-By: Claude Sonnet 5.5 <noreply@anthropic.com>
</commit_message>
<xml_diff>
--- a/docs/RL_V2_rl.pptx
+++ b/docs/RL_V2_rl.pptx
@@ -2423,7 +2423,7 @@
           <a:lstStyle/>
           <a:p>
             <a:r>
-              <a:t>CORRECTED 2026-10-02: an earlier version of this slide and the design slide said 748 candidates and 240 kept. That was wrong. The pool is 748 questions that passed the gate, and 240 is the size of each of three phase sets (src/partition_r3_pools.py docstring: 748 - 12 rubric - 16 eval = 720 = 240 x 3, zero spare; data/rl/pools_r3.jsonl has 748 rows, r3_rubric.jsonl 12, r3_eval.jsonl 16, r3_cpt/r3_sft/r3_rl.jsonl 240 each). The count of candidates rejected by the gate is not recorded here. HPO screens: data/rl/r3_screen_*.jsonl, 60 rows each. No separate replay-buffer holdout partition was found; the 40 held-out records are carved from the RL set, and the replay text in CPT is the RedPajama 10% mix (instructions.md 6.4). Numbers: 79 chunks and 16 skills come from instructions.md 1.6 and SETTLED.md. Chunking is median-based, not a fixed target: src/rlv2/data/chunking.py (atoms_for) takes each note's own paragraphs-per-section median m and MAD d, merges sections below m paragraphs and splits those above m + 2d with stride m; the 458-token size in src/chunk_more_trees.py (TARGET_TOKENS) was set to the median packed chunk of the base file. The 0.80 gate: COSINE_MAX in src/build_pools_r3.py. Saturation figures (147 items, 36% at 0.78 or above, the last twelve at 0.798 to 0.800, 24 to 42 chunks did not help, 3 to 17 skills widened on 2026-08-26) are comments in the TARGET_SKILLS block of build_pools_r3.py and the docstring of split_chunks_finer.py. Four categories multiply usable items per chunk: R3_CATEGORIES in build_pools_r3.py. 197 train and 40 held out: commit 5264d4c ("197-record RL split without gold==question records") and the transfer run entries in dispositions.md; the design slide's notes say 200 and 40, the file counts are 197 and 40. Not recorded here: the exact per-skill quotas of the final 240; the count of records per category differs between the 237 rows in the RL files (math 71, code 58, instruction 55, STEM 53) and the candidate counts above, because filtering was not uniform.</a:t>
+              <a:t>CORRECTED 2026-10-02: an earlier version of this slide and the design slide said 748 candidates and 240 kept. That was wrong. The pool is 748 questions that passed the gate, and 240 is the size of each of three phase sets (src/partition_r3_pools.py docstring: 748 - 12 rubric - 16 eval = 720 = 240 x 3, zero spare; data/rl/pools_r3.jsonl has 748 rows, r3_rubric.jsonl 12, r3_eval.jsonl 16, r3_cpt/r3_sft/r3_rl.jsonl 240 each). The count of candidates rejected by the gate is not recorded here. HPO screens: data/rl/r3_screen_*.jsonl, 60 rows each. No separate replay-buffer holdout partition was found; the 40 held-out records are carved from the RL set, and the replay text in CPT is the RedPajama 10% mix (instructions.md 6.4). Numbers: 79 chunks and 16 skills come from instructions.md 1.6 and SETTLED.md. Two chunkers, no overlap in either. (1) Question source: src/chunk_more_trees.py pack() splits on paragraph boundaries and greedily packs toward TARGET_TOKENS = 458 (chars/4 estimate), the median packed chunk of the base file; a trailing scrap under a quarter of the target is folded into the previous chunk. (2) CPT text: src/rlv2/data/chunking.py atoms_for() takes each note's paragraphs-per-section median m and MAD d, merges sections below m and splits those above m + 2d with stride m, so atoms tile the source; records then pack atoms greedily to 512 tokens, and the record stride (default 1, exposure 2.67x; 2 gives 1.72x, 3 gives 1.32x) is the only overlap, a chosen dose and not a defect. de_overlap_strings (the operator's reduce-overlap algorithm) is not applied to atoms: atoms are disjoint by construction, it trimmed 310 characters across 15,871 atoms that were coincidental markdown collisions (data loss), so paragraph conservation (every source paragraph in exactly one atom) is asserted instead. Not verified: which chunker produced the 79 base chunks. The 0.80 gate: COSINE_MAX in src/build_pools_r3.py. Saturation figures (147 items, 36% at 0.78 or above, the last twelve at 0.798 to 0.800, 24 to 42 chunks did not help, 3 to 17 skills widened on 2026-08-26) are comments in the TARGET_SKILLS block of build_pools_r3.py and the docstring of split_chunks_finer.py. Four categories multiply usable items per chunk: R3_CATEGORIES in build_pools_r3.py. 197 train and 40 held out: commit 5264d4c ("197-record RL split without gold==question records") and the transfer run entries in dispositions.md; the design slide's notes say 200 and 40, the file counts are 197 and 40. Not recorded here: the exact per-skill quotas of the final 240; the count of records per category differs between the 237 rows in the RL files (math 71, code 58, instruction 55, STEM 53) and the candidate counts above, because filtering was not uniform.</a:t>
             </a:r>
           </a:p>
         </p:txBody>
@@ -22927,7 +22927,7 @@
                           </a:solidFill>
                           <a:latin typeface="Calibri"/>
                         </a:rPr>
-                        <a:t>Skill notes cut on paragraph boundaries. Size comes from each note's own median and MAD, not a fixed length: merge below the median, split above median + 2 MAD</a:t>
+                        <a:t>Paragraph-boundary splits, no overlap. Questions: pack to 458 tokens, the median base chunk. CPT: atoms from each note's median and MAD, then 512-token records.</a:t>
                       </a:r>
                     </a:p>
                   </a:txBody>
@@ -22949,7 +22949,7 @@
                           </a:solidFill>
                           <a:latin typeface="Calibri"/>
                         </a:rPr>
-                        <a:t>458 tokens = median packed chunk; 79 chunks, 16 skills</a:t>
+                        <a:t>79 chunks, 16 skills. Only overlap: CPT record stride 1 = 2.67x exposure, chosen</a:t>
                       </a:r>
                     </a:p>
                   </a:txBody>

</xml_diff>

<commit_message>
RL deck slide 5: say what a CPT training example is
Co-Authored-By: Claude Sonnet 5.5 <noreply@anthropic.com>
</commit_message>
<xml_diff>
--- a/docs/RL_V2_rl.pptx
+++ b/docs/RL_V2_rl.pptx
@@ -22927,7 +22927,7 @@
                           </a:solidFill>
                           <a:latin typeface="Calibri"/>
                         </a:rPr>
-                        <a:t>Paragraph-boundary splits, no overlap. Questions: pack to 458 tokens, the median base chunk. CPT: atoms from each note's median and MAD, then 512-token records.</a:t>
+                        <a:t>Paragraph splits, no overlap. Questions: pack to 458 tokens, the median base chunk. CPT: median/MAD atoms, joined to fill the 512-token window.</a:t>
                       </a:r>
                     </a:p>
                   </a:txBody>
@@ -22949,7 +22949,7 @@
                           </a:solidFill>
                           <a:latin typeface="Calibri"/>
                         </a:rPr>
-                        <a:t>79 chunks, 16 skills. Only overlap: CPT record stride 1 = 2.67x exposure, chosen</a:t>
+                        <a:t>79 chunks, 16 skills. Only overlap: CPT examples step 1 atom at a time (2.67x exposure), chosen</a:t>
                       </a:r>
                     </a:p>
                   </a:txBody>

</xml_diff>

<commit_message>
RL deck slide 5: two packing levels (atoms to records, records to 512)
Co-Authored-By: Claude Sonnet 5.5 <noreply@anthropic.com>
</commit_message>
<xml_diff>
--- a/docs/RL_V2_rl.pptx
+++ b/docs/RL_V2_rl.pptx
@@ -2423,7 +2423,7 @@
           <a:lstStyle/>
           <a:p>
             <a:r>
-              <a:t>CORRECTED 2026-10-02: an earlier version of this slide and the design slide said 748 candidates and 240 kept. That was wrong. The pool is 748 questions that passed the gate, and 240 is the size of each of three phase sets (src/partition_r3_pools.py docstring: 748 - 12 rubric - 16 eval = 720 = 240 x 3, zero spare; data/rl/pools_r3.jsonl has 748 rows, r3_rubric.jsonl 12, r3_eval.jsonl 16, r3_cpt/r3_sft/r3_rl.jsonl 240 each). The count of candidates rejected by the gate is not recorded here. HPO screens: data/rl/r3_screen_*.jsonl, 60 rows each. No separate replay-buffer holdout partition was found; the 40 held-out records are carved from the RL set, and the replay text in CPT is the RedPajama 10% mix (instructions.md 6.4). Numbers: 79 chunks and 16 skills come from instructions.md 1.6 and SETTLED.md. Two chunkers, no overlap in either. (1) Question source: src/chunk_more_trees.py pack() splits on paragraph boundaries and greedily packs toward TARGET_TOKENS = 458 (chars/4 estimate), the median packed chunk of the base file; a trailing scrap under a quarter of the target is folded into the previous chunk. (2) CPT text: src/rlv2/data/chunking.py atoms_for() takes each note's paragraphs-per-section median m and MAD d, merges sections below m and splits those above m + 2d with stride m, so atoms tile the source; records then pack atoms greedily to 512 tokens, and the record stride (default 1, exposure 2.67x; 2 gives 1.72x, 3 gives 1.32x) is the only overlap, a chosen dose and not a defect. de_overlap_strings (the operator's reduce-overlap algorithm) is not applied to atoms: atoms are disjoint by construction, it trimmed 310 characters across 15,871 atoms that were coincidental markdown collisions (data loss), so paragraph conservation (every source paragraph in exactly one atom) is asserted instead. Not verified: which chunker produced the 79 base chunks. The 0.80 gate: COSINE_MAX in src/build_pools_r3.py. Saturation figures (147 items, 36% at 0.78 or above, the last twelve at 0.798 to 0.800, 24 to 42 chunks did not help, 3 to 17 skills widened on 2026-08-26) are comments in the TARGET_SKILLS block of build_pools_r3.py and the docstring of split_chunks_finer.py. Four categories multiply usable items per chunk: R3_CATEGORIES in build_pools_r3.py. 197 train and 40 held out: commit 5264d4c ("197-record RL split without gold==question records") and the transfer run entries in dispositions.md; the design slide's notes say 200 and 40, the file counts are 197 and 40. Not recorded here: the exact per-skill quotas of the final 240; the count of records per category differs between the 237 rows in the RL files (math 71, code 58, instruction 55, STEM 53) and the candidate counts above, because filtering was not uniform.</a:t>
+              <a:t>CORRECTED 2026-10-02: an earlier version of this slide and the design slide said 748 candidates and 240 kept. That was wrong. The pool is 748 questions that passed the gate, and 240 is the size of each of three phase sets (src/partition_r3_pools.py docstring: 748 - 12 rubric - 16 eval = 720 = 240 x 3, zero spare; data/rl/pools_r3.jsonl has 748 rows, r3_rubric.jsonl 12, r3_eval.jsonl 16, r3_cpt/r3_sft/r3_rl.jsonl 240 each). The count of candidates rejected by the gate is not recorded here. HPO screens: data/rl/r3_screen_*.jsonl, 60 rows each. No separate replay-buffer holdout partition was found; the 40 held-out records are carved from the RL set, and the replay text in CPT is the RedPajama 10% mix (instructions.md 6.4). Numbers: 79 chunks and 16 skills come from instructions.md 1.6 and SETTLED.md. Two chunkers, no overlap in either. (1) Question source: src/chunk_more_trees.py pack() splits on paragraph boundaries and greedily packs toward TARGET_TOKENS = 458 (chars/4 estimate), the median packed chunk of the base file; a trailing scrap under a quarter of the target is folded into the previous chunk. (2) CPT text: src/rlv2/data/chunking.py atoms_for() takes each note's paragraphs-per-section median m and MAD d, merges sections below m and splits those above m + 2d with stride m, so atoms tile the source; chunking.py then joins atoms of ONE note into a record, greedy to 512 tokens, and the record stride (default 1, exposure 2.67x; 2 gives 1.72x, 3 gives 1.32x) is the only overlap, a chosen dose and not a defect. de_overlap_strings (the operator's reduce-overlap algorithm) is not applied to atoms: atoms are disjoint by construction, it trimmed 310 characters across 15,871 atoms that were coincidental markdown collisions (data loss), so paragraph conservation (every source paragraph in exactly one atom) is asserted instead. Not verified: which chunker produced the 79 base chunks. The 0.80 gate: COSINE_MAX in src/build_pools_r3.py. Saturation figures (147 items, 36% at 0.78 or above, the last twelve at 0.798 to 0.800, 24 to 42 chunks did not help, 3 to 17 skills widened on 2026-08-26) are comments in the TARGET_SKILLS block of build_pools_r3.py and the docstring of split_chunks_finer.py. Four categories multiply usable items per chunk: R3_CATEGORIES in build_pools_r3.py. 197 train and 40 held out: commit 5264d4c ("197-record RL split without gold==question records") and the transfer run entries in dispositions.md; the design slide's notes say 200 and 40, the file counts are 197 and 40. Not recorded here: the exact per-skill quotas of the final 240; the count of records per category differs between the 237 rows in the RL files (math 71, code 58, instruction 55, STEM 53) and the candidate counts above, because filtering was not uniform.</a:t>
             </a:r>
           </a:p>
         </p:txBody>
@@ -22927,7 +22927,7 @@
                           </a:solidFill>
                           <a:latin typeface="Calibri"/>
                         </a:rPr>
-                        <a:t>Paragraph splits, no overlap. Questions: pack to 458 tokens, the median base chunk. CPT: median/MAD atoms, joined to fill the 512-token window.</a:t>
+                        <a:t>Paragraph splits, no overlap. Questions: pack to 458 tokens, the median base chunk. CPT: median/MAD atoms form records; the trainer packs whole records to 512.</a:t>
                       </a:r>
                     </a:p>
                   </a:txBody>
@@ -22949,7 +22949,7 @@
                           </a:solidFill>
                           <a:latin typeface="Calibri"/>
                         </a:rPr>
-                        <a:t>79 chunks, 16 skills. Only overlap: CPT examples step 1 atom at a time (2.67x exposure), chosen</a:t>
+                        <a:t>79 chunks, 16 skills. Only overlap: CPT records step 1 atom at a time (2.67x exposure), chosen</a:t>
                       </a:r>
                     </a:p>
                   </a:txBody>

</xml_diff>

<commit_message>
RL deck slide 13: aim was full-parameter SFT and RL; what we landed on, with evidence
Co-Authored-By: Claude Sonnet 5.5 <noreply@anthropic.com>
</commit_message>
<xml_diff>
--- a/docs/RL_V2_rl.pptx
+++ b/docs/RL_V2_rl.pptx
@@ -674,7 +674,7 @@
           <a:lstStyle/>
           <a:p>
             <a:r>
-              <a:t>From dispositions.md. Continue-adapter trials: lr 3e-5 / 1e-5 / 5e-6 gave macro-F1 0.257 / 0.259 / 0.265 against an SFT of 0.442. Cause recorded: lr-independent; GRPO on-policy rollouts destabilize the SFT adapter weights at any step size, and f1_answer collapses while f1_abstain holds. Merge-then-RL: 0.170 (alpha mismatch 32 to 64), 0.378 (alpha matched, 62-record SFT), 0.288 (alpha matched, merged full). Proven path: full-parameter SFT lr 1e-5, 200 records, 3 epochs gave 0.420; a fresh zero-initialized LoRA RL on top gave 0.452 (+0.032). Caveat: the an earlier talk prints 0.548 for the last cell; dispositions.md is the primary record and says 0.452, so I use that and flag the discrepancy. This lane ran before the abstention machinery was dropped (r3 lane: no abstention), so the metric is the early macro-F1, not the 16-question count. Per SETTLED.md, adapters for knowledge injection are falsified and not to be reopened.</a:t>
+              <a:t>From dispositions.md. Continue-adapter trials: lr 3e-5 / 1e-5 / 5e-6 gave macro-F1 0.257 / 0.259 / 0.265 against an SFT of 0.442. Cause recorded: lr-independent; GRPO on-policy rollouts destabilize the SFT adapter weights at any step size, and f1_answer collapses while f1_abstain holds. Merge-then-RL: 0.170 (alpha mismatch 32 to 64), 0.378 (alpha matched, 62-record SFT), 0.288 (alpha matched, merged full). Proven path: full-parameter SFT lr 1e-5, 200 records, 3 epochs gave 0.420; a fresh zero-initialized LoRA RL on top gave 0.452 (+0.032). Caveat: the an earlier talk prints 0.548 for the last cell; dispositions.md is the primary record and says 0.452, so I use that and flag the discrepancy. This lane ran before the abstention machinery was dropped (r3 lane: no abstention), so the metric is the early macro-F1, not the 16-question count. Per SETTLED.md, adapters for knowledge injection are falsified and not to be reopened. WHAT WE LANDED ON (evidence): full-parameter SFT and full-parameter RL. (1) dispositions.md, THE CLEAR WINNER (2026-09-06): 'ONE full-parameter MGPO pass on the full-parameter SFT deposit', base 4/16 to 8/16, 'full-param GRPO, lr 1e-5, G=4', reproduced in two lanes; 'LoRA chain: capped at 5'. (2) docs/grpo_one_file.py load_policy: 'a 0.8B fits at full parameters on 16 GB, and adapters were falsified for knowledge INJECTION in this project, so full-parameter is the default'; fp32 'is what every published number here used'; QLoRA is behind the --qlora flag, meant for larger models. (3) The launch commands recorded in docs/run-logs/rl_kl03.md, rl_lr3e6.md and rl_nowm.md contain no --qlora flag, so those runs took the full-parameter default. Not verified: the dtype flag in each launch command. Background: an earlier note in dispositions.md records the author's wish for adapter-only training of larger models, and that RL worked only on a full-parameter SFT base; the table's last row (fresh adapter on top of full SFT, +0.03) is the early lane, before the full-parameter pass.</a:t>
             </a:r>
           </a:p>
         </p:txBody>
@@ -7867,7 +7867,7 @@
                 </a:solidFill>
                 <a:latin typeface="Calibri"/>
               </a:rPr>
-              <a:t>Source: dispositions.md, "LoRA Chain Approaches: ALL FALSIFIED" and "Proven Path"</a:t>
+              <a:t>Source: dispositions.md "LoRA Chain Approaches", "Proven Path", "THE CLEAR WINNER" · docs/grpo_one_file.py load_policy</a:t>
             </a:r>
           </a:p>
         </p:txBody>
@@ -7970,7 +7970,7 @@
                 </a:solidFill>
                 <a:latin typeface="Calibri"/>
               </a:rPr>
-              <a:t>A deposit written into a LoRA adapter can be sharpened by RL, as a full-parameter deposit can.</a:t>
+              <a:t>Aim: full-parameter SFT and RL, so no adapter confounds the result. Test: can a deposit in an adapter be sharpened by RL as a full-parameter one can?</a:t>
             </a:r>
           </a:p>
         </p:txBody>
@@ -8623,7 +8623,7 @@
                 </a:solidFill>
                 <a:latin typeface="Calibri"/>
               </a:rPr>
-              <a:t>Every adapter route lost 0.06 to 0.27 under RL, at every learning rate tried. Only the full-parameter deposit was kept (+0.03).</a:t>
+              <a:t>Every adapter route lost 0.06 to 0.27 under RL. We landed on full-parameter SFT and RL: the winning pass (4 to 8 of 16) and the long runs.</a:t>
             </a:r>
           </a:p>
         </p:txBody>

</xml_diff>

<commit_message>
RL deck slide 31: scoring is 3 single-answer judgings, majority decides
Co-Authored-By: Claude Sonnet 5.5 <noreply@anthropic.com>
</commit_message>
<xml_diff>
--- a/docs/RL_V2_rl.pptx
+++ b/docs/RL_V2_rl.pptx
@@ -2284,7 +2284,7 @@
           <a:lstStyle/>
           <a:p>
             <a:r>
-              <a:t>The fixed-scoring sequence is the same one the short talk opened with. Its numbers are quoted as measured at the time; the long runs used a different eval prompt (see slide 24 and the appendix slides), so the two are not on one instrument.</a:t>
+              <a:t>The fixed-scoring sequence is the same one the short talk opened with. Its numbers are quoted as measured at the time; the long runs used a different eval prompt (see slide 24 and the appendix slides), so the two are not on one instrument. Scoring detail (dispositions.md, THE LOCKED MECHANISM AND THE UNIFORM BOARD): the checkpoint's greedy answers, each (question, answer) judged ALONE 3 times by the 4B judge, empty or stub answers scored 0 mechanically, the majority of the 3 readings is that question's verdict, and the count of 16 is the phase score. Board, one procedure: base 4, SFT 5, SFT plus one MGPO run on 6 records 9, that plus IPO 5, coverage 4. Training past the first RL update lost in three attempts: 8 to 5 (lr 1e-5, 72 records), 6 to 5 (lr 3e-6, 60 records), 6 to 2 (restart from the better model). The in-run eval reads of the winning pass (RL step 3: 6, step 6: 8, step 9: 7, step 12: 8) come from a different instrument, so they are not on this board.</a:t>
             </a:r>
           </a:p>
         </p:txBody>
@@ -21658,7 +21658,7 @@
                 </a:solidFill>
                 <a:latin typeface="Calibri"/>
               </a:rPr>
-              <a:t>Fixed scoring, one judge invocation: base 4, full-parameter SFT 5, first RL pass from the SFT deposit 9 of 16. SFT then RL, no CPT.</a:t>
+              <a:t>Fixed scoring (each answer judged alone 3 times by a 4B judge, majority decides): base 4, full-parameter SFT 5, first RL pass from the SFT deposit 9 of 16. SFT then RL, no CPT.</a:t>
             </a:r>
           </a:p>
           <a:p>

</xml_diff>

<commit_message>
RL deck slide 31: the base 4, SFT, RL 9 figure with its in-run readings
Co-Authored-By: Claude Sonnet 5.5 <noreply@anthropic.com>
</commit_message>
<xml_diff>
--- a/docs/RL_V2_rl.pptx
+++ b/docs/RL_V2_rl.pptx
@@ -2284,7 +2284,7 @@
           <a:lstStyle/>
           <a:p>
             <a:r>
-              <a:t>The fixed-scoring sequence is the same one the short talk opened with. Its numbers are quoted as measured at the time; the long runs used a different eval prompt (see slide 24 and the appendix slides), so the two are not on one instrument. Scoring detail (dispositions.md, THE LOCKED MECHANISM AND THE UNIFORM BOARD): the checkpoint's greedy answers, each (question, answer) judged ALONE 3 times by the 4B judge, empty or stub answers scored 0 mechanically, the majority of the 3 readings is that question's verdict, and the count of 16 is the phase score. Board, one procedure: base 4, SFT 5, SFT plus one MGPO run on 6 records 9, that plus IPO 5, coverage 4. Training past the first RL update lost in three attempts: 8 to 5 (lr 1e-5, 72 records), 6 to 5 (lr 3e-6, 60 records), 6 to 2 (restart from the better model). The in-run eval reads of the winning pass (RL step 3: 6, step 6: 8, step 9: 7, step 12: 8) come from a different instrument, so they are not on this board.</a:t>
+              <a:t>The fixed-scoring sequence is the same one the short talk opened with. Its numbers are quoted as measured at the time; the long runs used a different eval prompt (see slide 24 and the appendix slides), so the two are not on one instrument. Scoring detail (dispositions.md, THE LOCKED MECHANISM AND THE UNIFORM BOARD): the checkpoint's greedy answers, each (question, answer) judged ALONE 3 times by the 4B judge, empty or stub answers scored 0 mechanically, the majority of the 3 readings is that question's verdict, and the count of 16 is the phase score. Board, one procedure: base 4, SFT 5, SFT plus one MGPO run on 6 records 9, that plus IPO 5, coverage 4. Training past the first RL update lost in three attempts: 8 to 5 (lr 1e-5, 72 records), 6 to 5 (lr 3e-6, 60 records), 6 to 2 (restart from the better model). The in-run eval reads of the winning pass (RL step 3: 6, step 6: 8, step 9: 7, step 12: 8) come from a different instrument, so they are not on this board. Figure (docs/figures/critical_lifts.png, from data/probe3_locked.json): left panel, base 4, SFT epochs 1/3/5 read 1, 3, 5, then the RL checkpoint trained from SFT (past9_r1a) reads 9; its own in-run readings at steps 3, 6, 9, 12 read 6, 8, 7, 8 (same run, different instrument from the 9). Right panel: the full-coverage campaign's in-run readings 3, 5, 5, 7, 7 at steps 2 to 10 (12 records each), against the same SFT of 1 and winner of 5.</a:t>
             </a:r>
           </a:p>
         </p:txBody>
@@ -21571,7 +21571,7 @@
                 </a:solidFill>
                 <a:latin typeface="Calibri"/>
               </a:rPr>
-              <a:t>Source: docs/dispositions.md, THE LOCKED MECHANISM AND THE UNIFORM BOARD · scored by the fixed single-answer protocol, 16 questions</a:t>
+              <a:t>Source: docs/dispositions.md, THE LOCKED MECHANISM AND THE UNIFORM BOARD · figure: docs/figures/critical_lifts.png (data/probe3_locked.json, past9_r1a)</a:t>
             </a:r>
           </a:p>
         </p:txBody>
@@ -21632,8 +21632,8 @@
         </p:nvSpPr>
         <p:spPr>
           <a:xfrm>
-            <a:off x="1051560" y="1800000"/>
-            <a:ext cx="10088575" cy="3200000"/>
+            <a:off x="1047750" y="1800000"/>
+            <a:ext cx="3810000" cy="3200000"/>
           </a:xfrm>
           <a:prstGeom prst="rect">
             <a:avLst/>
@@ -21652,7 +21652,7 @@
               </a:spcAft>
             </a:pPr>
             <a:r>
-              <a:rPr sz="1700" b="1">
+              <a:rPr sz="1400" b="1">
                 <a:solidFill>
                   <a:srgbClr val="1A2332"/>
                 </a:solidFill>
@@ -21668,7 +21668,7 @@
               </a:spcAft>
             </a:pPr>
             <a:r>
-              <a:rPr sz="1700" b="0">
+              <a:rPr sz="1400" b="0">
                 <a:solidFill>
                   <a:srgbClr val="1A2332"/>
                 </a:solidFill>
@@ -21684,7 +21684,7 @@
               </a:spcAft>
             </a:pPr>
             <a:r>
-              <a:rPr sz="1700" b="0">
+              <a:rPr sz="1400" b="0">
                 <a:solidFill>
                   <a:srgbClr val="1A2332"/>
                 </a:solidFill>
@@ -21700,7 +21700,7 @@
               </a:spcAft>
             </a:pPr>
             <a:r>
-              <a:rPr sz="1700" b="0">
+              <a:rPr sz="1400" b="0">
                 <a:solidFill>
                   <a:srgbClr val="1A2332"/>
                 </a:solidFill>
@@ -21846,6 +21846,30 @@
           </a:p>
         </p:txBody>
       </p:sp>
+      <p:pic>
+        <p:nvPicPr>
+          <p:cNvPr id="11" name="Picture critical_lifts" descr="critical_lifts.png"/>
+          <p:cNvPicPr>
+            <a:picLocks noChangeAspect="1"/>
+          </p:cNvPicPr>
+          <p:nvPr/>
+        </p:nvPicPr>
+        <p:blipFill>
+          <a:blip r:embed="rId3"/>
+          <a:stretch>
+            <a:fillRect/>
+          </a:stretch>
+        </p:blipFill>
+        <p:spPr>
+          <a:xfrm>
+            <a:off x="5000625" y="1952625"/>
+            <a:ext cx="6191250" cy="2646260"/>
+          </a:xfrm>
+          <a:prstGeom prst="rect">
+            <a:avLst/>
+          </a:prstGeom>
+        </p:spPr>
+      </p:pic>
     </p:spTree>
   </p:cSld>
   <p:clrMapOvr>

</xml_diff>

<commit_message>
RL deck slide 31: what replicated (first-pass lift 3 to 4) and what did not (the 9)
Co-Authored-By: Claude Sonnet 5.5 <noreply@anthropic.com>
</commit_message>
<xml_diff>
--- a/docs/RL_V2_rl.pptx
+++ b/docs/RL_V2_rl.pptx
@@ -2284,7 +2284,7 @@
           <a:lstStyle/>
           <a:p>
             <a:r>
-              <a:t>The fixed-scoring sequence is the same one the short talk opened with. Its numbers are quoted as measured at the time; the long runs used a different eval prompt (see slide 24 and the appendix slides), so the two are not on one instrument. Scoring detail (dispositions.md, THE LOCKED MECHANISM AND THE UNIFORM BOARD): the checkpoint's greedy answers, each (question, answer) judged ALONE 3 times by the 4B judge, empty or stub answers scored 0 mechanically, the majority of the 3 readings is that question's verdict, and the count of 16 is the phase score. Board, one procedure: base 4, SFT 5, SFT plus one MGPO run on 6 records 9, that plus IPO 5, coverage 4. Training past the first RL update lost in three attempts: 8 to 5 (lr 1e-5, 72 records), 6 to 5 (lr 3e-6, 60 records), 6 to 2 (restart from the better model). The in-run eval reads of the winning pass (RL step 3: 6, step 6: 8, step 9: 7, step 12: 8) come from a different instrument, so they are not on this board. Figure (docs/figures/critical_lifts.png, from data/probe3_locked.json): left panel, base 4, SFT epochs 1/3/5 read 1, 3, 5, then the RL checkpoint trained from SFT (past9_r1a) reads 9; its own in-run readings at steps 3, 6, 9, 12 read 6, 8, 7, 8 (same run, different instrument from the 9). Right panel: the full-coverage campaign's in-run readings 3, 5, 5, 7, 7 at steps 2 to 10 (12 records each), against the same SFT of 1 and winner of 5.</a:t>
+              <a:t>The fixed-scoring sequence is the same one the short talk opened with. Its numbers are quoted as measured at the time; the long runs used a different eval prompt (see slide 24 and the appendix slides), so the two are not on one instrument. Scoring detail (dispositions.md, THE LOCKED MECHANISM AND THE UNIFORM BOARD): the checkpoint's greedy answers, each (question, answer) judged ALONE 3 times by the 4B judge, empty or stub answers scored 0 mechanically, the majority of the 3 readings is that question's verdict, and the count of 16 is the phase score. Board, one procedure: base 4, SFT 5, SFT plus one MGPO run on 6 records 9, that plus IPO 5, coverage 4. Training past the first RL update lost in three attempts: 8 to 5 (lr 1e-5, 72 records), 6 to 5 (lr 3e-6, 60 records), 6 to 2 (restart from the better model). The in-run eval reads of the winning pass (RL step 3: 6, step 6: 8, step 9: 7, step 12: 8) come from a different instrument, so they are not on this board. Figure (docs/figures/critical_lifts.png, from data/probe3_locked.json): left panel, base 4, SFT epochs 1/3/5 read 1, 3, 5, then the RL checkpoint trained from SFT (past9_r1a) reads 9; its own in-run readings at steps 3, 6, 9, 12 read 6, 8, 7, 8 (same run, different instrument from the 9). Right panel: the full-coverage campaign's in-run readings 3, 5, 5, 7, 7 at steps 2 to 10 (12 records each), against the same SFT of 1 and winner of 5. Reading of the 9 (dispositions.md): the locked board has the champion RL pass at 8 and the second lineage fpv2_pass2 at 8; 'Every FIRST RL pass lifts (+3..4); every second/third pass collapses (2-5)'; 'Earlier headline numbers (9, 10, 11, 12) were floors/other-grader readings'. Resolution: one question = 6.25 points; one reading has a standard error of 12.5 points; a 5-point difference at 80% power needs about 1,568 questions per arm.</a:t>
             </a:r>
           </a:p>
         </p:txBody>
@@ -21652,7 +21652,7 @@
               </a:spcAft>
             </a:pPr>
             <a:r>
-              <a:rPr sz="1400" b="1">
+              <a:rPr sz="1300" b="1">
                 <a:solidFill>
                   <a:srgbClr val="1A2332"/>
                 </a:solidFill>
@@ -21668,13 +21668,13 @@
               </a:spcAft>
             </a:pPr>
             <a:r>
-              <a:rPr sz="1400" b="0">
+              <a:rPr sz="1300" b="0">
                 <a:solidFill>
                   <a:srgbClr val="1A2332"/>
                 </a:solidFill>
                 <a:latin typeface="Calibri"/>
               </a:rPr>
-              <a:t>The RL step is the only one that moved the count by more than the same-checkpoint wobble (an unchanged model read 6/16 and 7/16).</a:t>
+              <a:t>The 9 is one reading: the same checkpoint later read 8, and a second run also read 8. What replicated is a first-pass lift of 3 to 4 questions.</a:t>
             </a:r>
           </a:p>
           <a:p>
@@ -21684,13 +21684,13 @@
               </a:spcAft>
             </a:pPr>
             <a:r>
-              <a:rPr sz="1400" b="0">
+              <a:rPr sz="1300" b="0">
                 <a:solidFill>
                   <a:srgbClr val="1A2332"/>
                 </a:solidFill>
                 <a:latin typeface="Calibri"/>
               </a:rPr>
-              <a:t>Later passes degraded, and the long runs on slides 29 and 30 never beat 9 and never held a gain.</a:t>
+              <a:t>One question is 6.25 points and an unchanged model read 6/16 then 7/16, so 16 questions cannot size the lift. Later passes degraded, and the long runs on slides 29 and 30 never beat 9 and never held a gain.</a:t>
             </a:r>
           </a:p>
           <a:p>
@@ -21700,13 +21700,13 @@
               </a:spcAft>
             </a:pPr>
             <a:r>
-              <a:rPr sz="1400" b="0">
+              <a:rPr sz="1300" b="0">
                 <a:solidFill>
                   <a:srgbClr val="1A2332"/>
                 </a:solidFill>
                 <a:latin typeface="Calibri"/>
               </a:rPr>
-              <a:t>The 9 comes from the early instrument. It was not re-read under the training prompt (slide 24), so it is not comparable with the long-run numbers.</a:t>
+              <a:t>The 9 was not re-read under the training prompt (slide 24), so it is not comparable with the long-run numbers.</a:t>
             </a:r>
           </a:p>
         </p:txBody>
@@ -21841,7 +21841,7 @@
                 </a:solidFill>
                 <a:latin typeface="Calibri"/>
               </a:rPr>
-              <a:t>Why the question looked answerable, and why the later runs were run: one pass reached 9 of 16, and nothing afterwards held it.</a:t>
+              <a:t>Why the question looked answerable: a first RL pass lifted 3 to 4 questions. The 9 itself was not reproduced, and no later run held a gain.</a:t>
             </a:r>
           </a:p>
         </p:txBody>

</xml_diff>

<commit_message>
RL deck slide 31: label the 9 as the old method; current runs are the headline
Co-Authored-By: Claude Sonnet 5.5 <noreply@anthropic.com>
</commit_message>
<xml_diff>
--- a/docs/RL_V2_rl.pptx
+++ b/docs/RL_V2_rl.pptx
@@ -2284,7 +2284,7 @@
           <a:lstStyle/>
           <a:p>
             <a:r>
-              <a:t>The fixed-scoring sequence is the same one the short talk opened with. Its numbers are quoted as measured at the time; the long runs used a different eval prompt (see slide 24 and the appendix slides), so the two are not on one instrument. Scoring detail (dispositions.md, THE LOCKED MECHANISM AND THE UNIFORM BOARD): the checkpoint's greedy answers, each (question, answer) judged ALONE 3 times by the 4B judge, empty or stub answers scored 0 mechanically, the majority of the 3 readings is that question's verdict, and the count of 16 is the phase score. Board, one procedure: base 4, SFT 5, SFT plus one MGPO run on 6 records 9, that plus IPO 5, coverage 4. Training past the first RL update lost in three attempts: 8 to 5 (lr 1e-5, 72 records), 6 to 5 (lr 3e-6, 60 records), 6 to 2 (restart from the better model). The in-run eval reads of the winning pass (RL step 3: 6, step 6: 8, step 9: 7, step 12: 8) come from a different instrument, so they are not on this board. Figure (docs/figures/critical_lifts.png, from data/probe3_locked.json): left panel, base 4, SFT epochs 1/3/5 read 1, 3, 5, then the RL checkpoint trained from SFT (past9_r1a) reads 9; its own in-run readings at steps 3, 6, 9, 12 read 6, 8, 7, 8 (same run, different instrument from the 9). Right panel: the full-coverage campaign's in-run readings 3, 5, 5, 7, 7 at steps 2 to 10 (12 records each), against the same SFT of 1 and winner of 5. Reading of the 9 (dispositions.md): the locked board has the champion RL pass at 8 and the second lineage fpv2_pass2 at 8; 'Every FIRST RL pass lifts (+3..4); every second/third pass collapses (2-5)'; 'Earlier headline numbers (9, 10, 11, 12) were floors/other-grader readings'. Resolution: one question = 6.25 points; one reading has a standard error of 12.5 points; a 5-point difference at 80% power needs about 1,568 questions per arm.</a:t>
+              <a:t>The fixed-scoring sequence is the same one the short talk opened with. Its numbers are quoted as measured at the time; the long runs used a different eval prompt (see slide 24 and the appendix slides), so the two are not on one instrument. Scoring detail (dispositions.md, THE LOCKED MECHANISM AND THE UNIFORM BOARD): the checkpoint's greedy answers, each (question, answer) judged ALONE 3 times by the 4B judge, empty or stub answers scored 0 mechanically, the majority of the 3 readings is that question's verdict, and the count of 16 is the phase score. Board, one procedure: base 4, SFT 5, SFT plus one MGPO run on 6 records 9, that plus IPO 5, coverage 4. Training past the first RL update lost in three attempts: 8 to 5 (lr 1e-5, 72 records), 6 to 5 (lr 3e-6, 60 records), 6 to 2 (restart from the better model). The in-run eval reads of the winning pass (RL step 3: 6, step 6: 8, step 9: 7, step 12: 8) come from a different instrument, so they are not on this board. Figure (docs/figures/critical_lifts.png, from data/probe3_locked.json): left panel, base 4, SFT epochs 1/3/5 read 1, 3, 5, then the RL checkpoint trained from SFT (past9_r1a) reads 9; its own in-run readings at steps 3, 6, 9, 12 read 6, 8, 7, 8 (same run, different instrument from the 9). Right panel: the full-coverage campaign's in-run readings 3, 5, 5, 7, 7 at steps 2 to 10 (12 records each), against the same SFT of 1 and winner of 5. Reading of the 9 (dispositions.md): the locked board has the champion RL pass at 8 and the second lineage fpv2_pass2 at 8; 'Every FIRST RL pass lifts (+3..4); every second/third pass collapses (2-5)'; 'Earlier headline numbers (9, 10, 11, 12) were floors/other-grader readings'. Resolution: one question = 6.25 points; one reading has a standard error of 12.5 points; a 5-point difference at 80% power needs about 1,568 questions per arm. CORRECTION: the reading above that a first-pass lift of 3 to 4 'replicated' rests on old-method boards only (LLM judge, 3-read majority, comparative-grader era); it does not carry to the current method (training prompt, Jev, 200-record runs rl_kl03, rl_lr3e6, rl_replay2), where no run held a gain.</a:t>
             </a:r>
           </a:p>
         </p:txBody>
@@ -21503,7 +21503,7 @@
                 </a:solidFill>
                 <a:latin typeface="Consolas"/>
               </a:rPr>
-              <a:t>CONTEXT · THE FIRST RL PASS</a:t>
+              <a:t>CONTEXT · THE FIRST RL PASS (OLD METHOD)</a:t>
             </a:r>
           </a:p>
         </p:txBody>
@@ -21658,7 +21658,7 @@
                 </a:solidFill>
                 <a:latin typeface="Calibri"/>
               </a:rPr>
-              <a:t>Fixed scoring (each answer judged alone 3 times by a 4B judge, majority decides): base 4, full-parameter SFT 5, first RL pass from the SFT deposit 9 of 16. SFT then RL, no CPT.</a:t>
+              <a:t>Old method (LLM judge, greedy answers, each judged alone 3 times, majority decides): base 4, full-parameter SFT 5, first RL pass from the SFT deposit 9 of 16. SFT then RL, no CPT.</a:t>
             </a:r>
           </a:p>
           <a:p>
@@ -21674,7 +21674,7 @@
                 </a:solidFill>
                 <a:latin typeface="Calibri"/>
               </a:rPr>
-              <a:t>The 9 is one reading: the same checkpoint later read 8, and a second run also read 8. What replicated is a first-pass lift of 3 to 4 questions.</a:t>
+              <a:t>It is the result that got us excited. The 9 was one reading (the same checkpoint later read 8), and later passes under this method fell back.</a:t>
             </a:r>
           </a:p>
           <a:p>
@@ -21690,7 +21690,7 @@
                 </a:solidFill>
                 <a:latin typeface="Calibri"/>
               </a:rPr>
-              <a:t>One question is 6.25 points and an unchanged model read 6/16 then 7/16, so 16 questions cannot size the lift. Later passes degraded, and the long runs on slides 29 and 30 never beat 9 and never held a gain.</a:t>
+              <a:t>The current method (training prompt, Jev judge, long runs on slides 29 and 30) never beat 9 and never held a gain. One question is 6.25 points, so 16 questions cannot size a lift either way.</a:t>
             </a:r>
           </a:p>
           <a:p>
@@ -21706,7 +21706,7 @@
                 </a:solidFill>
                 <a:latin typeface="Calibri"/>
               </a:rPr>
-              <a:t>The 9 was not re-read under the training prompt (slide 24), so it is not comparable with the long-run numbers.</a:t>
+              <a:t>The two methods are not comparable: the 9 was not re-read under the training prompt (slide 24).</a:t>
             </a:r>
           </a:p>
         </p:txBody>
@@ -21841,7 +21841,7 @@
                 </a:solidFill>
                 <a:latin typeface="Calibri"/>
               </a:rPr>
-              <a:t>Why the question looked answerable: a first RL pass lifted 3 to 4 questions. The 9 itself was not reproduced, and no later run held a gain.</a:t>
+              <a:t>Why we had high hopes: one pass under the old method reached 9 of 16. Under the current method, no run has held a gain.</a:t>
             </a:r>
           </a:p>
         </p:txBody>

</xml_diff>

<commit_message>
RL deck: the long runs now follow slide 13 (slides 14 to 16); references renumbered
Co-Authored-By: Claude Sonnet 5.5 <noreply@anthropic.com>
</commit_message>
<xml_diff>
--- a/docs/RL_V2_rl.pptx
+++ b/docs/RL_V2_rl.pptx
@@ -18,11 +18,13 @@
     <p:sldId id="264" r:id="rId16"/>
     <p:sldId id="265" r:id="rId17"/>
     <p:sldId id="267" r:id="rId19"/>
+    <p:sldId id="272" r:id="rId24"/>
+    <p:sldId id="288" r:id="rId40"/>
+    <p:sldId id="289" r:id="rId41"/>
     <p:sldId id="268" r:id="rId20"/>
     <p:sldId id="269" r:id="rId21"/>
     <p:sldId id="270" r:id="rId22"/>
     <p:sldId id="271" r:id="rId23"/>
-    <p:sldId id="272" r:id="rId24"/>
     <p:sldId id="273" r:id="rId25"/>
     <p:sldId id="274" r:id="rId26"/>
     <p:sldId id="275" r:id="rId27"/>
@@ -33,8 +35,6 @@
     <p:sldId id="280" r:id="rId32"/>
     <p:sldId id="281" r:id="rId33"/>
     <p:sldId id="282" r:id="rId34"/>
-    <p:sldId id="288" r:id="rId40"/>
-    <p:sldId id="289" r:id="rId41"/>
     <p:sldId id="290" r:id="rId42"/>
     <p:sldId id="291" r:id="rId43"/>
     <p:sldId id="287" r:id="rId39"/>
@@ -2284,7 +2284,7 @@
           <a:lstStyle/>
           <a:p>
             <a:r>
-              <a:t>The fixed-scoring sequence is the same one the short talk opened with. Its numbers are quoted as measured at the time; the long runs used a different eval prompt (see slide 24 and the appendix slides), so the two are not on one instrument. Scoring detail (dispositions.md, THE LOCKED MECHANISM AND THE UNIFORM BOARD): the checkpoint's greedy answers, each (question, answer) judged ALONE 3 times by the 4B judge, empty or stub answers scored 0 mechanically, the majority of the 3 readings is that question's verdict, and the count of 16 is the phase score. Board, one procedure: base 4, SFT 5, SFT plus one MGPO run on 6 records 9, that plus IPO 5, coverage 4. Training past the first RL update lost in three attempts: 8 to 5 (lr 1e-5, 72 records), 6 to 5 (lr 3e-6, 60 records), 6 to 2 (restart from the better model). The in-run eval reads of the winning pass (RL step 3: 6, step 6: 8, step 9: 7, step 12: 8) come from a different instrument, so they are not on this board. Figure (docs/figures/critical_lifts.png, from data/probe3_locked.json): left panel, base 4, SFT epochs 1/3/5 read 1, 3, 5, then the RL checkpoint trained from SFT (past9_r1a) reads 9; its own in-run readings at steps 3, 6, 9, 12 read 6, 8, 7, 8 (same run, different instrument from the 9). Right panel: the full-coverage campaign's in-run readings 3, 5, 5, 7, 7 at steps 2 to 10 (12 records each), against the same SFT of 1 and winner of 5. Reading of the 9 (dispositions.md): the locked board has the champion RL pass at 8 and the second lineage fpv2_pass2 at 8; 'Every FIRST RL pass lifts (+3..4); every second/third pass collapses (2-5)'; 'Earlier headline numbers (9, 10, 11, 12) were floors/other-grader readings'. Resolution: one question = 6.25 points; one reading has a standard error of 12.5 points; a 5-point difference at 80% power needs about 1,568 questions per arm. CORRECTION: the reading above that a first-pass lift of 3 to 4 'replicated' rests on old-method boards only (LLM judge, 3-read majority, comparative-grader era); it does not carry to the current method (training prompt, Jev, 200-record runs rl_kl03, rl_lr3e6, rl_replay2), where no run held a gain.</a:t>
+              <a:t>The fixed-scoring sequence is the same one the short talk opened with. Its numbers are quoted as measured at the time; the long runs used a different eval prompt (see slide 26 and slides 15 and 16), so the two are not on one instrument. Scoring detail (dispositions.md, THE LOCKED MECHANISM AND THE UNIFORM BOARD): the checkpoint's greedy answers, each (question, answer) judged ALONE 3 times by the 4B judge, empty or stub answers scored 0 mechanically, the majority of the 3 readings is that question's verdict, and the count of 16 is the phase score. Board, one procedure: base 4, SFT 5, SFT plus one MGPO run on 6 records 9, that plus IPO 5, coverage 4. Training past the first RL update lost in three attempts: 8 to 5 (lr 1e-5, 72 records), 6 to 5 (lr 3e-6, 60 records), 6 to 2 (restart from the better model). The in-run eval reads of the winning pass (RL step 3: 6, step 6: 8, step 9: 7, step 12: 8) come from a different instrument, so they are not on this board. Figure (docs/figures/critical_lifts.png, from data/probe3_locked.json): left panel, base 4, SFT epochs 1/3/5 read 1, 3, 5, then the RL checkpoint trained from SFT (past9_r1a) reads 9; its own in-run readings at steps 3, 6, 9, 12 read 6, 8, 7, 8 (same run, different instrument from the 9). Right panel: the full-coverage campaign's in-run readings 3, 5, 5, 7, 7 at steps 2 to 10 (12 records each), against the same SFT of 1 and winner of 5. Reading of the 9 (dispositions.md): the locked board has the champion RL pass at 8 and the second lineage fpv2_pass2 at 8; 'Every FIRST RL pass lifts (+3..4); every second/third pass collapses (2-5)'; 'Earlier headline numbers (9, 10, 11, 12) were floors/other-grader readings'. Resolution: one question = 6.25 points; one reading has a standard error of 12.5 points; a 5-point difference at 80% power needs about 1,568 questions per arm. CORRECTION: the reading above that a first-pass lift of 3 to 4 'replicated' rests on old-method boards only (LLM judge, 3-read majority, comparative-grader era); it does not carry to the current method (training prompt, Jev, 200-record runs rl_kl03, rl_lr3e6, rl_replay2), where no run held a gain.</a:t>
             </a:r>
           </a:p>
         </p:txBody>
@@ -2354,7 +2354,7 @@
           <a:lstStyle/>
           <a:p>
             <a:r>
-              <a:t>Computation: two-proportion test, p = 0.5, alpha 0.05 two-sided (z 1.96), power 80% (z 0.84), detect 0.05: n per arm = (1.96+0.84)^2 * 2 * 0.25 / 0.05^2 = 1568. Standard error of a proportion at n = 16, p = 0.5: sqrt(0.25/16) = 0.125. This supports the eval-size half of the scale reading only; slide 27 lists the tests that would separate the readings.</a:t>
+              <a:t>Computation: two-proportion test, p = 0.5, alpha 0.05 two-sided (z 1.96), power 80% (z 0.84), detect 0.05: n per arm = (1.96+0.84)^2 * 2 * 0.25 / 0.05^2 = 1568. Standard error of a proportion at n = 16, p = 0.5: sqrt(0.25/16) = 0.125. This supports the eval-size half of the scale reading only; slide 29 lists the tests that would separate the readings.</a:t>
             </a:r>
           </a:p>
         </p:txBody>
@@ -2424,7 +2424,7 @@
           <a:lstStyle/>
           <a:p>
             <a:r>
-              <a:t>Numbers: 16 skills on decision trees and ensembles, 79 chunks, 748 questions that passed a correlation filter (reject any candidate with cosine similarity of 0.80 or more to a kept question; Math 230, Code 179, Instruction 172, STEM 167). CORRECTED 2026-10-02: an earlier version said 240 kept; 240 is the size of each phase set. Partition (src/partition_r3_pools.py): 12 rubric examples, 16 eval, 240 CPT, 240 SFT, 240 RL, with no spare. The 16 eval questions are frozen and never trained on. From 2026-09-27 the RL runs held out a further 40 records (200 train, 40 held out, stratified by category, seed 7). Reward under the LLM judge: 0 / 0.5 / 1 by judge score (0.70 passing, 0.90 high quality), gated by correctness (SETTLED.md). Under Jev (from 2026-09-26) it is 0 or 1, since Jev answers yes/no. Framing: concepts MDP Formulation Checklist, Dynamic System vs Environment Wrapper, State vs Observation. Pipeline as run: SFT then RL for all long runs (rl_kl03, rl_lr3e6, rl_replay2 start from the SFT checkpoint sft_book1e5/sft_full_epoch1; see docs/run-logs). CPT was tested separately and dropped (slide 25).</a:t>
+              <a:t>Numbers: 16 skills on decision trees and ensembles, 79 chunks, 748 questions that passed a correlation filter (reject any candidate with cosine similarity of 0.80 or more to a kept question; Math 230, Code 179, Instruction 172, STEM 167). CORRECTED 2026-10-02: an earlier version said 240 kept; 240 is the size of each phase set. Partition (src/partition_r3_pools.py): 12 rubric examples, 16 eval, 240 CPT, 240 SFT, 240 RL, with no spare. The 16 eval questions are frozen and never trained on. From 2026-09-27 the RL runs held out a further 40 records (200 train, 40 held out, stratified by category, seed 7). Reward under the LLM judge: 0 / 0.5 / 1 by judge score (0.70 passing, 0.90 high quality), gated by correctness (SETTLED.md). Under Jev (from 2026-09-26) it is 0 or 1, since Jev answers yes/no. Framing: concepts MDP Formulation Checklist, Dynamic System vs Environment Wrapper, State vs Observation. Pipeline as run: SFT then RL for all long runs (rl_kl03, rl_lr3e6, rl_replay2 start from the SFT checkpoint sft_book1e5/sft_full_epoch1; see docs/run-logs). CPT was tested separately and dropped (slide 27).</a:t>
             </a:r>
           </a:p>
         </p:txBody>
@@ -10959,7 +10959,7 @@
                 </a:solidFill>
                 <a:latin typeface="Calibri"/>
               </a:rPr>
-              <a:t>Source: dispositions.md: rl_nowm, rl_k, rl_kl03, rl_lr3e6 (09-23 to 09-25); crossing-run correction 3  ·  figure: slide 29</a:t>
+              <a:t>Source: dispositions.md: rl_nowm, rl_k, rl_kl03, rl_lr3e6 (09-23 to 09-25); crossing-run correction 3  ·  figure: slide 15</a:t>
             </a:r>
           </a:p>
         </p:txBody>
@@ -11809,7 +11809,7 @@
                 </a:solidFill>
                 <a:latin typeface="Consolas"/>
               </a:rPr>
-              <a:t>ENTRY 7 · THE SHAPE OF A GOOD RUN</a:t>
+              <a:t>LONG RUNS · ENTRY 7 · THE SHAPE OF A GOOD RUN</a:t>
             </a:r>
           </a:p>
         </p:txBody>
@@ -13134,7 +13134,7 @@
                 </a:solidFill>
                 <a:latin typeface="Calibri"/>
               </a:rPr>
-              <a:t>Source: dispositions.md: "REPLAY SAMPLER" (09-24), "rl_replay2" (09-25 to 09-26)  ·  figure: slide 30</a:t>
+              <a:t>Source: dispositions.md: "REPLAY SAMPLER" (09-24), "rl_replay2" (09-25 to 09-26)  ·  figure: slide 16</a:t>
             </a:r>
           </a:p>
         </p:txBody>
@@ -20057,7 +20057,7 @@
                 </a:solidFill>
                 <a:latin typeface="Consolas"/>
               </a:rPr>
-              <a:t>APPENDIX · THE 60-STEP RUN</a:t>
+              <a:t>LONG RUNS · THE 60-STEP RUN</a:t>
             </a:r>
           </a:p>
         </p:txBody>
@@ -21142,7 +21142,7 @@
                 </a:solidFill>
                 <a:latin typeface="Consolas"/>
               </a:rPr>
-              <a:t>APPENDIX · THE REPLAY SAMPLER</a:t>
+              <a:t>LONG RUNS · THE REPLAY SAMPLER</a:t>
             </a:r>
           </a:p>
         </p:txBody>
@@ -21690,7 +21690,7 @@
                 </a:solidFill>
                 <a:latin typeface="Calibri"/>
               </a:rPr>
-              <a:t>The current method (training prompt, Jev judge, long runs on slides 29 and 30) never beat 9 and never held a gain. One question is 6.25 points, so 16 questions cannot size a lift either way.</a:t>
+              <a:t>The current method (training prompt, Jev judge, long runs on slides 15 and 16) never beat 9 and never held a gain. One question is 6.25 points, so 16 questions cannot size a lift either way.</a:t>
             </a:r>
           </a:p>
           <a:p>
@@ -21706,7 +21706,7 @@
                 </a:solidFill>
                 <a:latin typeface="Calibri"/>
               </a:rPr>
-              <a:t>The two methods are not comparable: the 9 was not re-read under the training prompt (slide 24).</a:t>
+              <a:t>The two methods are not comparable: the 9 was not re-read under the training prompt (slide 26).</a:t>
             </a:r>
           </a:p>
         </p:txBody>

</xml_diff>

<commit_message>
RL deck slide 18: plainer result labels
Co-Authored-By: Claude Sonnet 5.5 <noreply@anthropic.com>
</commit_message>
<xml_diff>
--- a/docs/RL_V2_rl.pptx
+++ b/docs/RL_V2_rl.pptx
@@ -10841,13 +10841,13 @@
           <a:lstStyle/>
           <a:p>
             <a:r>
-              <a:rPr sz="1600" b="0">
+              <a:rPr sz="1400" b="0">
                 <a:solidFill>
                   <a:srgbClr val="4A5864"/>
                 </a:solidFill>
                 <a:latin typeface="Calibri"/>
               </a:rPr>
-              <a:t>of records split right and wrong: base versus SFT epoch 2, same records, same judge</a:t>
+              <a:t>Records the model gets right some tries and wrong others. Base 10%, after SFT 38% (20 and 16 records, so rough). SFT makes records RL can learn from.</a:t>
             </a:r>
           </a:p>
         </p:txBody>
@@ -10909,13 +10909,13 @@
           <a:lstStyle/>
           <a:p>
             <a:r>
-              <a:rPr sz="1600" b="0">
+              <a:rPr sz="1400" b="0">
                 <a:solidFill>
                   <a:srgbClr val="4A5864"/>
                 </a:solidFill>
                 <a:latin typeface="Calibri"/>
               </a:rPr>
-              <a:t>mixed rate, epoch 3 versus epoch 2 (24 records, so about two records apart)</a:t>
+              <a:t>Same share at SFT epoch 3 vs epoch 2, on the same 24 records. About two records apart, so epoch 3 is only slightly ahead.</a:t>
             </a:r>
           </a:p>
         </p:txBody>
@@ -10977,13 +10977,13 @@
           <a:lstStyle/>
           <a:p>
             <a:r>
-              <a:rPr sz="1600" b="0">
+              <a:rPr sz="1400" b="0">
                 <a:solidFill>
                   <a:srgbClr val="4A5864"/>
                 </a:solidFill>
                 <a:latin typeface="Calibri"/>
               </a:rPr>
-              <a:t>of 16 on the eval, epoch 3 versus epoch 2: the two criteria disagree</a:t>
+              <a:t>Eval score out of 16: epoch 3 got 5, epoch 2 got 7. The half-known share picks epoch 3; the eval prefers epoch 2.</a:t>
             </a:r>
           </a:p>
         </p:txBody>

</xml_diff>

<commit_message>
RL deck slide 19: plainer result labels
Co-Authored-By: Claude Sonnet 5.5 <noreply@anthropic.com>
</commit_message>
<xml_diff>
--- a/docs/RL_V2_rl.pptx
+++ b/docs/RL_V2_rl.pptx
@@ -11685,13 +11685,13 @@
           <a:lstStyle/>
           <a:p>
             <a:r>
-              <a:rPr sz="1600" b="0">
+              <a:rPr sz="1400" b="0">
                 <a:solidFill>
                   <a:srgbClr val="4A5864"/>
                 </a:solidFill>
                 <a:latin typeface="Calibri"/>
               </a:rPr>
-              <a:t>of 1,752 judged answers paid exactly 0.0 under the bands (1,522 answers)</a:t>
+              <a:t>of 1,752 judged answers got reward 0 (1,522 answers). Only 9.3% got full reward, so most answers in a group scored the same.</a:t>
             </a:r>
           </a:p>
         </p:txBody>
@@ -11753,13 +11753,13 @@
           <a:lstStyle/>
           <a:p>
             <a:r>
-              <a:rPr sz="1600" b="0">
+              <a:rPr sz="1400" b="0">
                 <a:solidFill>
                   <a:srgbClr val="4A5864"/>
                 </a:solidFill>
                 <a:latin typeface="Calibri"/>
               </a:rPr>
-              <a:t>judged groups per filled slot as training ran: 73 up to 103 draws for 16 slots</a:t>
+              <a:t>Prompts tried to fill each training slot, with bands. A slot needs a prompt whose answers differ: 73 tried for 16 slots early (4.6×), 103 later (6.4×).</a:t>
             </a:r>
           </a:p>
         </p:txBody>
@@ -11821,13 +11821,13 @@
           <a:lstStyle/>
           <a:p>
             <a:r>
-              <a:rPr sz="1600" b="0">
+              <a:rPr sz="1400" b="0">
                 <a:solidFill>
                   <a:srgbClr val="4A5864"/>
                 </a:solidFill>
                 <a:latin typeface="Calibri"/>
               </a:rPr>
-              <a:t>with the raw judge score, same seed and base: 32 draws for 16 slots</a:t>
+              <a:t>Same seed and base with the raw judge score instead of bands: 32 prompts tried for 16 slots.</a:t>
             </a:r>
           </a:p>
         </p:txBody>

</xml_diff>

<commit_message>
RL deck slides 20 to 30: plain-language captions, consistent counts
Co-Authored-By: Claude Sonnet 5.5 <noreply@anthropic.com>
</commit_message>
<xml_diff>
--- a/docs/RL_V2_rl.pptx
+++ b/docs/RL_V2_rl.pptx
@@ -12815,7 +12815,7 @@
                 </a:solidFill>
                 <a:latin typeface="Calibri"/>
               </a:rPr>
-              <a:t>Same pool and judge, SFT checkpoint start (no CPT). KL beta 0, 0.001, 0.3 and 0.02; learning rate 1e-5 and 3e-6. Watch raw KL, entropy and the answer text each step.</a:t>
+              <a:t>Same pool and judge, SFT checkpoint start (no CPT). KL beta 0, 0.001, 0.3, 0.02; learning rate 1e-5, 3e-6. Watch raw KL (drift from SFT), entropy and answers each step.</a:t>
             </a:r>
           </a:p>
         </p:txBody>
@@ -13210,7 +13210,7 @@
                           </a:solidFill>
                           <a:latin typeface="Calibri"/>
                         </a:rPr>
-                        <a:t>0.02, other form</a:t>
+                        <a:t>0.02, different KL formula</a:t>
                       </a:r>
                     </a:p>
                   </a:txBody>
@@ -13254,7 +13254,7 @@
                           </a:solidFill>
                           <a:latin typeface="Calibri"/>
                         </a:rPr>
-                        <a:t>the crossing run: no runaway in 30 steps</a:t>
+                        <a:t>the run where solved passed mixed (slide 14): no runaway in 30 steps</a:t>
                       </a:r>
                     </a:p>
                   </a:txBody>
@@ -14102,7 +14102,7 @@
                 </a:solidFill>
                 <a:latin typeface="Calibri"/>
               </a:rPr>
-              <a:t>Three variants from the same SFT start. Pre-registered bar for the reuse variant: 5 of 16 by the step with 46 updates.</a:t>
+              <a:t>Three variants from the same SFT start. Bar set in advance for the reuse variant: 5 of 16 by the step with 46 updates.</a:t>
             </a:r>
           </a:p>
         </p:txBody>
@@ -14292,7 +14292,7 @@
                           </a:solidFill>
                           <a:latin typeface="Calibri"/>
                         </a:rPr>
-                        <a:t>dropped 2/6 to 4/6 per round; never ablated</a:t>
+                        <a:t>dropped 2 to 4 of every 6 prompts per round; never tested without it</a:t>
                       </a:r>
                     </a:p>
                   </a:txBody>
@@ -14316,7 +14316,7 @@
                           </a:solidFill>
                           <a:latin typeface="Calibri"/>
                         </a:rPr>
-                        <a:t>Flashcard priority</a:t>
+                        <a:t>Flashcard priority (revisit uncertain records more)</a:t>
                       </a:r>
                     </a:p>
                   </a:txBody>
@@ -14338,7 +14338,7 @@
                           </a:solidFill>
                           <a:latin typeface="Calibri"/>
                         </a:rPr>
-                        <a:t>in the best pass; replay-clock defect fixed</a:t>
+                        <a:t>used in the best earlier pass; a counting bug was fixed</a:t>
                       </a:r>
                     </a:p>
                   </a:txBody>
@@ -14362,7 +14362,7 @@
                           </a:solidFill>
                           <a:latin typeface="Calibri"/>
                         </a:rPr>
-                        <a:t>Reuse judged answers, clipped ratio</a:t>
+                        <a:t>Reuse judged answers up to 5 steps old</a:t>
                       </a:r>
                     </a:p>
                   </a:txBody>
@@ -14384,7 +14384,7 @@
                           </a:solidFill>
                           <a:latin typeface="Calibri"/>
                         </a:rPr>
-                        <a:t>eval 3/16 at the bar (need 5); KL 0.86, aborted at step 24</a:t>
+                        <a:t>scored 3 of 16, needed 5; stopped at step 24 when the model had drifted too far (KL 0.86)</a:t>
                       </a:r>
                     </a:p>
                   </a:txBody>
@@ -14428,7 +14428,7 @@
                 </a:solidFill>
                 <a:latin typeface="Calibri"/>
               </a:rPr>
-              <a:t>RL theory concepts: replay decorrelates consecutive steps. Here the 16 records per step are independent, so only reuse was left, and reused answers went stale within 5 steps (mean log-ratio 0.23 → 0.77).</a:t>
+              <a:t>Replay normally breaks up correlated steps. Here the 16 records per step are already independent, so only reuse was left, and reused answers went stale within 5 steps.</a:t>
             </a:r>
           </a:p>
         </p:txBody>
@@ -14986,7 +14986,7 @@
                 </a:solidFill>
                 <a:latin typeface="Calibri"/>
               </a:rPr>
-              <a:t>5-network ensemble predicts the verdict. Ask the real judge with probability min(1, D × spread ÷ median spread): disagreement means ask.</a:t>
+              <a:t>5 small networks predict the judge's verdict. The more they disagree on an answer, the more likely the real judge is asked.</a:t>
             </a:r>
           </a:p>
         </p:txBody>
@@ -15136,7 +15136,7 @@
                 </a:solidFill>
                 <a:latin typeface="Calibri"/>
               </a:rPr>
-              <a:t>spread of a group's 4 answers: world model versus the real judge</a:t>
+              <a:t>how much the 4 answers in a group differed in score: world model vs real judge. The world model scored them nearly alike.</a:t>
             </a:r>
           </a:p>
         </p:txBody>
@@ -15204,7 +15204,7 @@
                 </a:solidFill>
                 <a:latin typeface="Calibri"/>
               </a:rPr>
-              <a:t>visits scored all-wrong: modelled versus judged</a:t>
+              <a:t>of visits where every answer scored wrong: world model vs real judge</a:t>
             </a:r>
           </a:p>
         </p:txBody>
@@ -15272,7 +15272,7 @@
                 </a:solidFill>
                 <a:latin typeface="Calibri"/>
               </a:rPr>
-              <a:t>correct on the 220-item receipt after 13 steps; intervals overlap</a:t>
+              <a:t>correct out of 220 questions, SFT start vs after 13 steps. Within noise.</a:t>
             </a:r>
           </a:p>
         </p:txBody>
@@ -15741,7 +15741,7 @@
                 </a:solidFill>
                 <a:latin typeface="Calibri"/>
               </a:rPr>
-              <a:t>Open-Jev-2B, served locally; the reference answer goes with every prompt; reward 1 if p(yes) is 0.5 or more. It agreed with the 9B judge on 105 of 150 answers.</a:t>
+              <a:t>Open-Jev-2B, served locally; the reference answer goes with every prompt; reward 1 if its yes-probability is 0.5 or more. It agreed with the 9B judge on 105 of 150 answers.</a:t>
             </a:r>
           </a:p>
         </p:txBody>
@@ -15931,7 +15931,7 @@
                           </a:solidFill>
                           <a:latin typeface="Calibri"/>
                         </a:rPr>
-                        <a:t>scored correct on 40 of 60 golds; RL collapsed to 2-token answers</a:t>
+                        <a:t>scored correct on 40 of 60 reference answers; RL collapsed to 2-token answers</a:t>
                       </a:r>
                     </a:p>
                   </a:txBody>
@@ -15955,7 +15955,7 @@
                           </a:solidFill>
                           <a:latin typeface="Calibri"/>
                         </a:rPr>
-                        <a:t>"1" after the numeric gate</a:t>
+                        <a:t>"1" after a numeric-answer check</a:t>
                       </a:r>
                     </a:p>
                   </a:txBody>
@@ -16047,7 +16047,7 @@
                           </a:solidFill>
                           <a:latin typeface="Calibri"/>
                         </a:rPr>
-                        <a:t>Jev scoring its own gold</a:t>
+                        <a:t>Jev scoring its own reference answer</a:t>
                       </a:r>
                     </a:p>
                   </a:txBody>
@@ -16069,7 +16069,7 @@
                           </a:solidFill>
                           <a:latin typeface="Calibri"/>
                         </a:rPr>
-                        <a:t>rejected 19 of 253 golds (8%)</a:t>
+                        <a:t>rejected 19 of 253 (8%)</a:t>
                       </a:r>
                     </a:p>
                   </a:txBody>
@@ -16214,7 +16214,7 @@
                 </a:solidFill>
                 <a:latin typeface="Calibri"/>
               </a:rPr>
-              <a:t>As a drop-in reward: the echoes made the eval read 0.250 → 0.594; with the guard it read 0.039. Probe a judge with stubs, echoes and its own golds first.</a:t>
+              <a:t>As a drop-in reward: answers that repeated the question made the eval read 0.250 → 0.594; with a repeat filter it read 0.039. Probe a judge with stubs, echoes and its own reference answers first.</a:t>
             </a:r>
           </a:p>
         </p:txBody>
@@ -16548,7 +16548,7 @@
                 </a:solidFill>
                 <a:latin typeface="Calibri"/>
               </a:rPr>
-              <a:t>200 records trained, 40 held out; 3-visit cap; 8 answers per question; start and end scored in one invocation, echo guard on.</a:t>
+              <a:t>200 records trained, 40 held out; each record visited at most 3 times; 8 answers per question; start and end scored in the same run, repeat filter on.</a:t>
             </a:r>
           </a:p>
         </p:txBody>
@@ -16698,7 +16698,7 @@
                 </a:solidFill>
                 <a:latin typeface="Calibri"/>
               </a:rPr>
-              <a:t>accuracy on revisited records by step 17, each against its own first visit</a:t>
+              <a:t>accuracy on records seen again, against the same record's first visit, by step 17</a:t>
             </a:r>
           </a:p>
         </p:txBody>
@@ -16766,7 +16766,7 @@
                 </a:solidFill>
                 <a:latin typeface="Calibri"/>
               </a:rPr>
-              <a:t>first-visit accuracy, first fifth of the run versus last fifth</a:t>
+              <a:t>accuracy the first time a record is seen, first fifth of the run vs last fifth: no better on new records</a:t>
             </a:r>
           </a:p>
         </p:txBody>
@@ -16834,7 +16834,7 @@
                 </a:solidFill>
                 <a:latin typeface="Calibri"/>
               </a:rPr>
-              <a:t>eval, best-solved weights versus the SFT start (held-out: 79 → 73 of 320)</a:t>
+              <a:t>eval answers correct (16 questions × 8 answers), SFT start vs after RL. Held-out questions: 79 → 73 of 320.</a:t>
             </a:r>
           </a:p>
         </p:txBody>
@@ -17029,7 +17029,7 @@
                 </a:solidFill>
                 <a:latin typeface="Consolas"/>
               </a:rPr>
-              <a:t>EVIDENCE FOR READING 1</a:t>
+              <a:t>SYNTHESIS · DEFECTS IN HOW WE RAN IT</a:t>
             </a:r>
           </a:p>
         </p:txBody>
@@ -17364,7 +17364,7 @@
                           </a:solidFill>
                           <a:latin typeface="Calibri"/>
                         </a:rPr>
-                        <a:t>a bare "1" paid on 40 of 60 golds; echo share reached 49%</a:t>
+                        <a:t>a bare "1" paid on 40 of 60 reference answers; echo share reached 49%</a:t>
                       </a:r>
                     </a:p>
                   </a:txBody>
@@ -17410,7 +17410,7 @@
                           </a:solidFill>
                           <a:latin typeface="Calibri"/>
                         </a:rPr>
-                        <a:t>Visit cap counted draws, not training</a:t>
+                        <a:t>Visit cap counted draws, not times trained on</a:t>
                       </a:r>
                     </a:p>
                   </a:txBody>
@@ -17432,7 +17432,7 @@
                           </a:solidFill>
                           <a:latin typeface="Calibri"/>
                         </a:rPr>
-                        <a:t>114 of 197 records never produced a mixed group</a:t>
+                        <a:t>112 of 197 records never produced a mixed group</a:t>
                       </a:r>
                     </a:p>
                   </a:txBody>
@@ -18016,7 +18016,7 @@
                           </a:solidFill>
                           <a:latin typeface="Calibri"/>
                         </a:rPr>
-                        <a:t>lost 0.06 to 0.27 on every route</a:t>
+                        <a:t>lost 0.06 to 0.27 of accuracy on every route</a:t>
                       </a:r>
                     </a:p>
                   </a:txBody>
@@ -18220,7 +18220,7 @@
                           </a:solidFill>
                           <a:latin typeface="Calibri"/>
                         </a:rPr>
-                        <a:t>off or thin: blow-up at step 19</a:t>
+                        <a:t>KL off or thin: blow-up at step 19</a:t>
                       </a:r>
                     </a:p>
                   </a:txBody>
@@ -18356,7 +18356,7 @@
                           </a:solidFill>
                           <a:latin typeface="Calibri"/>
                         </a:rPr>
-                        <a:t>paid stubs and echoes; rejected 8% of golds</a:t>
+                        <a:t>paid stubs and echoes; rejected 8% of reference answers</a:t>
                       </a:r>
                     </a:p>
                   </a:txBody>
@@ -18781,7 +18781,7 @@
                 </a:solidFill>
                 <a:latin typeface="Calibri"/>
               </a:rPr>
-              <a:t>Five real defects: eval prompt, constant reward, judge exploits, cap, counters.</a:t>
+              <a:t>Four real defects: eval prompt, constant reward, judge exploits, visit cap.</a:t>
             </a:r>
           </a:p>
           <a:p>
@@ -18996,7 +18996,7 @@
                 </a:solidFill>
                 <a:latin typeface="Calibri"/>
               </a:rPr>
-              <a:t>112 of 197 records never split; 9 of 16 held-out questions never solved by any checkpoint; 16 questions resolve about one.</a:t>
+              <a:t>112 of 197 records never split; 9 of 16 held-out questions never solved by any checkpoint; a 16-question eval has a standard error of 12.5 points.</a:t>
             </a:r>
           </a:p>
           <a:p>
@@ -19028,7 +19028,7 @@
                 </a:solidFill>
                 <a:latin typeface="Calibri"/>
               </a:rPr>
-              <a:t>Nothing yet. It was never run at 30,000.</a:t>
+              <a:t>Nothing yet. It was never run at scale.</a:t>
             </a:r>
           </a:p>
           <a:p>
@@ -19918,7 +19918,7 @@
                 </a:solidFill>
                 <a:latin typeface="Calibri"/>
               </a:rPr>
-              <a:t>Rerun the crossing recipe exactly (its base, KL 0.02, k1) on the fixed trainer, with the guards.</a:t>
+              <a:t>Rerun the recipe of the run where solved passed mixed (slide 14) exactly: its base, KL 0.02, KL formula k1, on the fixed trainer with the guards.</a:t>
             </a:r>
           </a:p>
         </p:txBody>
@@ -20976,7 +20976,7 @@
                 </a:solidFill>
                 <a:latin typeface="Calibri"/>
               </a:rPr>
-              <a:t>16 questions, and the same seed read 6/16 then 7/16. Now: 8 answers per question, one invocation per comparison.</a:t>
+              <a:t>16 questions, and the same seed read 6/16 then 7/16. Now: 8 answers per question, one run per comparison.</a:t>
             </a:r>
           </a:p>
         </p:txBody>
@@ -21079,7 +21079,7 @@
                 </a:solidFill>
                 <a:latin typeface="Calibri"/>
               </a:rPr>
-              <a:t>Stubs, echoes and its own golds. A bare "1" paid on 40 of 60 golds.</a:t>
+              <a:t>Stubs, echoes and its own reference answers. A bare "1" paid on 40 of 60 reference answers.</a:t>
             </a:r>
           </a:p>
         </p:txBody>

</xml_diff>

<commit_message>
RL deck slide 19: say what a usable prompt and a slot are
Co-Authored-By: Claude Sonnet 5.5 <noreply@anthropic.com>
</commit_message>
<xml_diff>
--- a/docs/RL_V2_rl.pptx
+++ b/docs/RL_V2_rl.pptx
@@ -11541,7 +11541,7 @@
                 </a:solidFill>
                 <a:latin typeface="Calibri"/>
               </a:rPr>
-              <a:t>Count reward values over 1,752 judged answers from the campaign's own runs. Compare judged groups per filled slot, banded versus raw score.</a:t>
+              <a:t>Each step needs 16 usable prompts: ones whose 4 answers get different scores. Count prompts judged per 16 usable, bands vs raw judge score.</a:t>
             </a:r>
           </a:p>
         </p:txBody>
@@ -11759,7 +11759,7 @@
                 </a:solidFill>
                 <a:latin typeface="Calibri"/>
               </a:rPr>
-              <a:t>Prompts tried to fill each training slot, with bands. A slot needs a prompt whose answers differ: 73 tried for 16 slots early (4.6×), 103 later (6.4×).</a:t>
+              <a:t>prompts judged per usable prompt, with bands: 73 judged to fill 16 slots (4.6×), later 103 (6.4×). The rest were thrown away.</a:t>
             </a:r>
           </a:p>
         </p:txBody>
@@ -11827,7 +11827,7 @@
                 </a:solidFill>
                 <a:latin typeface="Calibri"/>
               </a:rPr>
-              <a:t>Same seed and base with the raw judge score instead of bands: 32 prompts tried for 16 slots.</a:t>
+              <a:t>with the raw judge score: 32 judged to fill the same 16 slots (2.0×). Same seed and base.</a:t>
             </a:r>
           </a:p>
         </p:txBody>

</xml_diff>

<commit_message>
RL deck slide 19: self-contained result captions
Co-Authored-By: Claude Sonnet 5.5 <noreply@anthropic.com>
</commit_message>
<xml_diff>
--- a/docs/RL_V2_rl.pptx
+++ b/docs/RL_V2_rl.pptx
@@ -11670,8 +11670,8 @@
         </p:nvSpPr>
         <p:spPr>
           <a:xfrm>
-            <a:off x="8119872" y="2148840"/>
-            <a:ext cx="3065983" cy="960120"/>
+            <a:off x="7620000" y="2148840"/>
+            <a:ext cx="3565855" cy="960120"/>
           </a:xfrm>
           <a:prstGeom prst="rect">
             <a:avLst/>
@@ -11738,8 +11738,8 @@
         </p:nvSpPr>
         <p:spPr>
           <a:xfrm>
-            <a:off x="8119872" y="3108960"/>
-            <a:ext cx="3065983" cy="960120"/>
+            <a:off x="7620000" y="3108960"/>
+            <a:ext cx="3565855" cy="960120"/>
           </a:xfrm>
           <a:prstGeom prst="rect">
             <a:avLst/>
@@ -11759,7 +11759,7 @@
                 </a:solidFill>
                 <a:latin typeface="Calibri"/>
               </a:rPr>
-              <a:t>prompts judged per usable prompt, with bands: 73 judged to fill 16 slots (4.6×), later 103 (6.4×). The rest were thrown away.</a:t>
+              <a:t>judge calls per usable prompt, with bands. A usable prompt has 4 answers that differ. 73 judged to get 16, later 103 to get 16.</a:t>
             </a:r>
           </a:p>
         </p:txBody>
@@ -11806,8 +11806,8 @@
         </p:nvSpPr>
         <p:spPr>
           <a:xfrm>
-            <a:off x="8119872" y="4069080"/>
-            <a:ext cx="3065983" cy="960120"/>
+            <a:off x="7620000" y="4069080"/>
+            <a:ext cx="3565855" cy="960120"/>
           </a:xfrm>
           <a:prstGeom prst="rect">
             <a:avLst/>
@@ -11827,7 +11827,7 @@
                 </a:solidFill>
                 <a:latin typeface="Calibri"/>
               </a:rPr>
-              <a:t>with the raw judge score: 32 judged to fill the same 16 slots (2.0×). Same seed and base.</a:t>
+              <a:t>same count with the raw judge score: 32 judged to get 16. Bands cost 2 to 3 times as many judge calls.</a:t>
             </a:r>
           </a:p>
         </p:txBody>

</xml_diff>

<commit_message>
RL deck slide 19: define the bands on the slide
Co-Authored-By: Claude Sonnet 5.5 <noreply@anthropic.com>
</commit_message>
<xml_diff>
--- a/docs/RL_V2_rl.pptx
+++ b/docs/RL_V2_rl.pptx
@@ -11438,7 +11438,7 @@
                 </a:solidFill>
                 <a:latin typeface="Calibri"/>
               </a:rPr>
-              <a:t>Gating quality by correctness (bands 0, 0.5, 1) gives RL a usable learning signal.</a:t>
+              <a:t>The judge scores each answer 0 to 1. Bands pay a step instead: 0 below 0.70, 0.5 from 0.70, 1 from 0.90. Hypothesis: bands give RL a usable learning signal.</a:t>
             </a:r>
           </a:p>
         </p:txBody>
@@ -11541,7 +11541,7 @@
                 </a:solidFill>
                 <a:latin typeface="Calibri"/>
               </a:rPr>
-              <a:t>Each step needs 16 usable prompts: ones whose 4 answers get different scores. Count prompts judged per 16 usable, bands vs raw judge score.</a:t>
+              <a:t>Each step needs 16 usable prompts: ones whose 4 answers get different rewards. Count prompts judged per 16 usable, bands vs the raw judge score paid as is.</a:t>
             </a:r>
           </a:p>
         </p:txBody>

</xml_diff>

<commit_message>
RL deck slide 19: usable means not all the same
Co-Authored-By: Claude Sonnet 5.5 <noreply@anthropic.com>
</commit_message>
<xml_diff>
--- a/docs/RL_V2_rl.pptx
+++ b/docs/RL_V2_rl.pptx
@@ -11541,7 +11541,7 @@
                 </a:solidFill>
                 <a:latin typeface="Calibri"/>
               </a:rPr>
-              <a:t>Each step needs 16 usable prompts: ones whose 4 answers get different rewards. Count prompts judged per 16 usable, bands vs the raw judge score paid as is.</a:t>
+              <a:t>Each step needs 16 usable prompts: ones whose 4 answers are not all rewarded the same. Count prompts judged per 16 usable, bands vs the raw judge score paid as is.</a:t>
             </a:r>
           </a:p>
         </p:txBody>
@@ -11759,7 +11759,7 @@
                 </a:solidFill>
                 <a:latin typeface="Calibri"/>
               </a:rPr>
-              <a:t>judge calls per usable prompt, with bands. A usable prompt has 4 answers that differ. 73 judged to get 16, later 103 to get 16.</a:t>
+              <a:t>judge calls per usable prompt, with bands. Usable: the 4 answers are not all scored the same. 73 judged to get 16, later 103 to get 16.</a:t>
             </a:r>
           </a:p>
         </p:txBody>

</xml_diff>

<commit_message>
RL deck slide 19: rebuild the result as cause then cost
Co-Authored-By: Claude Sonnet 5.5 <noreply@anthropic.com>
</commit_message>
<xml_diff>
--- a/docs/RL_V2_rl.pptx
+++ b/docs/RL_V2_rl.pptx
@@ -11541,7 +11541,7 @@
                 </a:solidFill>
                 <a:latin typeface="Calibri"/>
               </a:rPr>
-              <a:t>Each step needs 16 usable prompts: ones whose 4 answers are not all rewarded the same. Count prompts judged per 16 usable, bands vs the raw judge score paid as is.</a:t>
+              <a:t>A step trains on 16 prompts, 4 answers each. A prompt whose answers all earn the same reward teaches nothing and is dropped. Count prompts judged per step.</a:t>
             </a:r>
           </a:p>
         </p:txBody>
@@ -11691,7 +11691,7 @@
                 </a:solidFill>
                 <a:latin typeface="Calibri"/>
               </a:rPr>
-              <a:t>of 1,752 judged answers got reward 0 (1,522 answers). Only 9.3% got full reward, so most answers in a group scored the same.</a:t>
+              <a:t>of 1,752 judged answers earned reward 0 under bands (1,522). So most groups of 4 were all zeros, and identical rewards teach nothing.</a:t>
             </a:r>
           </a:p>
         </p:txBody>
@@ -11725,7 +11725,7 @@
                 </a:solidFill>
                 <a:latin typeface="Georgia"/>
               </a:rPr>
-              <a:t>4.6× → 6.4×</a:t>
+              <a:t>73 → 16</a:t>
             </a:r>
           </a:p>
         </p:txBody>
@@ -11759,7 +11759,7 @@
                 </a:solidFill>
                 <a:latin typeface="Calibri"/>
               </a:rPr>
-              <a:t>judge calls per usable prompt, with bands. Usable: the 4 answers are not all scored the same. 73 judged to get 16, later 103 to get 16.</a:t>
+              <a:t>Bands: 73 prompts judged to find 16 whose answers differed. The other 57 were thrown away. Later steps needed 103.</a:t>
             </a:r>
           </a:p>
         </p:txBody>
@@ -11793,7 +11793,7 @@
                 </a:solidFill>
                 <a:latin typeface="Georgia"/>
               </a:rPr>
-              <a:t>2.0×</a:t>
+              <a:t>32 → 16</a:t>
             </a:r>
           </a:p>
         </p:txBody>
@@ -11827,7 +11827,7 @@
                 </a:solidFill>
                 <a:latin typeface="Calibri"/>
               </a:rPr>
-              <a:t>with the raw judge score: 32 prompts judged to get the same 16. Bands needed 73 to 103, about 2 to 3 times as much judging.</a:t>
+              <a:t>Raw judge score, same seed and base: 32 judged to find 16. Same step, less than half the judging.</a:t>
             </a:r>
           </a:p>
         </p:txBody>
@@ -11962,7 +11962,7 @@
                 </a:solidFill>
                 <a:latin typeface="Calibri"/>
               </a:rPr>
-              <a:t>Seven answers in eight paid the same reward, so most groups had no gradient. The raw score removed the waste; it did not produce lift (entry 12).</a:t>
+              <a:t>Seven answers in eight paid the same reward, so most groups had no gradient. The raw score cut the waste by more than half; it did not produce lift (entry 12).</a:t>
             </a:r>
           </a:p>
         </p:txBody>

</xml_diff>

<commit_message>
RL deck slide 19: worked example table
Co-Authored-By: Claude Sonnet 5.5 <noreply@anthropic.com>
</commit_message>
<xml_diff>
--- a/docs/RL_V2_rl.pptx
+++ b/docs/RL_V2_rl.pptx
@@ -11630,210 +11630,6 @@
       </p:sp>
       <p:sp>
         <p:nvSpPr>
-          <p:cNvPr id="11" name="TextBox 10"/>
-          <p:cNvSpPr txBox="1"/>
-          <p:nvPr/>
-        </p:nvSpPr>
-        <p:spPr>
-          <a:xfrm>
-            <a:off x="5285232" y="2148840"/>
-            <a:ext cx="2697480" cy="960120"/>
-          </a:xfrm>
-          <a:prstGeom prst="rect">
-            <a:avLst/>
-          </a:prstGeom>
-          <a:noFill/>
-        </p:spPr>
-        <p:txBody>
-          <a:bodyPr wrap="square" lIns="0" rIns="0" tIns="0" bIns="0" anchor="ctr">
-            <a:spAutoFit/>
-          </a:bodyPr>
-          <a:lstStyle/>
-          <a:p>
-            <a:r>
-              <a:rPr sz="2800" b="1">
-                <a:solidFill>
-                  <a:srgbClr val="B94E08"/>
-                </a:solidFill>
-                <a:latin typeface="Georgia"/>
-              </a:rPr>
-              <a:t>86.9%</a:t>
-            </a:r>
-          </a:p>
-        </p:txBody>
-      </p:sp>
-      <p:sp>
-        <p:nvSpPr>
-          <p:cNvPr id="12" name="TextBox 11"/>
-          <p:cNvSpPr txBox="1"/>
-          <p:nvPr/>
-        </p:nvSpPr>
-        <p:spPr>
-          <a:xfrm>
-            <a:off x="7620000" y="2148840"/>
-            <a:ext cx="3565855" cy="960120"/>
-          </a:xfrm>
-          <a:prstGeom prst="rect">
-            <a:avLst/>
-          </a:prstGeom>
-          <a:noFill/>
-        </p:spPr>
-        <p:txBody>
-          <a:bodyPr wrap="square" lIns="0" rIns="0" tIns="0" bIns="0" anchor="ctr">
-            <a:spAutoFit/>
-          </a:bodyPr>
-          <a:lstStyle/>
-          <a:p>
-            <a:r>
-              <a:rPr sz="1400" b="0">
-                <a:solidFill>
-                  <a:srgbClr val="4A5864"/>
-                </a:solidFill>
-                <a:latin typeface="Calibri"/>
-              </a:rPr>
-              <a:t>of 1,752 judged answers earned reward 0 under bands (1,522). So most groups of 4 were all zeros, and identical rewards teach nothing.</a:t>
-            </a:r>
-          </a:p>
-        </p:txBody>
-      </p:sp>
-      <p:sp>
-        <p:nvSpPr>
-          <p:cNvPr id="13" name="TextBox 12"/>
-          <p:cNvSpPr txBox="1"/>
-          <p:nvPr/>
-        </p:nvSpPr>
-        <p:spPr>
-          <a:xfrm>
-            <a:off x="5285232" y="3108960"/>
-            <a:ext cx="2697480" cy="960120"/>
-          </a:xfrm>
-          <a:prstGeom prst="rect">
-            <a:avLst/>
-          </a:prstGeom>
-          <a:noFill/>
-        </p:spPr>
-        <p:txBody>
-          <a:bodyPr wrap="square" lIns="0" rIns="0" tIns="0" bIns="0" anchor="ctr">
-            <a:spAutoFit/>
-          </a:bodyPr>
-          <a:lstStyle/>
-          <a:p>
-            <a:r>
-              <a:rPr sz="2800" b="1">
-                <a:solidFill>
-                  <a:srgbClr val="B94E08"/>
-                </a:solidFill>
-                <a:latin typeface="Georgia"/>
-              </a:rPr>
-              <a:t>73 → 16</a:t>
-            </a:r>
-          </a:p>
-        </p:txBody>
-      </p:sp>
-      <p:sp>
-        <p:nvSpPr>
-          <p:cNvPr id="14" name="TextBox 13"/>
-          <p:cNvSpPr txBox="1"/>
-          <p:nvPr/>
-        </p:nvSpPr>
-        <p:spPr>
-          <a:xfrm>
-            <a:off x="7620000" y="3108960"/>
-            <a:ext cx="3565855" cy="960120"/>
-          </a:xfrm>
-          <a:prstGeom prst="rect">
-            <a:avLst/>
-          </a:prstGeom>
-          <a:noFill/>
-        </p:spPr>
-        <p:txBody>
-          <a:bodyPr wrap="square" lIns="0" rIns="0" tIns="0" bIns="0" anchor="ctr">
-            <a:spAutoFit/>
-          </a:bodyPr>
-          <a:lstStyle/>
-          <a:p>
-            <a:r>
-              <a:rPr sz="1400" b="0">
-                <a:solidFill>
-                  <a:srgbClr val="4A5864"/>
-                </a:solidFill>
-                <a:latin typeface="Calibri"/>
-              </a:rPr>
-              <a:t>Bands: 73 prompts judged to find 16 whose answers differed. The other 57 were thrown away. Later steps needed 103.</a:t>
-            </a:r>
-          </a:p>
-        </p:txBody>
-      </p:sp>
-      <p:sp>
-        <p:nvSpPr>
-          <p:cNvPr id="15" name="TextBox 14"/>
-          <p:cNvSpPr txBox="1"/>
-          <p:nvPr/>
-        </p:nvSpPr>
-        <p:spPr>
-          <a:xfrm>
-            <a:off x="5285232" y="4069080"/>
-            <a:ext cx="2697480" cy="960120"/>
-          </a:xfrm>
-          <a:prstGeom prst="rect">
-            <a:avLst/>
-          </a:prstGeom>
-          <a:noFill/>
-        </p:spPr>
-        <p:txBody>
-          <a:bodyPr wrap="square" lIns="0" rIns="0" tIns="0" bIns="0" anchor="ctr">
-            <a:spAutoFit/>
-          </a:bodyPr>
-          <a:lstStyle/>
-          <a:p>
-            <a:r>
-              <a:rPr sz="2800" b="1">
-                <a:solidFill>
-                  <a:srgbClr val="1F5FA8"/>
-                </a:solidFill>
-                <a:latin typeface="Georgia"/>
-              </a:rPr>
-              <a:t>32 → 16</a:t>
-            </a:r>
-          </a:p>
-        </p:txBody>
-      </p:sp>
-      <p:sp>
-        <p:nvSpPr>
-          <p:cNvPr id="16" name="TextBox 15"/>
-          <p:cNvSpPr txBox="1"/>
-          <p:nvPr/>
-        </p:nvSpPr>
-        <p:spPr>
-          <a:xfrm>
-            <a:off x="7620000" y="4069080"/>
-            <a:ext cx="3565855" cy="960120"/>
-          </a:xfrm>
-          <a:prstGeom prst="rect">
-            <a:avLst/>
-          </a:prstGeom>
-          <a:noFill/>
-        </p:spPr>
-        <p:txBody>
-          <a:bodyPr wrap="square" lIns="0" rIns="0" tIns="0" bIns="0" anchor="ctr">
-            <a:spAutoFit/>
-          </a:bodyPr>
-          <a:lstStyle/>
-          <a:p>
-            <a:r>
-              <a:rPr sz="1400" b="0">
-                <a:solidFill>
-                  <a:srgbClr val="4A5864"/>
-                </a:solidFill>
-                <a:latin typeface="Calibri"/>
-              </a:rPr>
-              <a:t>Raw judge score, same seed and base: 32 judged to find 16. Same step, less than half the judging.</a:t>
-            </a:r>
-          </a:p>
-        </p:txBody>
-      </p:sp>
-      <p:sp>
-        <p:nvSpPr>
           <p:cNvPr id="17" name="Rounded Rectangle 16"/>
           <p:cNvSpPr/>
           <p:nvPr/>
@@ -11963,6 +11759,496 @@
                 <a:latin typeface="Calibri"/>
               </a:rPr>
               <a:t>Seven answers in eight paid the same reward, so most groups had no gradient. The raw score cut the waste by more than half; it did not produce lift (entry 12).</a:t>
+            </a:r>
+          </a:p>
+        </p:txBody>
+      </p:sp>
+      <p:graphicFrame>
+        <p:nvGraphicFramePr>
+          <p:cNvPr id="20" name="Table 19"/>
+          <p:cNvGraphicFramePr>
+            <a:graphicFrameLocks noGrp="1"/>
+          </p:cNvGraphicFramePr>
+          <p:nvPr/>
+        </p:nvGraphicFramePr>
+        <p:xfrm>
+          <a:off x="5285232" y="2120000"/>
+          <a:ext cx="5900623" cy="1200000"/>
+        </p:xfrm>
+        <a:graphic>
+          <a:graphicData uri="http://schemas.openxmlformats.org/drawingml/2006/table">
+            <a:tbl>
+              <a:tblPr firstRow="1" bandRow="1">
+                <a:tableStyleId>{5C22544A-7EE6-4342-B048-85BDC9FD1C3A}</a:tableStyleId>
+              </a:tblPr>
+              <a:tblGrid>
+                <a:gridCol w="900000"/>
+                <a:gridCol w="1800000"/>
+                <a:gridCol w="1900000"/>
+                <a:gridCol w="1300623"/>
+              </a:tblGrid>
+              <a:tr h="300000">
+                <a:tc>
+                  <a:txBody>
+                    <a:bodyPr wrap="square"/>
+                    <a:lstStyle/>
+                    <a:p>
+                      <a:r>
+                        <a:rPr sz="1200" b="1">
+                          <a:solidFill>
+                            <a:srgbClr val="16222B"/>
+                          </a:solidFill>
+                          <a:latin typeface="Calibri"/>
+                        </a:rPr>
+                        <a:t>Prompt</a:t>
+                      </a:r>
+                    </a:p>
+                  </a:txBody>
+                  <a:tcPr marT="30000" marB="30000">
+                    <a:solidFill>
+                      <a:srgbClr val="D2D9DD"/>
+                    </a:solidFill>
+                  </a:tcPr>
+                </a:tc>
+                <a:tc>
+                  <a:txBody>
+                    <a:bodyPr wrap="square"/>
+                    <a:lstStyle/>
+                    <a:p>
+                      <a:r>
+                        <a:rPr sz="1200" b="1">
+                          <a:solidFill>
+                            <a:srgbClr val="16222B"/>
+                          </a:solidFill>
+                          <a:latin typeface="Calibri"/>
+                        </a:rPr>
+                        <a:t>Judge scores, 4 answers</a:t>
+                      </a:r>
+                    </a:p>
+                  </a:txBody>
+                  <a:tcPr marT="30000" marB="30000">
+                    <a:solidFill>
+                      <a:srgbClr val="D2D9DD"/>
+                    </a:solidFill>
+                  </a:tcPr>
+                </a:tc>
+                <a:tc>
+                  <a:txBody>
+                    <a:bodyPr wrap="square"/>
+                    <a:lstStyle/>
+                    <a:p>
+                      <a:r>
+                        <a:rPr sz="1200" b="1">
+                          <a:solidFill>
+                            <a:srgbClr val="16222B"/>
+                          </a:solidFill>
+                          <a:latin typeface="Calibri"/>
+                        </a:rPr>
+                        <a:t>Banded reward</a:t>
+                      </a:r>
+                    </a:p>
+                  </a:txBody>
+                  <a:tcPr marT="30000" marB="30000">
+                    <a:solidFill>
+                      <a:srgbClr val="D2D9DD"/>
+                    </a:solidFill>
+                  </a:tcPr>
+                </a:tc>
+                <a:tc>
+                  <a:txBody>
+                    <a:bodyPr wrap="square"/>
+                    <a:lstStyle/>
+                    <a:p>
+                      <a:r>
+                        <a:rPr sz="1200" b="1">
+                          <a:solidFill>
+                            <a:srgbClr val="16222B"/>
+                          </a:solidFill>
+                          <a:latin typeface="Calibri"/>
+                        </a:rPr>
+                        <a:t>Raw reward</a:t>
+                      </a:r>
+                    </a:p>
+                  </a:txBody>
+                  <a:tcPr marT="30000" marB="30000">
+                    <a:solidFill>
+                      <a:srgbClr val="D2D9DD"/>
+                    </a:solidFill>
+                  </a:tcPr>
+                </a:tc>
+              </a:tr>
+              <a:tr h="300000">
+                <a:tc>
+                  <a:txBody>
+                    <a:bodyPr wrap="square"/>
+                    <a:lstStyle/>
+                    <a:p>
+                      <a:r>
+                        <a:rPr sz="1200" b="0">
+                          <a:solidFill>
+                            <a:srgbClr val="16222B"/>
+                          </a:solidFill>
+                          <a:latin typeface="Calibri"/>
+                        </a:rPr>
+                        <a:t>A  hard</a:t>
+                      </a:r>
+                    </a:p>
+                  </a:txBody>
+                  <a:tcPr marT="30000" marB="30000">
+                    <a:solidFill>
+                      <a:srgbClr val="FBFCFC"/>
+                    </a:solidFill>
+                  </a:tcPr>
+                </a:tc>
+                <a:tc>
+                  <a:txBody>
+                    <a:bodyPr wrap="square"/>
+                    <a:lstStyle/>
+                    <a:p>
+                      <a:r>
+                        <a:rPr sz="1200" b="0">
+                          <a:solidFill>
+                            <a:srgbClr val="16222B"/>
+                          </a:solidFill>
+                          <a:latin typeface="Calibri"/>
+                        </a:rPr>
+                        <a:t>.31  .45  .52  .60</a:t>
+                      </a:r>
+                    </a:p>
+                  </a:txBody>
+                  <a:tcPr marT="30000" marB="30000">
+                    <a:solidFill>
+                      <a:srgbClr val="FBFCFC"/>
+                    </a:solidFill>
+                  </a:tcPr>
+                </a:tc>
+                <a:tc>
+                  <a:txBody>
+                    <a:bodyPr wrap="square"/>
+                    <a:lstStyle/>
+                    <a:p>
+                      <a:r>
+                        <a:rPr sz="1200" b="0">
+                          <a:solidFill>
+                            <a:srgbClr val="B84A0B"/>
+                          </a:solidFill>
+                          <a:latin typeface="Calibri"/>
+                        </a:rPr>
+                        <a:t>0  0  0  0  dropped</a:t>
+                      </a:r>
+                    </a:p>
+                  </a:txBody>
+                  <a:tcPr marT="30000" marB="30000">
+                    <a:solidFill>
+                      <a:srgbClr val="FBFCFC"/>
+                    </a:solidFill>
+                  </a:tcPr>
+                </a:tc>
+                <a:tc>
+                  <a:txBody>
+                    <a:bodyPr wrap="square"/>
+                    <a:lstStyle/>
+                    <a:p>
+                      <a:r>
+                        <a:rPr sz="1200" b="0">
+                          <a:solidFill>
+                            <a:srgbClr val="16222B"/>
+                          </a:solidFill>
+                          <a:latin typeface="Calibri"/>
+                        </a:rPr>
+                        <a:t>kept</a:t>
+                      </a:r>
+                    </a:p>
+                  </a:txBody>
+                  <a:tcPr marT="30000" marB="30000">
+                    <a:solidFill>
+                      <a:srgbClr val="FBFCFC"/>
+                    </a:solidFill>
+                  </a:tcPr>
+                </a:tc>
+              </a:tr>
+              <a:tr h="300000">
+                <a:tc>
+                  <a:txBody>
+                    <a:bodyPr wrap="square"/>
+                    <a:lstStyle/>
+                    <a:p>
+                      <a:r>
+                        <a:rPr sz="1200" b="0">
+                          <a:solidFill>
+                            <a:srgbClr val="16222B"/>
+                          </a:solidFill>
+                          <a:latin typeface="Calibri"/>
+                        </a:rPr>
+                        <a:t>B  mixed</a:t>
+                      </a:r>
+                    </a:p>
+                  </a:txBody>
+                  <a:tcPr marT="30000" marB="30000">
+                    <a:solidFill>
+                      <a:srgbClr val="FBFCFC"/>
+                    </a:solidFill>
+                  </a:tcPr>
+                </a:tc>
+                <a:tc>
+                  <a:txBody>
+                    <a:bodyPr wrap="square"/>
+                    <a:lstStyle/>
+                    <a:p>
+                      <a:r>
+                        <a:rPr sz="1200" b="0">
+                          <a:solidFill>
+                            <a:srgbClr val="16222B"/>
+                          </a:solidFill>
+                          <a:latin typeface="Calibri"/>
+                        </a:rPr>
+                        <a:t>.35  .75  .92  .40</a:t>
+                      </a:r>
+                    </a:p>
+                  </a:txBody>
+                  <a:tcPr marT="30000" marB="30000">
+                    <a:solidFill>
+                      <a:srgbClr val="FBFCFC"/>
+                    </a:solidFill>
+                  </a:tcPr>
+                </a:tc>
+                <a:tc>
+                  <a:txBody>
+                    <a:bodyPr wrap="square"/>
+                    <a:lstStyle/>
+                    <a:p>
+                      <a:r>
+                        <a:rPr sz="1200" b="0">
+                          <a:solidFill>
+                            <a:srgbClr val="1F5EA8"/>
+                          </a:solidFill>
+                          <a:latin typeface="Calibri"/>
+                        </a:rPr>
+                        <a:t>0  .5  1  0  kept</a:t>
+                      </a:r>
+                    </a:p>
+                  </a:txBody>
+                  <a:tcPr marT="30000" marB="30000">
+                    <a:solidFill>
+                      <a:srgbClr val="FBFCFC"/>
+                    </a:solidFill>
+                  </a:tcPr>
+                </a:tc>
+                <a:tc>
+                  <a:txBody>
+                    <a:bodyPr wrap="square"/>
+                    <a:lstStyle/>
+                    <a:p>
+                      <a:r>
+                        <a:rPr sz="1200" b="0">
+                          <a:solidFill>
+                            <a:srgbClr val="16222B"/>
+                          </a:solidFill>
+                          <a:latin typeface="Calibri"/>
+                        </a:rPr>
+                        <a:t>kept</a:t>
+                      </a:r>
+                    </a:p>
+                  </a:txBody>
+                  <a:tcPr marT="30000" marB="30000">
+                    <a:solidFill>
+                      <a:srgbClr val="FBFCFC"/>
+                    </a:solidFill>
+                  </a:tcPr>
+                </a:tc>
+              </a:tr>
+              <a:tr h="300000">
+                <a:tc>
+                  <a:txBody>
+                    <a:bodyPr wrap="square"/>
+                    <a:lstStyle/>
+                    <a:p>
+                      <a:r>
+                        <a:rPr sz="1200" b="0">
+                          <a:solidFill>
+                            <a:srgbClr val="16222B"/>
+                          </a:solidFill>
+                          <a:latin typeface="Calibri"/>
+                        </a:rPr>
+                        <a:t>C  easy</a:t>
+                      </a:r>
+                    </a:p>
+                  </a:txBody>
+                  <a:tcPr marT="30000" marB="30000">
+                    <a:solidFill>
+                      <a:srgbClr val="FBFCFC"/>
+                    </a:solidFill>
+                  </a:tcPr>
+                </a:tc>
+                <a:tc>
+                  <a:txBody>
+                    <a:bodyPr wrap="square"/>
+                    <a:lstStyle/>
+                    <a:p>
+                      <a:r>
+                        <a:rPr sz="1200" b="0">
+                          <a:solidFill>
+                            <a:srgbClr val="16222B"/>
+                          </a:solidFill>
+                          <a:latin typeface="Calibri"/>
+                        </a:rPr>
+                        <a:t>.93  .95  .91  .97</a:t>
+                      </a:r>
+                    </a:p>
+                  </a:txBody>
+                  <a:tcPr marT="30000" marB="30000">
+                    <a:solidFill>
+                      <a:srgbClr val="FBFCFC"/>
+                    </a:solidFill>
+                  </a:tcPr>
+                </a:tc>
+                <a:tc>
+                  <a:txBody>
+                    <a:bodyPr wrap="square"/>
+                    <a:lstStyle/>
+                    <a:p>
+                      <a:r>
+                        <a:rPr sz="1200" b="0">
+                          <a:solidFill>
+                            <a:srgbClr val="B84A0B"/>
+                          </a:solidFill>
+                          <a:latin typeface="Calibri"/>
+                        </a:rPr>
+                        <a:t>1  1  1  1  dropped</a:t>
+                      </a:r>
+                    </a:p>
+                  </a:txBody>
+                  <a:tcPr marT="30000" marB="30000">
+                    <a:solidFill>
+                      <a:srgbClr val="FBFCFC"/>
+                    </a:solidFill>
+                  </a:tcPr>
+                </a:tc>
+                <a:tc>
+                  <a:txBody>
+                    <a:bodyPr wrap="square"/>
+                    <a:lstStyle/>
+                    <a:p>
+                      <a:r>
+                        <a:rPr sz="1200" b="0">
+                          <a:solidFill>
+                            <a:srgbClr val="16222B"/>
+                          </a:solidFill>
+                          <a:latin typeface="Calibri"/>
+                        </a:rPr>
+                        <a:t>kept, small</a:t>
+                      </a:r>
+                    </a:p>
+                  </a:txBody>
+                  <a:tcPr marT="30000" marB="30000">
+                    <a:solidFill>
+                      <a:srgbClr val="FBFCFC"/>
+                    </a:solidFill>
+                  </a:tcPr>
+                </a:tc>
+              </a:tr>
+            </a:tbl>
+          </a:graphicData>
+        </a:graphic>
+      </p:graphicFrame>
+      <p:sp>
+        <p:nvSpPr>
+          <p:cNvPr id="21" name="TextBox 20"/>
+          <p:cNvSpPr txBox="1"/>
+          <p:nvPr/>
+        </p:nvSpPr>
+        <p:spPr>
+          <a:xfrm>
+            <a:off x="5285232" y="3380000"/>
+            <a:ext cx="5900623" cy="230000"/>
+          </a:xfrm>
+          <a:prstGeom prst="rect">
+            <a:avLst/>
+          </a:prstGeom>
+          <a:noFill/>
+        </p:spPr>
+        <p:txBody>
+          <a:bodyPr wrap="square" lIns="0" rIns="0">
+            <a:spAutoFit/>
+          </a:bodyPr>
+          <a:lstStyle/>
+          <a:p>
+            <a:r>
+              <a:rPr sz="1100" i="1">
+                <a:solidFill>
+                  <a:srgbClr val="5E6B75"/>
+                </a:solidFill>
+                <a:latin typeface="Calibri"/>
+              </a:rPr>
+              <a:t>Made-up scores, one prompt each. Reward minus the group average is what RL learns from; a group of equal rewards has none.</a:t>
+            </a:r>
+          </a:p>
+        </p:txBody>
+      </p:sp>
+      <p:sp>
+        <p:nvSpPr>
+          <p:cNvPr id="22" name="TextBox 21"/>
+          <p:cNvSpPr txBox="1"/>
+          <p:nvPr/>
+        </p:nvSpPr>
+        <p:spPr>
+          <a:xfrm>
+            <a:off x="5285232" y="3880000"/>
+            <a:ext cx="5900623" cy="600000"/>
+          </a:xfrm>
+          <a:prstGeom prst="rect">
+            <a:avLst/>
+          </a:prstGeom>
+          <a:noFill/>
+        </p:spPr>
+        <p:txBody>
+          <a:bodyPr wrap="square" lIns="0" rIns="0">
+            <a:spAutoFit/>
+          </a:bodyPr>
+          <a:lstStyle/>
+          <a:p>
+            <a:r>
+              <a:rPr sz="1400" i="0">
+                <a:solidFill>
+                  <a:srgbClr val="16222B"/>
+                </a:solidFill>
+                <a:latin typeface="Calibri"/>
+              </a:rPr>
+              <a:t>Real counts. Bands: 73 prompts judged to find 16 that teach something, 57 thrown away; later steps needed 103. Raw judge score, same seed and base: 32.</a:t>
+            </a:r>
+          </a:p>
+        </p:txBody>
+      </p:sp>
+      <p:sp>
+        <p:nvSpPr>
+          <p:cNvPr id="23" name="TextBox 22"/>
+          <p:cNvSpPr txBox="1"/>
+          <p:nvPr/>
+        </p:nvSpPr>
+        <p:spPr>
+          <a:xfrm>
+            <a:off x="5285232" y="4560000"/>
+            <a:ext cx="5900623" cy="560000"/>
+          </a:xfrm>
+          <a:prstGeom prst="rect">
+            <a:avLst/>
+          </a:prstGeom>
+          <a:noFill/>
+        </p:spPr>
+        <p:txBody>
+          <a:bodyPr wrap="square" lIns="0" rIns="0">
+            <a:spAutoFit/>
+          </a:bodyPr>
+          <a:lstStyle/>
+          <a:p>
+            <a:r>
+              <a:rPr sz="1400" i="0">
+                <a:solidFill>
+                  <a:srgbClr val="B84A0B"/>
+                </a:solidFill>
+                <a:latin typeface="Calibri"/>
+              </a:rPr>
+              <a:t>86.9% of 1,752 judged answers earned 0 under bands, so most prompts looked like A.</a:t>
             </a:r>
           </a:p>
         </p:txBody>

</xml_diff>

<commit_message>
RL deck slide 19: restore the 2.3x takeaway
Co-Authored-By: Claude Sonnet 5.5 <noreply@anthropic.com>
</commit_message>
<xml_diff>
--- a/docs/RL_V2_rl.pptx
+++ b/docs/RL_V2_rl.pptx
@@ -12208,13 +12208,22 @@
           <a:lstStyle/>
           <a:p>
             <a:r>
-              <a:rPr sz="1400" i="0">
+              <a:rPr b="1" sz="1400">
                 <a:solidFill>
                   <a:srgbClr val="16222B"/>
                 </a:solidFill>
                 <a:latin typeface="Calibri"/>
               </a:rPr>
-              <a:t>Real counts. Bands: 73 prompts judged to find 16 that teach something, 57 thrown away; later steps needed 103. Raw judge score, same seed and base: 32.</a:t>
+              <a:t>Bands cost 2.3 times the judging for the same step: </a:t>
+            </a:r>
+            <a:r>
+              <a:rPr sz="1400">
+                <a:solidFill>
+                  <a:srgbClr val="16222B"/>
+                </a:solidFill>
+                <a:latin typeface="Calibri"/>
+              </a:rPr>
+              <a:t>73 prompts judged to find 16 that teach something, against 32 with the raw judge score (same seed and base). Later banded steps needed 103.</a:t>
             </a:r>
           </a:p>
         </p:txBody>

</xml_diff>

<commit_message>
RL deck slide 19: bands vs binary vs raw made explicit
Co-Authored-By: Claude Sonnet 5.5 <noreply@anthropic.com>
</commit_message>
<xml_diff>
--- a/docs/RL_V2_rl.pptx
+++ b/docs/RL_V2_rl.pptx
@@ -11763,9 +11763,120 @@
           </a:p>
         </p:txBody>
       </p:sp>
+      <p:sp>
+        <p:nvSpPr>
+          <p:cNvPr id="21" name="TextBox 20"/>
+          <p:cNvSpPr txBox="1"/>
+          <p:nvPr/>
+        </p:nvSpPr>
+        <p:spPr>
+          <a:xfrm>
+            <a:off x="5285232" y="3380000"/>
+            <a:ext cx="5900623" cy="230000"/>
+          </a:xfrm>
+          <a:prstGeom prst="rect">
+            <a:avLst/>
+          </a:prstGeom>
+          <a:noFill/>
+        </p:spPr>
+        <p:txBody>
+          <a:bodyPr wrap="square" lIns="0" rIns="0">
+            <a:spAutoFit/>
+          </a:bodyPr>
+          <a:lstStyle/>
+          <a:p>
+            <a:r>
+              <a:rPr sz="1100" i="1">
+                <a:solidFill>
+                  <a:srgbClr val="5E6B75"/>
+                </a:solidFill>
+                <a:latin typeface="Calibri"/>
+              </a:rPr>
+              <a:t>Made-up scores, one prompt each. RL learns from reward minus the group average; a group of equal rewards has none.</a:t>
+            </a:r>
+          </a:p>
+        </p:txBody>
+      </p:sp>
+      <p:sp>
+        <p:nvSpPr>
+          <p:cNvPr id="22" name="TextBox 21"/>
+          <p:cNvSpPr txBox="1"/>
+          <p:nvPr/>
+        </p:nvSpPr>
+        <p:spPr>
+          <a:xfrm>
+            <a:off x="5285232" y="3800000"/>
+            <a:ext cx="5900623" cy="600000"/>
+          </a:xfrm>
+          <a:prstGeom prst="rect">
+            <a:avLst/>
+          </a:prstGeom>
+          <a:noFill/>
+        </p:spPr>
+        <p:txBody>
+          <a:bodyPr wrap="square" lIns="0" rIns="0">
+            <a:spAutoFit/>
+          </a:bodyPr>
+          <a:lstStyle/>
+          <a:p>
+            <a:r>
+              <a:rPr b="1" sz="1300">
+                <a:solidFill>
+                  <a:srgbClr val="16222B"/>
+                </a:solidFill>
+                <a:latin typeface="Calibri"/>
+              </a:rPr>
+              <a:t>Raw score: less than half the judging of bands. </a:t>
+            </a:r>
+            <a:r>
+              <a:rPr sz="1300">
+                <a:solidFill>
+                  <a:srgbClr val="16222B"/>
+                </a:solidFill>
+                <a:latin typeface="Calibri"/>
+              </a:rPr>
+              <a:t>32 prompts judged to find 16, against 73 for bands (same seed and base). Binary drops every prompt bands drop, so it costs at least as much; not run.</a:t>
+            </a:r>
+          </a:p>
+        </p:txBody>
+      </p:sp>
+      <p:sp>
+        <p:nvSpPr>
+          <p:cNvPr id="23" name="TextBox 22"/>
+          <p:cNvSpPr txBox="1"/>
+          <p:nvPr/>
+        </p:nvSpPr>
+        <p:spPr>
+          <a:xfrm>
+            <a:off x="5285232" y="4600000"/>
+            <a:ext cx="5900623" cy="560000"/>
+          </a:xfrm>
+          <a:prstGeom prst="rect">
+            <a:avLst/>
+          </a:prstGeom>
+          <a:noFill/>
+        </p:spPr>
+        <p:txBody>
+          <a:bodyPr wrap="square" lIns="0" rIns="0">
+            <a:spAutoFit/>
+          </a:bodyPr>
+          <a:lstStyle/>
+          <a:p>
+            <a:r>
+              <a:rPr sz="1400" i="0">
+                <a:solidFill>
+                  <a:srgbClr val="B84A0B"/>
+                </a:solidFill>
+                <a:latin typeface="Calibri"/>
+              </a:rPr>
+              <a:t>86.9% of answers earned 0 under bands, so most prompts looked like A.</a:t>
+            </a:r>
+          </a:p>
+        </p:txBody>
+      </p:sp>
       <p:graphicFrame>
         <p:nvGraphicFramePr>
-          <p:cNvPr id="20" name="Table 19"/>
+          <p:cNvPr id="24" name="Table 23"/>
           <p:cNvGraphicFramePr>
             <a:graphicFrameLocks noGrp="1"/>
           </p:cNvGraphicFramePr>
@@ -11782,10 +11893,11 @@
                 <a:tableStyleId>{5C22544A-7EE6-4342-B048-85BDC9FD1C3A}</a:tableStyleId>
               </a:tblPr>
               <a:tblGrid>
-                <a:gridCol w="900000"/>
-                <a:gridCol w="1800000"/>
-                <a:gridCol w="1900000"/>
-                <a:gridCol w="1300623"/>
+                <a:gridCol w="780000"/>
+                <a:gridCol w="1250000"/>
+                <a:gridCol w="1370000"/>
+                <a:gridCol w="1370000"/>
+                <a:gridCol w="1130623"/>
               </a:tblGrid>
               <a:tr h="300000">
                 <a:tc>
@@ -11794,7 +11906,7 @@
                     <a:lstStyle/>
                     <a:p>
                       <a:r>
-                        <a:rPr sz="1200" b="1">
+                        <a:rPr sz="1100" b="1">
                           <a:solidFill>
                             <a:srgbClr val="16222B"/>
                           </a:solidFill>
@@ -11804,7 +11916,7 @@
                       </a:r>
                     </a:p>
                   </a:txBody>
-                  <a:tcPr marT="30000" marB="30000">
+                  <a:tcPr marT="30000" marB="30000" marL="60000" marR="60000">
                     <a:solidFill>
                       <a:srgbClr val="D2D9DD"/>
                     </a:solidFill>
@@ -11816,17 +11928,17 @@
                     <a:lstStyle/>
                     <a:p>
                       <a:r>
-                        <a:rPr sz="1200" b="1">
+                        <a:rPr sz="1100" b="1">
                           <a:solidFill>
                             <a:srgbClr val="16222B"/>
                           </a:solidFill>
                           <a:latin typeface="Calibri"/>
                         </a:rPr>
-                        <a:t>Judge scores, 4 answers</a:t>
+                        <a:t>Judge scores</a:t>
                       </a:r>
                     </a:p>
                   </a:txBody>
-                  <a:tcPr marT="30000" marB="30000">
+                  <a:tcPr marT="30000" marB="30000" marL="60000" marR="60000">
                     <a:solidFill>
                       <a:srgbClr val="D2D9DD"/>
                     </a:solidFill>
@@ -11838,17 +11950,17 @@
                     <a:lstStyle/>
                     <a:p>
                       <a:r>
-                        <a:rPr sz="1200" b="1">
+                        <a:rPr sz="1100" b="1">
                           <a:solidFill>
                             <a:srgbClr val="16222B"/>
                           </a:solidFill>
                           <a:latin typeface="Calibri"/>
                         </a:rPr>
-                        <a:t>Banded reward</a:t>
+                        <a:t>Bands</a:t>
                       </a:r>
                     </a:p>
                   </a:txBody>
-                  <a:tcPr marT="30000" marB="30000">
+                  <a:tcPr marT="30000" marB="30000" marL="60000" marR="60000">
                     <a:solidFill>
                       <a:srgbClr val="D2D9DD"/>
                     </a:solidFill>
@@ -11860,17 +11972,39 @@
                     <a:lstStyle/>
                     <a:p>
                       <a:r>
-                        <a:rPr sz="1200" b="1">
+                        <a:rPr sz="1100" b="1">
                           <a:solidFill>
                             <a:srgbClr val="16222B"/>
                           </a:solidFill>
                           <a:latin typeface="Calibri"/>
                         </a:rPr>
-                        <a:t>Raw reward</a:t>
+                        <a:t>Binary 0/1</a:t>
                       </a:r>
                     </a:p>
                   </a:txBody>
-                  <a:tcPr marT="30000" marB="30000">
+                  <a:tcPr marT="30000" marB="30000" marL="60000" marR="60000">
+                    <a:solidFill>
+                      <a:srgbClr val="D2D9DD"/>
+                    </a:solidFill>
+                  </a:tcPr>
+                </a:tc>
+                <a:tc>
+                  <a:txBody>
+                    <a:bodyPr wrap="square"/>
+                    <a:lstStyle/>
+                    <a:p>
+                      <a:r>
+                        <a:rPr sz="1100" b="1">
+                          <a:solidFill>
+                            <a:srgbClr val="16222B"/>
+                          </a:solidFill>
+                          <a:latin typeface="Calibri"/>
+                        </a:rPr>
+                        <a:t>Raw score</a:t>
+                      </a:r>
+                    </a:p>
+                  </a:txBody>
+                  <a:tcPr marT="30000" marB="30000" marL="60000" marR="60000">
                     <a:solidFill>
                       <a:srgbClr val="D2D9DD"/>
                     </a:solidFill>
@@ -11884,7 +12018,7 @@
                     <a:lstStyle/>
                     <a:p>
                       <a:r>
-                        <a:rPr sz="1200" b="0">
+                        <a:rPr sz="1100" b="0">
                           <a:solidFill>
                             <a:srgbClr val="16222B"/>
                           </a:solidFill>
@@ -11894,7 +12028,7 @@
                       </a:r>
                     </a:p>
                   </a:txBody>
-                  <a:tcPr marT="30000" marB="30000">
+                  <a:tcPr marT="30000" marB="30000" marL="60000" marR="60000">
                     <a:solidFill>
                       <a:srgbClr val="FBFCFC"/>
                     </a:solidFill>
@@ -11906,17 +12040,17 @@
                     <a:lstStyle/>
                     <a:p>
                       <a:r>
-                        <a:rPr sz="1200" b="0">
+                        <a:rPr sz="1100" b="0">
                           <a:solidFill>
                             <a:srgbClr val="16222B"/>
                           </a:solidFill>
                           <a:latin typeface="Calibri"/>
                         </a:rPr>
-                        <a:t>.31  .45  .52  .60</a:t>
+                        <a:t>.31 .45 .52 .60</a:t>
                       </a:r>
                     </a:p>
                   </a:txBody>
-                  <a:tcPr marT="30000" marB="30000">
+                  <a:tcPr marT="30000" marB="30000" marL="60000" marR="60000">
                     <a:solidFill>
                       <a:srgbClr val="FBFCFC"/>
                     </a:solidFill>
@@ -11928,17 +12062,17 @@
                     <a:lstStyle/>
                     <a:p>
                       <a:r>
-                        <a:rPr sz="1200" b="0">
+                        <a:rPr sz="1100" b="0">
                           <a:solidFill>
                             <a:srgbClr val="B84A0B"/>
                           </a:solidFill>
                           <a:latin typeface="Calibri"/>
                         </a:rPr>
-                        <a:t>0  0  0  0  dropped</a:t>
+                        <a:t>0 0 0 0  dropped</a:t>
                       </a:r>
                     </a:p>
                   </a:txBody>
-                  <a:tcPr marT="30000" marB="30000">
+                  <a:tcPr marT="30000" marB="30000" marL="60000" marR="60000">
                     <a:solidFill>
                       <a:srgbClr val="FBFCFC"/>
                     </a:solidFill>
@@ -11950,7 +12084,29 @@
                     <a:lstStyle/>
                     <a:p>
                       <a:r>
-                        <a:rPr sz="1200" b="0">
+                        <a:rPr sz="1100" b="0">
+                          <a:solidFill>
+                            <a:srgbClr val="B84A0B"/>
+                          </a:solidFill>
+                          <a:latin typeface="Calibri"/>
+                        </a:rPr>
+                        <a:t>0 0 0 0  dropped</a:t>
+                      </a:r>
+                    </a:p>
+                  </a:txBody>
+                  <a:tcPr marT="30000" marB="30000" marL="60000" marR="60000">
+                    <a:solidFill>
+                      <a:srgbClr val="FBFCFC"/>
+                    </a:solidFill>
+                  </a:tcPr>
+                </a:tc>
+                <a:tc>
+                  <a:txBody>
+                    <a:bodyPr wrap="square"/>
+                    <a:lstStyle/>
+                    <a:p>
+                      <a:r>
+                        <a:rPr sz="1100" b="0">
                           <a:solidFill>
                             <a:srgbClr val="16222B"/>
                           </a:solidFill>
@@ -11960,7 +12116,7 @@
                       </a:r>
                     </a:p>
                   </a:txBody>
-                  <a:tcPr marT="30000" marB="30000">
+                  <a:tcPr marT="30000" marB="30000" marL="60000" marR="60000">
                     <a:solidFill>
                       <a:srgbClr val="FBFCFC"/>
                     </a:solidFill>
@@ -11974,7 +12130,7 @@
                     <a:lstStyle/>
                     <a:p>
                       <a:r>
-                        <a:rPr sz="1200" b="0">
+                        <a:rPr sz="1100" b="0">
                           <a:solidFill>
                             <a:srgbClr val="16222B"/>
                           </a:solidFill>
@@ -11984,7 +12140,7 @@
                       </a:r>
                     </a:p>
                   </a:txBody>
-                  <a:tcPr marT="30000" marB="30000">
+                  <a:tcPr marT="30000" marB="30000" marL="60000" marR="60000">
                     <a:solidFill>
                       <a:srgbClr val="FBFCFC"/>
                     </a:solidFill>
@@ -11996,17 +12152,17 @@
                     <a:lstStyle/>
                     <a:p>
                       <a:r>
-                        <a:rPr sz="1200" b="0">
+                        <a:rPr sz="1100" b="0">
                           <a:solidFill>
                             <a:srgbClr val="16222B"/>
                           </a:solidFill>
                           <a:latin typeface="Calibri"/>
                         </a:rPr>
-                        <a:t>.35  .75  .92  .40</a:t>
+                        <a:t>.35 .75 .92 .40</a:t>
                       </a:r>
                     </a:p>
                   </a:txBody>
-                  <a:tcPr marT="30000" marB="30000">
+                  <a:tcPr marT="30000" marB="30000" marL="60000" marR="60000">
                     <a:solidFill>
                       <a:srgbClr val="FBFCFC"/>
                     </a:solidFill>
@@ -12018,17 +12174,17 @@
                     <a:lstStyle/>
                     <a:p>
                       <a:r>
-                        <a:rPr sz="1200" b="0">
+                        <a:rPr sz="1100" b="0">
                           <a:solidFill>
                             <a:srgbClr val="1F5EA8"/>
                           </a:solidFill>
                           <a:latin typeface="Calibri"/>
                         </a:rPr>
-                        <a:t>0  .5  1  0  kept</a:t>
+                        <a:t>0 .5 1 0  kept</a:t>
                       </a:r>
                     </a:p>
                   </a:txBody>
-                  <a:tcPr marT="30000" marB="30000">
+                  <a:tcPr marT="30000" marB="30000" marL="60000" marR="60000">
                     <a:solidFill>
                       <a:srgbClr val="FBFCFC"/>
                     </a:solidFill>
@@ -12040,7 +12196,29 @@
                     <a:lstStyle/>
                     <a:p>
                       <a:r>
-                        <a:rPr sz="1200" b="0">
+                        <a:rPr sz="1100" b="0">
+                          <a:solidFill>
+                            <a:srgbClr val="1F5EA8"/>
+                          </a:solidFill>
+                          <a:latin typeface="Calibri"/>
+                        </a:rPr>
+                        <a:t>0 1 1 0  kept</a:t>
+                      </a:r>
+                    </a:p>
+                  </a:txBody>
+                  <a:tcPr marT="30000" marB="30000" marL="60000" marR="60000">
+                    <a:solidFill>
+                      <a:srgbClr val="FBFCFC"/>
+                    </a:solidFill>
+                  </a:tcPr>
+                </a:tc>
+                <a:tc>
+                  <a:txBody>
+                    <a:bodyPr wrap="square"/>
+                    <a:lstStyle/>
+                    <a:p>
+                      <a:r>
+                        <a:rPr sz="1100" b="0">
                           <a:solidFill>
                             <a:srgbClr val="16222B"/>
                           </a:solidFill>
@@ -12050,7 +12228,7 @@
                       </a:r>
                     </a:p>
                   </a:txBody>
-                  <a:tcPr marT="30000" marB="30000">
+                  <a:tcPr marT="30000" marB="30000" marL="60000" marR="60000">
                     <a:solidFill>
                       <a:srgbClr val="FBFCFC"/>
                     </a:solidFill>
@@ -12064,7 +12242,7 @@
                     <a:lstStyle/>
                     <a:p>
                       <a:r>
-                        <a:rPr sz="1200" b="0">
+                        <a:rPr sz="1100" b="0">
                           <a:solidFill>
                             <a:srgbClr val="16222B"/>
                           </a:solidFill>
@@ -12074,7 +12252,7 @@
                       </a:r>
                     </a:p>
                   </a:txBody>
-                  <a:tcPr marT="30000" marB="30000">
+                  <a:tcPr marT="30000" marB="30000" marL="60000" marR="60000">
                     <a:solidFill>
                       <a:srgbClr val="FBFCFC"/>
                     </a:solidFill>
@@ -12086,17 +12264,17 @@
                     <a:lstStyle/>
                     <a:p>
                       <a:r>
-                        <a:rPr sz="1200" b="0">
+                        <a:rPr sz="1100" b="0">
                           <a:solidFill>
                             <a:srgbClr val="16222B"/>
                           </a:solidFill>
                           <a:latin typeface="Calibri"/>
                         </a:rPr>
-                        <a:t>.93  .95  .91  .97</a:t>
+                        <a:t>.93 .95 .91 .97</a:t>
                       </a:r>
                     </a:p>
                   </a:txBody>
-                  <a:tcPr marT="30000" marB="30000">
+                  <a:tcPr marT="30000" marB="30000" marL="60000" marR="60000">
                     <a:solidFill>
                       <a:srgbClr val="FBFCFC"/>
                     </a:solidFill>
@@ -12108,17 +12286,17 @@
                     <a:lstStyle/>
                     <a:p>
                       <a:r>
-                        <a:rPr sz="1200" b="0">
+                        <a:rPr sz="1100" b="0">
                           <a:solidFill>
                             <a:srgbClr val="B84A0B"/>
                           </a:solidFill>
                           <a:latin typeface="Calibri"/>
                         </a:rPr>
-                        <a:t>1  1  1  1  dropped</a:t>
+                        <a:t>1 1 1 1  dropped</a:t>
                       </a:r>
                     </a:p>
                   </a:txBody>
-                  <a:tcPr marT="30000" marB="30000">
+                  <a:tcPr marT="30000" marB="30000" marL="60000" marR="60000">
                     <a:solidFill>
                       <a:srgbClr val="FBFCFC"/>
                     </a:solidFill>
@@ -12130,7 +12308,29 @@
                     <a:lstStyle/>
                     <a:p>
                       <a:r>
-                        <a:rPr sz="1200" b="0">
+                        <a:rPr sz="1100" b="0">
+                          <a:solidFill>
+                            <a:srgbClr val="B84A0B"/>
+                          </a:solidFill>
+                          <a:latin typeface="Calibri"/>
+                        </a:rPr>
+                        <a:t>1 1 1 1  dropped</a:t>
+                      </a:r>
+                    </a:p>
+                  </a:txBody>
+                  <a:tcPr marT="30000" marB="30000" marL="60000" marR="60000">
+                    <a:solidFill>
+                      <a:srgbClr val="FBFCFC"/>
+                    </a:solidFill>
+                  </a:tcPr>
+                </a:tc>
+                <a:tc>
+                  <a:txBody>
+                    <a:bodyPr wrap="square"/>
+                    <a:lstStyle/>
+                    <a:p>
+                      <a:r>
+                        <a:rPr sz="1100" b="0">
                           <a:solidFill>
                             <a:srgbClr val="16222B"/>
                           </a:solidFill>
@@ -12140,7 +12340,7 @@
                       </a:r>
                     </a:p>
                   </a:txBody>
-                  <a:tcPr marT="30000" marB="30000">
+                  <a:tcPr marT="30000" marB="30000" marL="60000" marR="60000">
                     <a:solidFill>
                       <a:srgbClr val="FBFCFC"/>
                     </a:solidFill>
@@ -12151,117 +12351,6 @@
           </a:graphicData>
         </a:graphic>
       </p:graphicFrame>
-      <p:sp>
-        <p:nvSpPr>
-          <p:cNvPr id="21" name="TextBox 20"/>
-          <p:cNvSpPr txBox="1"/>
-          <p:nvPr/>
-        </p:nvSpPr>
-        <p:spPr>
-          <a:xfrm>
-            <a:off x="5285232" y="3380000"/>
-            <a:ext cx="5900623" cy="230000"/>
-          </a:xfrm>
-          <a:prstGeom prst="rect">
-            <a:avLst/>
-          </a:prstGeom>
-          <a:noFill/>
-        </p:spPr>
-        <p:txBody>
-          <a:bodyPr wrap="square" lIns="0" rIns="0">
-            <a:spAutoFit/>
-          </a:bodyPr>
-          <a:lstStyle/>
-          <a:p>
-            <a:r>
-              <a:rPr sz="1100" i="1">
-                <a:solidFill>
-                  <a:srgbClr val="5E6B75"/>
-                </a:solidFill>
-                <a:latin typeface="Calibri"/>
-              </a:rPr>
-              <a:t>Made-up scores, one prompt each. Reward minus the group average is what RL learns from; a group of equal rewards has none.</a:t>
-            </a:r>
-          </a:p>
-        </p:txBody>
-      </p:sp>
-      <p:sp>
-        <p:nvSpPr>
-          <p:cNvPr id="22" name="TextBox 21"/>
-          <p:cNvSpPr txBox="1"/>
-          <p:nvPr/>
-        </p:nvSpPr>
-        <p:spPr>
-          <a:xfrm>
-            <a:off x="5285232" y="3880000"/>
-            <a:ext cx="5900623" cy="600000"/>
-          </a:xfrm>
-          <a:prstGeom prst="rect">
-            <a:avLst/>
-          </a:prstGeom>
-          <a:noFill/>
-        </p:spPr>
-        <p:txBody>
-          <a:bodyPr wrap="square" lIns="0" rIns="0">
-            <a:spAutoFit/>
-          </a:bodyPr>
-          <a:lstStyle/>
-          <a:p>
-            <a:r>
-              <a:rPr b="1" sz="1400">
-                <a:solidFill>
-                  <a:srgbClr val="16222B"/>
-                </a:solidFill>
-                <a:latin typeface="Calibri"/>
-              </a:rPr>
-              <a:t>Bands cost 2.3 times the judging for the same step: </a:t>
-            </a:r>
-            <a:r>
-              <a:rPr sz="1400">
-                <a:solidFill>
-                  <a:srgbClr val="16222B"/>
-                </a:solidFill>
-                <a:latin typeface="Calibri"/>
-              </a:rPr>
-              <a:t>73 prompts judged to find 16 that teach something, against 32 with the raw judge score (same seed and base). Later banded steps needed 103.</a:t>
-            </a:r>
-          </a:p>
-        </p:txBody>
-      </p:sp>
-      <p:sp>
-        <p:nvSpPr>
-          <p:cNvPr id="23" name="TextBox 22"/>
-          <p:cNvSpPr txBox="1"/>
-          <p:nvPr/>
-        </p:nvSpPr>
-        <p:spPr>
-          <a:xfrm>
-            <a:off x="5285232" y="4560000"/>
-            <a:ext cx="5900623" cy="560000"/>
-          </a:xfrm>
-          <a:prstGeom prst="rect">
-            <a:avLst/>
-          </a:prstGeom>
-          <a:noFill/>
-        </p:spPr>
-        <p:txBody>
-          <a:bodyPr wrap="square" lIns="0" rIns="0">
-            <a:spAutoFit/>
-          </a:bodyPr>
-          <a:lstStyle/>
-          <a:p>
-            <a:r>
-              <a:rPr sz="1400" i="0">
-                <a:solidFill>
-                  <a:srgbClr val="B84A0B"/>
-                </a:solidFill>
-                <a:latin typeface="Calibri"/>
-              </a:rPr>
-              <a:t>86.9% of 1,752 judged answers earned 0 under bands, so most prompts looked like A.</a:t>
-            </a:r>
-          </a:p>
-        </p:txBody>
-      </p:sp>
     </p:spTree>
   </p:cSld>
   <p:clrMapOvr>

</xml_diff>

<commit_message>
RL deck slide 19: add a case where bands and binary differ
Co-Authored-By: Claude Sonnet 5.5 <noreply@anthropic.com>
</commit_message>
<xml_diff>
--- a/docs/RL_V2_rl.pptx
+++ b/docs/RL_V2_rl.pptx
@@ -11771,7 +11771,7 @@
         </p:nvSpPr>
         <p:spPr>
           <a:xfrm>
-            <a:off x="5285232" y="3380000"/>
+            <a:off x="5285232" y="3740000"/>
             <a:ext cx="5900623" cy="230000"/>
           </a:xfrm>
           <a:prstGeom prst="rect">
@@ -11792,7 +11792,7 @@
                 </a:solidFill>
                 <a:latin typeface="Calibri"/>
               </a:rPr>
-              <a:t>Made-up scores, one prompt each. RL learns from reward minus the group average; a group of equal rewards has none.</a:t>
+              <a:t>Made-up scores. RL learns from reward minus group average; equal rewards give none. C is where bands and binary differ.</a:t>
             </a:r>
           </a:p>
         </p:txBody>
@@ -11805,7 +11805,7 @@
         </p:nvSpPr>
         <p:spPr>
           <a:xfrm>
-            <a:off x="5285232" y="3800000"/>
+            <a:off x="5285232" y="4140000"/>
             <a:ext cx="5900623" cy="600000"/>
           </a:xfrm>
           <a:prstGeom prst="rect">
@@ -11826,7 +11826,7 @@
                 </a:solidFill>
                 <a:latin typeface="Calibri"/>
               </a:rPr>
-              <a:t>Raw score: less than half the judging of bands. </a:t>
+              <a:t>Binary does not need fewer prompts. It needs more. </a:t>
             </a:r>
             <a:r>
               <a:rPr sz="1300">
@@ -11835,7 +11835,7 @@
                 </a:solidFill>
                 <a:latin typeface="Calibri"/>
               </a:rPr>
-              <a:t>32 prompts judged to find 16, against 73 for bands (same seed and base). Binary drops every prompt bands drop, so it costs at least as much; not run.</a:t>
+              <a:t>It scores C as 1 1 1 1 and drops it; bands keep it. Measured: bands 73 prompts judged to find 16, raw score 32 (same seed and base). Binary was not run.</a:t>
             </a:r>
           </a:p>
         </p:txBody>
@@ -11848,7 +11848,7 @@
         </p:nvSpPr>
         <p:spPr>
           <a:xfrm>
-            <a:off x="5285232" y="4600000"/>
+            <a:off x="5285232" y="4830000"/>
             <a:ext cx="5900623" cy="560000"/>
           </a:xfrm>
           <a:prstGeom prst="rect">
@@ -11884,7 +11884,7 @@
         </p:nvGraphicFramePr>
         <p:xfrm>
           <a:off x="5285232" y="2120000"/>
-          <a:ext cx="5900623" cy="1200000"/>
+          <a:ext cx="5900623" cy="1500000"/>
         </p:xfrm>
         <a:graphic>
           <a:graphicData uri="http://schemas.openxmlformats.org/drawingml/2006/table">
@@ -12248,7 +12248,119 @@
                           </a:solidFill>
                           <a:latin typeface="Calibri"/>
                         </a:rPr>
-                        <a:t>C  easy</a:t>
+                        <a:t>C  close</a:t>
+                      </a:r>
+                    </a:p>
+                  </a:txBody>
+                  <a:tcPr marT="30000" marB="30000" marL="60000" marR="60000">
+                    <a:solidFill>
+                      <a:srgbClr val="FBFCFC"/>
+                    </a:solidFill>
+                  </a:tcPr>
+                </a:tc>
+                <a:tc>
+                  <a:txBody>
+                    <a:bodyPr wrap="square"/>
+                    <a:lstStyle/>
+                    <a:p>
+                      <a:r>
+                        <a:rPr sz="1100" b="0">
+                          <a:solidFill>
+                            <a:srgbClr val="16222B"/>
+                          </a:solidFill>
+                          <a:latin typeface="Calibri"/>
+                        </a:rPr>
+                        <a:t>.75 .75 .92 .97</a:t>
+                      </a:r>
+                    </a:p>
+                  </a:txBody>
+                  <a:tcPr marT="30000" marB="30000" marL="60000" marR="60000">
+                    <a:solidFill>
+                      <a:srgbClr val="FBFCFC"/>
+                    </a:solidFill>
+                  </a:tcPr>
+                </a:tc>
+                <a:tc>
+                  <a:txBody>
+                    <a:bodyPr wrap="square"/>
+                    <a:lstStyle/>
+                    <a:p>
+                      <a:r>
+                        <a:rPr sz="1100" b="0">
+                          <a:solidFill>
+                            <a:srgbClr val="1F5EA8"/>
+                          </a:solidFill>
+                          <a:latin typeface="Calibri"/>
+                        </a:rPr>
+                        <a:t>.5 .5 1 1  kept</a:t>
+                      </a:r>
+                    </a:p>
+                  </a:txBody>
+                  <a:tcPr marT="30000" marB="30000" marL="60000" marR="60000">
+                    <a:solidFill>
+                      <a:srgbClr val="FBFCFC"/>
+                    </a:solidFill>
+                  </a:tcPr>
+                </a:tc>
+                <a:tc>
+                  <a:txBody>
+                    <a:bodyPr wrap="square"/>
+                    <a:lstStyle/>
+                    <a:p>
+                      <a:r>
+                        <a:rPr sz="1100" b="0">
+                          <a:solidFill>
+                            <a:srgbClr val="B84A0B"/>
+                          </a:solidFill>
+                          <a:latin typeface="Calibri"/>
+                        </a:rPr>
+                        <a:t>1 1 1 1  dropped</a:t>
+                      </a:r>
+                    </a:p>
+                  </a:txBody>
+                  <a:tcPr marT="30000" marB="30000" marL="60000" marR="60000">
+                    <a:solidFill>
+                      <a:srgbClr val="FBFCFC"/>
+                    </a:solidFill>
+                  </a:tcPr>
+                </a:tc>
+                <a:tc>
+                  <a:txBody>
+                    <a:bodyPr wrap="square"/>
+                    <a:lstStyle/>
+                    <a:p>
+                      <a:r>
+                        <a:rPr sz="1100" b="0">
+                          <a:solidFill>
+                            <a:srgbClr val="16222B"/>
+                          </a:solidFill>
+                          <a:latin typeface="Calibri"/>
+                        </a:rPr>
+                        <a:t>kept</a:t>
+                      </a:r>
+                    </a:p>
+                  </a:txBody>
+                  <a:tcPr marT="30000" marB="30000" marL="60000" marR="60000">
+                    <a:solidFill>
+                      <a:srgbClr val="FBFCFC"/>
+                    </a:solidFill>
+                  </a:tcPr>
+                </a:tc>
+              </a:tr>
+              <a:tr h="300000">
+                <a:tc>
+                  <a:txBody>
+                    <a:bodyPr wrap="square"/>
+                    <a:lstStyle/>
+                    <a:p>
+                      <a:r>
+                        <a:rPr sz="1100" b="0">
+                          <a:solidFill>
+                            <a:srgbClr val="16222B"/>
+                          </a:solidFill>
+                          <a:latin typeface="Calibri"/>
+                        </a:rPr>
+                        <a:t>D  easy</a:t>
                       </a:r>
                     </a:p>
                   </a:txBody>

</xml_diff>

<commit_message>
RL deck slide 19: thresholds and measured effect of bands vs binary vs raw
Co-Authored-By: Claude Sonnet 5.5 <noreply@anthropic.com>
</commit_message>
<xml_diff>
--- a/docs/RL_V2_rl.pptx
+++ b/docs/RL_V2_rl.pptx
@@ -11335,7 +11335,7 @@
                 </a:solidFill>
                 <a:latin typeface="Calibri"/>
               </a:rPr>
-              <a:t>Source: dispositions.md, "The reward was a constant for 87% of rollouts" (2026-09-22)</a:t>
+              <a:t>Source: dispositions.md, "The reward was a constant for 87% of rollouts" (2026-09-22); prompt counts recounted from judged_pairs_rl_wm_r1to5.jsonl</a:t>
             </a:r>
           </a:p>
         </p:txBody>
@@ -11758,7 +11758,7 @@
                 </a:solidFill>
                 <a:latin typeface="Calibri"/>
               </a:rPr>
-              <a:t>Seven answers in eight paid the same reward, so most groups had no gradient. The raw score cut the waste by more than half; it did not produce lift (entry 12).</a:t>
+              <a:t>Seven in eight answers paid the same reward. Raw score judged 32 prompts to fill a step where bands judged 73 (same seed and base); no lift (entry 12).</a:t>
             </a:r>
           </a:p>
         </p:txBody>
@@ -11792,7 +11792,7 @@
                 </a:solidFill>
                 <a:latin typeface="Calibri"/>
               </a:rPr>
-              <a:t>Made-up scores. RL learns from reward minus group average; equal rewards give none. C is where bands and binary differ.</a:t>
+              <a:t>Made-up scores. A prompt is kept only if its answers fall on both sides of a cutoff: binary 0.70; bands 0.70 or 0.90; raw score any difference. C is the one bands rescue.</a:t>
             </a:r>
           </a:p>
         </p:txBody>
@@ -11805,7 +11805,7 @@
         </p:nvSpPr>
         <p:spPr>
           <a:xfrm>
-            <a:off x="5285232" y="4140000"/>
+            <a:off x="5285232" y="4110000"/>
             <a:ext cx="5900623" cy="600000"/>
           </a:xfrm>
           <a:prstGeom prst="rect">
@@ -11820,22 +11820,22 @@
           <a:lstStyle/>
           <a:p>
             <a:r>
-              <a:rPr b="1" sz="1300">
+              <a:rPr b="1" sz="1200">
                 <a:solidFill>
                   <a:srgbClr val="16222B"/>
                 </a:solidFill>
                 <a:latin typeface="Calibri"/>
               </a:rPr>
-              <a:t>Binary does not need fewer prompts. It needs more. </a:t>
-            </a:r>
-            <a:r>
-              <a:rPr sz="1300">
+              <a:t>Of 308 real prompts, binary kept 85, bands 88, raw score 249. </a:t>
+            </a:r>
+            <a:r>
+              <a:rPr sz="1200">
                 <a:solidFill>
                   <a:srgbClr val="16222B"/>
                 </a:solidFill>
                 <a:latin typeface="Calibri"/>
               </a:rPr>
-              <a:t>It scores C as 1 1 1 1 and drops it; bands keep it. Measured: bands 73 prompts judged to find 16, raw score 32 (same seed and base). Binary was not run.</a:t>
+              <a:t>Bands rescued 3 over binary: answers rarely reach 0.70, so the 0.90 cutoff seldom splits a group. Raw score kept 161 that bands dropped. (Recount of logged judge scores, not a new run.)</a:t>
             </a:r>
           </a:p>
         </p:txBody>
@@ -11848,7 +11848,7 @@
         </p:nvSpPr>
         <p:spPr>
           <a:xfrm>
-            <a:off x="5285232" y="4830000"/>
+            <a:off x="5285232" y="4700000"/>
             <a:ext cx="5900623" cy="560000"/>
           </a:xfrm>
           <a:prstGeom prst="rect">
@@ -11863,13 +11863,13 @@
           <a:lstStyle/>
           <a:p>
             <a:r>
-              <a:rPr sz="1400" i="0">
+              <a:rPr sz="1300" i="0">
                 <a:solidFill>
                   <a:srgbClr val="B84A0B"/>
                 </a:solidFill>
                 <a:latin typeface="Calibri"/>
               </a:rPr>
-              <a:t>86.9% of answers earned 0 under bands, so most prompts looked like A.</a:t>
+              <a:t>211 of 308 prompts were like A: every answer under 0.70.</a:t>
             </a:r>
           </a:p>
         </p:txBody>

</xml_diff>